<commit_message>
Auto-build: 2026-08-07 16:16 UTC
</commit_message>
<xml_diff>
--- a/reports/2026-07.pptx
+++ b/reports/2026-07.pptx
@@ -241,16 +241,16 @@
                     <c:v>Uganda</c:v>
                   </c:pt>
                   <c:pt idx="1">
+                    <c:v>Tanzania</c:v>
+                  </c:pt>
+                  <c:pt idx="2">
                     <c:v>Kenya</c:v>
                   </c:pt>
-                  <c:pt idx="2">
+                  <c:pt idx="3">
                     <c:v>Sierra Leone</c:v>
                   </c:pt>
-                  <c:pt idx="3">
+                  <c:pt idx="4">
                     <c:v>Nigeria</c:v>
-                  </c:pt>
-                  <c:pt idx="4">
-                    <c:v>Tanzania</c:v>
                   </c:pt>
                 </c:lvl>
               </c:multiLvlStrCache>
@@ -266,16 +266,16 @@
                   <c:v>76</c:v>
                 </c:pt>
                 <c:pt idx="1">
+                  <c:v>72</c:v>
+                </c:pt>
+                <c:pt idx="2">
                   <c:v>68</c:v>
                 </c:pt>
-                <c:pt idx="2">
+                <c:pt idx="3">
                   <c:v>47</c:v>
                 </c:pt>
-                <c:pt idx="3">
+                <c:pt idx="4">
                   <c:v>45</c:v>
-                </c:pt>
-                <c:pt idx="4">
-                  <c:v>0</c:v>
                 </c:pt>
               </c:numCache>
             </c:numRef>
@@ -538,19 +538,19 @@
                 <c:ptCount val="5"/>
                 <c:lvl>
                   <c:pt idx="0">
-                    <c:v>Tanzania</c:v>
+                    <c:v>Uganda</c:v>
                   </c:pt>
                   <c:pt idx="1">
-                    <c:v>Uganda</c:v>
+                    <c:v>Sierra Leone</c:v>
                   </c:pt>
                   <c:pt idx="2">
-                    <c:v>Sierra Leone</c:v>
+                    <c:v>Nigeria</c:v>
                   </c:pt>
                   <c:pt idx="3">
-                    <c:v>Nigeria</c:v>
+                    <c:v>Kenya</c:v>
                   </c:pt>
                   <c:pt idx="4">
-                    <c:v>Kenya</c:v>
+                    <c:v>Tanzania</c:v>
                   </c:pt>
                 </c:lvl>
               </c:multiLvlStrCache>
@@ -563,19 +563,19 @@
                 <c:formatCode>General</c:formatCode>
                 <c:ptCount val="5"/>
                 <c:pt idx="0">
-                  <c:v>0</c:v>
+                  <c:v>9</c:v>
                 </c:pt>
                 <c:pt idx="1">
-                  <c:v>9</c:v>
+                  <c:v>28</c:v>
                 </c:pt>
                 <c:pt idx="2">
                   <c:v>28</c:v>
                 </c:pt>
                 <c:pt idx="3">
-                  <c:v>28</c:v>
+                  <c:v>38</c:v>
                 </c:pt>
                 <c:pt idx="4">
-                  <c:v>38</c:v>
+                  <c:v>120</c:v>
                 </c:pt>
               </c:numCache>
             </c:numRef>
@@ -1138,16 +1138,16 @@
                 <c:ptCount val="5"/>
                 <c:lvl>
                   <c:pt idx="0">
+                    <c:v>Tanzania</c:v>
+                  </c:pt>
+                  <c:pt idx="1">
                     <c:v>Sierra Leone</c:v>
                   </c:pt>
-                  <c:pt idx="1">
+                  <c:pt idx="2">
                     <c:v>Uganda</c:v>
                   </c:pt>
-                  <c:pt idx="2">
+                  <c:pt idx="3">
                     <c:v>Nigeria</c:v>
-                  </c:pt>
-                  <c:pt idx="3">
-                    <c:v>Tanzania</c:v>
                   </c:pt>
                   <c:pt idx="4">
                     <c:v>Kenya</c:v>
@@ -1163,16 +1163,16 @@
                 <c:formatCode>General</c:formatCode>
                 <c:ptCount val="5"/>
                 <c:pt idx="0">
+                  <c:v>2191848.288</c:v>
+                </c:pt>
+                <c:pt idx="1">
                   <c:v>647524.7959</c:v>
                 </c:pt>
-                <c:pt idx="1">
+                <c:pt idx="2">
                   <c:v>576396.6555</c:v>
                 </c:pt>
-                <c:pt idx="2">
+                <c:pt idx="3">
                   <c:v>157919.708</c:v>
-                </c:pt>
-                <c:pt idx="3">
-                  <c:v>0</c:v>
                 </c:pt>
                 <c:pt idx="4">
                   <c:v>0</c:v>
@@ -1438,16 +1438,16 @@
                 <c:ptCount val="5"/>
                 <c:lvl>
                   <c:pt idx="0">
+                    <c:v>Tanzania</c:v>
+                  </c:pt>
+                  <c:pt idx="1">
                     <c:v>Sierra Leone</c:v>
                   </c:pt>
-                  <c:pt idx="1">
+                  <c:pt idx="2">
                     <c:v>Uganda</c:v>
                   </c:pt>
-                  <c:pt idx="2">
+                  <c:pt idx="3">
                     <c:v>Nigeria</c:v>
-                  </c:pt>
-                  <c:pt idx="3">
-                    <c:v>Tanzania</c:v>
                   </c:pt>
                   <c:pt idx="4">
                     <c:v>Kenya</c:v>
@@ -1463,16 +1463,16 @@
                 <c:formatCode>General</c:formatCode>
                 <c:ptCount val="5"/>
                 <c:pt idx="0">
+                  <c:v>225.290193</c:v>
+                </c:pt>
+                <c:pt idx="1">
                   <c:v>490.549088</c:v>
                 </c:pt>
-                <c:pt idx="1">
+                <c:pt idx="2">
                   <c:v>222.97743</c:v>
                 </c:pt>
-                <c:pt idx="2">
+                <c:pt idx="3">
                   <c:v>186.006723</c:v>
-                </c:pt>
-                <c:pt idx="3">
-                  <c:v>0</c:v>
                 </c:pt>
                 <c:pt idx="4">
                   <c:v>0</c:v>
@@ -1738,16 +1738,16 @@
                 <c:ptCount val="5"/>
                 <c:lvl>
                   <c:pt idx="0">
+                    <c:v>Tanzania</c:v>
+                  </c:pt>
+                  <c:pt idx="1">
                     <c:v>Sierra Leone</c:v>
                   </c:pt>
-                  <c:pt idx="1">
+                  <c:pt idx="2">
                     <c:v>Uganda</c:v>
                   </c:pt>
-                  <c:pt idx="2">
+                  <c:pt idx="3">
                     <c:v>Nigeria</c:v>
-                  </c:pt>
-                  <c:pt idx="3">
-                    <c:v>Tanzania</c:v>
                   </c:pt>
                   <c:pt idx="4">
                     <c:v>Kenya</c:v>
@@ -1763,16 +1763,16 @@
                 <c:formatCode>General</c:formatCode>
                 <c:ptCount val="5"/>
                 <c:pt idx="0">
+                  <c:v>152</c:v>
+                </c:pt>
+                <c:pt idx="1">
                   <c:v>26</c:v>
                 </c:pt>
-                <c:pt idx="1">
+                <c:pt idx="2">
                   <c:v>63</c:v>
                 </c:pt>
-                <c:pt idx="2">
+                <c:pt idx="3">
                   <c:v>42</c:v>
-                </c:pt>
-                <c:pt idx="3">
-                  <c:v>0</c:v>
                 </c:pt>
                 <c:pt idx="4">
                   <c:v>0</c:v>
@@ -2038,16 +2038,16 @@
                 <c:ptCount val="5"/>
                 <c:lvl>
                   <c:pt idx="0">
+                    <c:v>Tanzania</c:v>
+                  </c:pt>
+                  <c:pt idx="1">
                     <c:v>Uganda</c:v>
                   </c:pt>
-                  <c:pt idx="1">
+                  <c:pt idx="2">
                     <c:v>Nigeria</c:v>
                   </c:pt>
-                  <c:pt idx="2">
+                  <c:pt idx="3">
                     <c:v>Sierra Leone</c:v>
-                  </c:pt>
-                  <c:pt idx="3">
-                    <c:v>Tanzania</c:v>
                   </c:pt>
                   <c:pt idx="4">
                     <c:v>Kenya</c:v>
@@ -2066,13 +2066,13 @@
                   <c:v>3</c:v>
                 </c:pt>
                 <c:pt idx="1">
+                  <c:v>3</c:v>
+                </c:pt>
+                <c:pt idx="2">
                   <c:v>4</c:v>
                 </c:pt>
-                <c:pt idx="2">
+                <c:pt idx="3">
                   <c:v>5</c:v>
-                </c:pt>
-                <c:pt idx="3">
-                  <c:v>0</c:v>
                 </c:pt>
                 <c:pt idx="4">
                   <c:v>0</c:v>
@@ -2338,19 +2338,19 @@
                 <c:ptCount val="5"/>
                 <c:lvl>
                   <c:pt idx="0">
+                    <c:v>Tanzania</c:v>
+                  </c:pt>
+                  <c:pt idx="1">
                     <c:v>Kenya</c:v>
                   </c:pt>
-                  <c:pt idx="1">
+                  <c:pt idx="2">
                     <c:v>Uganda</c:v>
                   </c:pt>
-                  <c:pt idx="2">
+                  <c:pt idx="3">
                     <c:v>Sierra Leone</c:v>
                   </c:pt>
-                  <c:pt idx="3">
+                  <c:pt idx="4">
                     <c:v>Nigeria</c:v>
-                  </c:pt>
-                  <c:pt idx="4">
-                    <c:v>Tanzania</c:v>
                   </c:pt>
                 </c:lvl>
               </c:multiLvlStrCache>
@@ -2363,19 +2363,19 @@
                 <c:formatCode>General</c:formatCode>
                 <c:ptCount val="5"/>
                 <c:pt idx="0">
+                  <c:v>5023684.416</c:v>
+                </c:pt>
+                <c:pt idx="1">
                   <c:v>4041137.379</c:v>
                 </c:pt>
-                <c:pt idx="1">
+                <c:pt idx="2">
                   <c:v>1412239.874</c:v>
                 </c:pt>
-                <c:pt idx="2">
+                <c:pt idx="3">
                   <c:v>1302464.715</c:v>
                 </c:pt>
-                <c:pt idx="3">
+                <c:pt idx="4">
                   <c:v>359022.5146</c:v>
-                </c:pt>
-                <c:pt idx="4">
-                  <c:v>0</c:v>
                 </c:pt>
               </c:numCache>
             </c:numRef>
@@ -2638,19 +2638,19 @@
                 <c:ptCount val="5"/>
                 <c:lvl>
                   <c:pt idx="0">
-                    <c:v>Tanzania</c:v>
+                    <c:v>Nigeria</c:v>
                   </c:pt>
                   <c:pt idx="1">
-                    <c:v>Nigeria</c:v>
+                    <c:v>Sierra Leone</c:v>
                   </c:pt>
                   <c:pt idx="2">
-                    <c:v>Sierra Leone</c:v>
+                    <c:v>Uganda</c:v>
                   </c:pt>
                   <c:pt idx="3">
-                    <c:v>Uganda</c:v>
+                    <c:v>Kenya</c:v>
                   </c:pt>
                   <c:pt idx="4">
-                    <c:v>Kenya</c:v>
+                    <c:v>Tanzania</c:v>
                   </c:pt>
                 </c:lvl>
               </c:multiLvlStrCache>
@@ -2663,19 +2663,19 @@
                 <c:formatCode>General</c:formatCode>
                 <c:ptCount val="5"/>
                 <c:pt idx="0">
-                  <c:v>0</c:v>
+                  <c:v>701</c:v>
                 </c:pt>
                 <c:pt idx="1">
-                  <c:v>701</c:v>
+                  <c:v>838</c:v>
                 </c:pt>
                 <c:pt idx="2">
-                  <c:v>838</c:v>
+                  <c:v>1176</c:v>
                 </c:pt>
                 <c:pt idx="3">
-                  <c:v>1176</c:v>
+                  <c:v>1359</c:v>
                 </c:pt>
                 <c:pt idx="4">
-                  <c:v>1359</c:v>
+                  <c:v>1511</c:v>
                 </c:pt>
               </c:numCache>
             </c:numRef>
@@ -2938,19 +2938,19 @@
                 <c:ptCount val="5"/>
                 <c:lvl>
                   <c:pt idx="0">
-                    <c:v>Tanzania</c:v>
+                    <c:v>Uganda</c:v>
                   </c:pt>
                   <c:pt idx="1">
-                    <c:v>Uganda</c:v>
+                    <c:v>Nigeria</c:v>
                   </c:pt>
                   <c:pt idx="2">
-                    <c:v>Nigeria</c:v>
+                    <c:v>Sierra Leone</c:v>
                   </c:pt>
                   <c:pt idx="3">
-                    <c:v>Sierra Leone</c:v>
+                    <c:v>Kenya</c:v>
                   </c:pt>
                   <c:pt idx="4">
-                    <c:v>Kenya</c:v>
+                    <c:v>Tanzania</c:v>
                   </c:pt>
                 </c:lvl>
               </c:multiLvlStrCache>
@@ -2963,19 +2963,19 @@
                 <c:formatCode>General</c:formatCode>
                 <c:ptCount val="5"/>
                 <c:pt idx="0">
-                  <c:v>0</c:v>
+                  <c:v>126</c:v>
                 </c:pt>
                 <c:pt idx="1">
-                  <c:v>126</c:v>
+                  <c:v>151</c:v>
                 </c:pt>
                 <c:pt idx="2">
-                  <c:v>151</c:v>
+                  <c:v>168</c:v>
                 </c:pt>
                 <c:pt idx="3">
-                  <c:v>168</c:v>
+                  <c:v>214</c:v>
                 </c:pt>
                 <c:pt idx="4">
-                  <c:v>214</c:v>
+                  <c:v>348</c:v>
                 </c:pt>
               </c:numCache>
             </c:numRef>
@@ -6592,6 +6592,484 @@
                           <a:ea typeface="Century Gothic" pitchFamily="34" charset="-122"/>
                           <a:cs typeface="Century Gothic" pitchFamily="34" charset="-120"/>
                         </a:rPr>
+                        <a:t>Tanzania</a:t>
+                      </a:r>
+                      <a:endParaRPr lang="en-US" sz="1200" dirty="0">
+                        <a:latin typeface="Century Gothic" charset="0"/>
+                        <a:ea typeface="Century Gothic" charset="0"/>
+                        <a:cs typeface="Century Gothic" charset="0"/>
+                      </a:endParaRPr>
+                    </a:p>
+                  </a:txBody>
+                  <a:tcPr marL="91440" marR="91440" marT="45720" marB="45720" anchor="ctr">
+                    <a:lnL w="6350" cap="flat" cmpd="sng" algn="ctr">
+                      <a:solidFill>
+                        <a:srgbClr val="D6CFC4"/>
+                      </a:solidFill>
+                      <a:prstDash val="solid"/>
+                      <a:round/>
+                      <a:headEnd type="none" w="med" len="med"/>
+                      <a:tailEnd type="none" w="med" len="med"/>
+                    </a:lnL>
+                    <a:lnR w="6350" cap="flat" cmpd="sng" algn="ctr">
+                      <a:solidFill>
+                        <a:srgbClr val="D6CFC4"/>
+                      </a:solidFill>
+                      <a:prstDash val="solid"/>
+                      <a:round/>
+                      <a:headEnd type="none" w="med" len="med"/>
+                      <a:tailEnd type="none" w="med" len="med"/>
+                    </a:lnR>
+                    <a:lnT w="6350" cap="flat" cmpd="sng" algn="ctr">
+                      <a:solidFill>
+                        <a:srgbClr val="D6CFC4"/>
+                      </a:solidFill>
+                      <a:prstDash val="solid"/>
+                      <a:round/>
+                      <a:headEnd type="none" w="med" len="med"/>
+                      <a:tailEnd type="none" w="med" len="med"/>
+                    </a:lnT>
+                    <a:lnB w="6350" cap="flat" cmpd="sng" algn="ctr">
+                      <a:solidFill>
+                        <a:srgbClr val="D6CFC4"/>
+                      </a:solidFill>
+                      <a:prstDash val="solid"/>
+                      <a:round/>
+                      <a:headEnd type="none" w="med" len="med"/>
+                      <a:tailEnd type="none" w="med" len="med"/>
+                    </a:lnB>
+                    <a:solidFill>
+                      <a:srgbClr val="FAF7F2"/>
+                    </a:solidFill>
+                  </a:tcPr>
+                </a:tc>
+                <a:tc>
+                  <a:txBody>
+                    <a:bodyPr/>
+                    <a:lstStyle/>
+                    <a:p>
+                      <a:pPr algn="ctr" indent="0" marL="0">
+                        <a:buNone/>
+                      </a:pPr>
+                      <a:r>
+                        <a:rPr lang="en-US" sz="1200" dirty="0">
+                          <a:solidFill>
+                            <a:srgbClr val="2D2A26"/>
+                          </a:solidFill>
+                          <a:latin typeface="Calibri" pitchFamily="34" charset="0"/>
+                          <a:ea typeface="Calibri" pitchFamily="34" charset="-122"/>
+                          <a:cs typeface="Calibri" pitchFamily="34" charset="-120"/>
+                        </a:rPr>
+                        <a:t>$907,231</a:t>
+                      </a:r>
+                      <a:endParaRPr lang="en-US" sz="1200" dirty="0">
+                        <a:latin typeface="Calibri" charset="0"/>
+                        <a:ea typeface="Calibri" charset="0"/>
+                        <a:cs typeface="Calibri" charset="0"/>
+                      </a:endParaRPr>
+                    </a:p>
+                  </a:txBody>
+                  <a:tcPr marL="91440" marR="91440" marT="45720" marB="45720" anchor="ctr">
+                    <a:lnL w="6350" cap="flat" cmpd="sng" algn="ctr">
+                      <a:solidFill>
+                        <a:srgbClr val="D6CFC4"/>
+                      </a:solidFill>
+                      <a:prstDash val="solid"/>
+                      <a:round/>
+                      <a:headEnd type="none" w="med" len="med"/>
+                      <a:tailEnd type="none" w="med" len="med"/>
+                    </a:lnL>
+                    <a:lnR w="6350" cap="flat" cmpd="sng" algn="ctr">
+                      <a:solidFill>
+                        <a:srgbClr val="D6CFC4"/>
+                      </a:solidFill>
+                      <a:prstDash val="solid"/>
+                      <a:round/>
+                      <a:headEnd type="none" w="med" len="med"/>
+                      <a:tailEnd type="none" w="med" len="med"/>
+                    </a:lnR>
+                    <a:lnT w="6350" cap="flat" cmpd="sng" algn="ctr">
+                      <a:solidFill>
+                        <a:srgbClr val="D6CFC4"/>
+                      </a:solidFill>
+                      <a:prstDash val="solid"/>
+                      <a:round/>
+                      <a:headEnd type="none" w="med" len="med"/>
+                      <a:tailEnd type="none" w="med" len="med"/>
+                    </a:lnT>
+                    <a:lnB w="6350" cap="flat" cmpd="sng" algn="ctr">
+                      <a:solidFill>
+                        <a:srgbClr val="D6CFC4"/>
+                      </a:solidFill>
+                      <a:prstDash val="solid"/>
+                      <a:round/>
+                      <a:headEnd type="none" w="med" len="med"/>
+                      <a:tailEnd type="none" w="med" len="med"/>
+                    </a:lnB>
+                    <a:solidFill>
+                      <a:srgbClr val="FAF7F2"/>
+                    </a:solidFill>
+                  </a:tcPr>
+                </a:tc>
+                <a:tc>
+                  <a:txBody>
+                    <a:bodyPr/>
+                    <a:lstStyle/>
+                    <a:p>
+                      <a:pPr algn="ctr" indent="0" marL="0">
+                        <a:buNone/>
+                      </a:pPr>
+                      <a:r>
+                        <a:rPr lang="en-US" sz="1200" dirty="0">
+                          <a:solidFill>
+                            <a:srgbClr val="2D2A26"/>
+                          </a:solidFill>
+                          <a:latin typeface="Calibri" pitchFamily="34" charset="0"/>
+                          <a:ea typeface="Calibri" pitchFamily="34" charset="-122"/>
+                          <a:cs typeface="Calibri" pitchFamily="34" charset="-120"/>
+                        </a:rPr>
+                        <a:t>$-214,692</a:t>
+                      </a:r>
+                      <a:endParaRPr lang="en-US" sz="1200" dirty="0">
+                        <a:latin typeface="Calibri" charset="0"/>
+                        <a:ea typeface="Calibri" charset="0"/>
+                        <a:cs typeface="Calibri" charset="0"/>
+                      </a:endParaRPr>
+                    </a:p>
+                  </a:txBody>
+                  <a:tcPr marL="91440" marR="91440" marT="45720" marB="45720" anchor="ctr">
+                    <a:lnL w="6350" cap="flat" cmpd="sng" algn="ctr">
+                      <a:solidFill>
+                        <a:srgbClr val="D6CFC4"/>
+                      </a:solidFill>
+                      <a:prstDash val="solid"/>
+                      <a:round/>
+                      <a:headEnd type="none" w="med" len="med"/>
+                      <a:tailEnd type="none" w="med" len="med"/>
+                    </a:lnL>
+                    <a:lnR w="6350" cap="flat" cmpd="sng" algn="ctr">
+                      <a:solidFill>
+                        <a:srgbClr val="D6CFC4"/>
+                      </a:solidFill>
+                      <a:prstDash val="solid"/>
+                      <a:round/>
+                      <a:headEnd type="none" w="med" len="med"/>
+                      <a:tailEnd type="none" w="med" len="med"/>
+                    </a:lnR>
+                    <a:lnT w="6350" cap="flat" cmpd="sng" algn="ctr">
+                      <a:solidFill>
+                        <a:srgbClr val="D6CFC4"/>
+                      </a:solidFill>
+                      <a:prstDash val="solid"/>
+                      <a:round/>
+                      <a:headEnd type="none" w="med" len="med"/>
+                      <a:tailEnd type="none" w="med" len="med"/>
+                    </a:lnT>
+                    <a:lnB w="6350" cap="flat" cmpd="sng" algn="ctr">
+                      <a:solidFill>
+                        <a:srgbClr val="D6CFC4"/>
+                      </a:solidFill>
+                      <a:prstDash val="solid"/>
+                      <a:round/>
+                      <a:headEnd type="none" w="med" len="med"/>
+                      <a:tailEnd type="none" w="med" len="med"/>
+                    </a:lnB>
+                    <a:solidFill>
+                      <a:srgbClr val="FAF7F2"/>
+                    </a:solidFill>
+                  </a:tcPr>
+                </a:tc>
+                <a:tc>
+                  <a:txBody>
+                    <a:bodyPr/>
+                    <a:lstStyle/>
+                    <a:p>
+                      <a:pPr algn="ctr" indent="0" marL="0">
+                        <a:buNone/>
+                      </a:pPr>
+                      <a:r>
+                        <a:rPr lang="en-US" sz="1200" dirty="0">
+                          <a:solidFill>
+                            <a:srgbClr val="2D2A26"/>
+                          </a:solidFill>
+                          <a:latin typeface="Calibri" pitchFamily="34" charset="0"/>
+                          <a:ea typeface="Calibri" pitchFamily="34" charset="-122"/>
+                          <a:cs typeface="Calibri" pitchFamily="34" charset="-120"/>
+                        </a:rPr>
+                        <a:t>$-594,579</a:t>
+                      </a:r>
+                      <a:endParaRPr lang="en-US" sz="1200" dirty="0">
+                        <a:latin typeface="Calibri" charset="0"/>
+                        <a:ea typeface="Calibri" charset="0"/>
+                        <a:cs typeface="Calibri" charset="0"/>
+                      </a:endParaRPr>
+                    </a:p>
+                  </a:txBody>
+                  <a:tcPr marL="91440" marR="91440" marT="45720" marB="45720" anchor="ctr">
+                    <a:lnL w="6350" cap="flat" cmpd="sng" algn="ctr">
+                      <a:solidFill>
+                        <a:srgbClr val="D6CFC4"/>
+                      </a:solidFill>
+                      <a:prstDash val="solid"/>
+                      <a:round/>
+                      <a:headEnd type="none" w="med" len="med"/>
+                      <a:tailEnd type="none" w="med" len="med"/>
+                    </a:lnL>
+                    <a:lnR w="6350" cap="flat" cmpd="sng" algn="ctr">
+                      <a:solidFill>
+                        <a:srgbClr val="D6CFC4"/>
+                      </a:solidFill>
+                      <a:prstDash val="solid"/>
+                      <a:round/>
+                      <a:headEnd type="none" w="med" len="med"/>
+                      <a:tailEnd type="none" w="med" len="med"/>
+                    </a:lnR>
+                    <a:lnT w="6350" cap="flat" cmpd="sng" algn="ctr">
+                      <a:solidFill>
+                        <a:srgbClr val="D6CFC4"/>
+                      </a:solidFill>
+                      <a:prstDash val="solid"/>
+                      <a:round/>
+                      <a:headEnd type="none" w="med" len="med"/>
+                      <a:tailEnd type="none" w="med" len="med"/>
+                    </a:lnT>
+                    <a:lnB w="6350" cap="flat" cmpd="sng" algn="ctr">
+                      <a:solidFill>
+                        <a:srgbClr val="D6CFC4"/>
+                      </a:solidFill>
+                      <a:prstDash val="solid"/>
+                      <a:round/>
+                      <a:headEnd type="none" w="med" len="med"/>
+                      <a:tailEnd type="none" w="med" len="med"/>
+                    </a:lnB>
+                    <a:solidFill>
+                      <a:srgbClr val="FAF7F2"/>
+                    </a:solidFill>
+                  </a:tcPr>
+                </a:tc>
+                <a:tc>
+                  <a:txBody>
+                    <a:bodyPr/>
+                    <a:lstStyle/>
+                    <a:p>
+                      <a:pPr algn="ctr" indent="0" marL="0">
+                        <a:buNone/>
+                      </a:pPr>
+                      <a:r>
+                        <a:rPr lang="en-US" sz="1200" dirty="0">
+                          <a:solidFill>
+                            <a:srgbClr val="2D2A26"/>
+                          </a:solidFill>
+                          <a:latin typeface="Calibri" pitchFamily="34" charset="0"/>
+                          <a:ea typeface="Calibri" pitchFamily="34" charset="-122"/>
+                          <a:cs typeface="Calibri" pitchFamily="34" charset="-120"/>
+                        </a:rPr>
+                        <a:t>$97,960</a:t>
+                      </a:r>
+                      <a:endParaRPr lang="en-US" sz="1200" dirty="0">
+                        <a:latin typeface="Calibri" charset="0"/>
+                        <a:ea typeface="Calibri" charset="0"/>
+                        <a:cs typeface="Calibri" charset="0"/>
+                      </a:endParaRPr>
+                    </a:p>
+                  </a:txBody>
+                  <a:tcPr marL="91440" marR="91440" marT="45720" marB="45720" anchor="ctr">
+                    <a:lnL w="6350" cap="flat" cmpd="sng" algn="ctr">
+                      <a:solidFill>
+                        <a:srgbClr val="D6CFC4"/>
+                      </a:solidFill>
+                      <a:prstDash val="solid"/>
+                      <a:round/>
+                      <a:headEnd type="none" w="med" len="med"/>
+                      <a:tailEnd type="none" w="med" len="med"/>
+                    </a:lnL>
+                    <a:lnR w="6350" cap="flat" cmpd="sng" algn="ctr">
+                      <a:solidFill>
+                        <a:srgbClr val="D6CFC4"/>
+                      </a:solidFill>
+                      <a:prstDash val="solid"/>
+                      <a:round/>
+                      <a:headEnd type="none" w="med" len="med"/>
+                      <a:tailEnd type="none" w="med" len="med"/>
+                    </a:lnR>
+                    <a:lnT w="6350" cap="flat" cmpd="sng" algn="ctr">
+                      <a:solidFill>
+                        <a:srgbClr val="D6CFC4"/>
+                      </a:solidFill>
+                      <a:prstDash val="solid"/>
+                      <a:round/>
+                      <a:headEnd type="none" w="med" len="med"/>
+                      <a:tailEnd type="none" w="med" len="med"/>
+                    </a:lnT>
+                    <a:lnB w="6350" cap="flat" cmpd="sng" algn="ctr">
+                      <a:solidFill>
+                        <a:srgbClr val="D6CFC4"/>
+                      </a:solidFill>
+                      <a:prstDash val="solid"/>
+                      <a:round/>
+                      <a:headEnd type="none" w="med" len="med"/>
+                      <a:tailEnd type="none" w="med" len="med"/>
+                    </a:lnB>
+                    <a:solidFill>
+                      <a:srgbClr val="FAF7F2"/>
+                    </a:solidFill>
+                  </a:tcPr>
+                </a:tc>
+                <a:tc>
+                  <a:txBody>
+                    <a:bodyPr/>
+                    <a:lstStyle/>
+                    <a:p>
+                      <a:pPr algn="ctr" indent="0" marL="0">
+                        <a:buNone/>
+                      </a:pPr>
+                      <a:r>
+                        <a:rPr lang="en-US" sz="1200" dirty="0">
+                          <a:solidFill>
+                            <a:srgbClr val="2D2A26"/>
+                          </a:solidFill>
+                          <a:latin typeface="Calibri" pitchFamily="34" charset="0"/>
+                          <a:ea typeface="Calibri" pitchFamily="34" charset="-122"/>
+                          <a:cs typeface="Calibri" pitchFamily="34" charset="-120"/>
+                        </a:rPr>
+                        <a:t>10.8%</a:t>
+                      </a:r>
+                      <a:endParaRPr lang="en-US" sz="1200" dirty="0">
+                        <a:latin typeface="Calibri" charset="0"/>
+                        <a:ea typeface="Calibri" charset="0"/>
+                        <a:cs typeface="Calibri" charset="0"/>
+                      </a:endParaRPr>
+                    </a:p>
+                  </a:txBody>
+                  <a:tcPr marL="91440" marR="91440" marT="45720" marB="45720" anchor="ctr">
+                    <a:lnL w="6350" cap="flat" cmpd="sng" algn="ctr">
+                      <a:solidFill>
+                        <a:srgbClr val="D6CFC4"/>
+                      </a:solidFill>
+                      <a:prstDash val="solid"/>
+                      <a:round/>
+                      <a:headEnd type="none" w="med" len="med"/>
+                      <a:tailEnd type="none" w="med" len="med"/>
+                    </a:lnL>
+                    <a:lnR w="6350" cap="flat" cmpd="sng" algn="ctr">
+                      <a:solidFill>
+                        <a:srgbClr val="D6CFC4"/>
+                      </a:solidFill>
+                      <a:prstDash val="solid"/>
+                      <a:round/>
+                      <a:headEnd type="none" w="med" len="med"/>
+                      <a:tailEnd type="none" w="med" len="med"/>
+                    </a:lnR>
+                    <a:lnT w="6350" cap="flat" cmpd="sng" algn="ctr">
+                      <a:solidFill>
+                        <a:srgbClr val="D6CFC4"/>
+                      </a:solidFill>
+                      <a:prstDash val="solid"/>
+                      <a:round/>
+                      <a:headEnd type="none" w="med" len="med"/>
+                      <a:tailEnd type="none" w="med" len="med"/>
+                    </a:lnT>
+                    <a:lnB w="6350" cap="flat" cmpd="sng" algn="ctr">
+                      <a:solidFill>
+                        <a:srgbClr val="D6CFC4"/>
+                      </a:solidFill>
+                      <a:prstDash val="solid"/>
+                      <a:round/>
+                      <a:headEnd type="none" w="med" len="med"/>
+                      <a:tailEnd type="none" w="med" len="med"/>
+                    </a:lnB>
+                    <a:solidFill>
+                      <a:srgbClr val="FAF7F2"/>
+                    </a:solidFill>
+                  </a:tcPr>
+                </a:tc>
+                <a:tc>
+                  <a:txBody>
+                    <a:bodyPr/>
+                    <a:lstStyle/>
+                    <a:p>
+                      <a:pPr algn="ctr" indent="0" marL="0">
+                        <a:buNone/>
+                      </a:pPr>
+                      <a:r>
+                        <a:rPr lang="en-US" sz="1200" dirty="0">
+                          <a:solidFill>
+                            <a:srgbClr val="2D2A26"/>
+                          </a:solidFill>
+                          <a:latin typeface="Calibri" pitchFamily="34" charset="0"/>
+                          <a:ea typeface="Calibri" pitchFamily="34" charset="-122"/>
+                          <a:cs typeface="Calibri" pitchFamily="34" charset="-120"/>
+                        </a:rPr>
+                        <a:t>$106,893</a:t>
+                      </a:r>
+                      <a:endParaRPr lang="en-US" sz="1200" dirty="0">
+                        <a:latin typeface="Calibri" charset="0"/>
+                        <a:ea typeface="Calibri" charset="0"/>
+                        <a:cs typeface="Calibri" charset="0"/>
+                      </a:endParaRPr>
+                    </a:p>
+                  </a:txBody>
+                  <a:tcPr marL="91440" marR="91440" marT="45720" marB="45720" anchor="ctr">
+                    <a:lnL w="6350" cap="flat" cmpd="sng" algn="ctr">
+                      <a:solidFill>
+                        <a:srgbClr val="D6CFC4"/>
+                      </a:solidFill>
+                      <a:prstDash val="solid"/>
+                      <a:round/>
+                      <a:headEnd type="none" w="med" len="med"/>
+                      <a:tailEnd type="none" w="med" len="med"/>
+                    </a:lnL>
+                    <a:lnR w="6350" cap="flat" cmpd="sng" algn="ctr">
+                      <a:solidFill>
+                        <a:srgbClr val="D6CFC4"/>
+                      </a:solidFill>
+                      <a:prstDash val="solid"/>
+                      <a:round/>
+                      <a:headEnd type="none" w="med" len="med"/>
+                      <a:tailEnd type="none" w="med" len="med"/>
+                    </a:lnR>
+                    <a:lnT w="6350" cap="flat" cmpd="sng" algn="ctr">
+                      <a:solidFill>
+                        <a:srgbClr val="D6CFC4"/>
+                      </a:solidFill>
+                      <a:prstDash val="solid"/>
+                      <a:round/>
+                      <a:headEnd type="none" w="med" len="med"/>
+                      <a:tailEnd type="none" w="med" len="med"/>
+                    </a:lnT>
+                    <a:lnB w="6350" cap="flat" cmpd="sng" algn="ctr">
+                      <a:solidFill>
+                        <a:srgbClr val="D6CFC4"/>
+                      </a:solidFill>
+                      <a:prstDash val="solid"/>
+                      <a:round/>
+                      <a:headEnd type="none" w="med" len="med"/>
+                      <a:tailEnd type="none" w="med" len="med"/>
+                    </a:lnB>
+                    <a:solidFill>
+                      <a:srgbClr val="FAF7F2"/>
+                    </a:solidFill>
+                  </a:tcPr>
+                </a:tc>
+              </a:tr>
+              <a:tr h="457200">
+                <a:tc>
+                  <a:txBody>
+                    <a:bodyPr/>
+                    <a:lstStyle/>
+                    <a:p>
+                      <a:pPr algn="l" indent="0" marL="0">
+                        <a:buNone/>
+                      </a:pPr>
+                      <a:r>
+                        <a:rPr lang="en-US" sz="1200" b="1" dirty="0">
+                          <a:solidFill>
+                            <a:srgbClr val="2D2A26"/>
+                          </a:solidFill>
+                          <a:latin typeface="Century Gothic" pitchFamily="34" charset="0"/>
+                          <a:ea typeface="Century Gothic" pitchFamily="34" charset="-122"/>
+                          <a:cs typeface="Century Gothic" pitchFamily="34" charset="-120"/>
+                        </a:rPr>
                         <a:t>Sierra Leone</a:t>
                       </a:r>
                       <a:endParaRPr lang="en-US" sz="1200" dirty="0">
@@ -6639,7 +7117,7 @@
                       <a:tailEnd type="none" w="med" len="med"/>
                     </a:lnB>
                     <a:solidFill>
-                      <a:srgbClr val="FAF7F2"/>
+                      <a:srgbClr val="FFFFFF"/>
                     </a:solidFill>
                   </a:tcPr>
                 </a:tc>
@@ -6707,7 +7185,7 @@
                       <a:tailEnd type="none" w="med" len="med"/>
                     </a:lnB>
                     <a:solidFill>
-                      <a:srgbClr val="FAF7F2"/>
+                      <a:srgbClr val="FFFFFF"/>
                     </a:solidFill>
                   </a:tcPr>
                 </a:tc>
@@ -6775,7 +7253,7 @@
                       <a:tailEnd type="none" w="med" len="med"/>
                     </a:lnB>
                     <a:solidFill>
-                      <a:srgbClr val="FAF7F2"/>
+                      <a:srgbClr val="FFFFFF"/>
                     </a:solidFill>
                   </a:tcPr>
                 </a:tc>
@@ -6843,7 +7321,7 @@
                       <a:tailEnd type="none" w="med" len="med"/>
                     </a:lnB>
                     <a:solidFill>
-                      <a:srgbClr val="FAF7F2"/>
+                      <a:srgbClr val="FFFFFF"/>
                     </a:solidFill>
                   </a:tcPr>
                 </a:tc>
@@ -6911,7 +7389,7 @@
                       <a:tailEnd type="none" w="med" len="med"/>
                     </a:lnB>
                     <a:solidFill>
-                      <a:srgbClr val="FAF7F2"/>
+                      <a:srgbClr val="FFFFFF"/>
                     </a:solidFill>
                   </a:tcPr>
                 </a:tc>
@@ -6979,7 +7457,7 @@
                       <a:tailEnd type="none" w="med" len="med"/>
                     </a:lnB>
                     <a:solidFill>
-                      <a:srgbClr val="FAF7F2"/>
+                      <a:srgbClr val="FFFFFF"/>
                     </a:solidFill>
                   </a:tcPr>
                 </a:tc>
@@ -7047,7 +7525,7 @@
                       <a:tailEnd type="none" w="med" len="med"/>
                     </a:lnB>
                     <a:solidFill>
-                      <a:srgbClr val="FAF7F2"/>
+                      <a:srgbClr val="FFFFFF"/>
                     </a:solidFill>
                   </a:tcPr>
                 </a:tc>
@@ -7117,7 +7595,7 @@
                       <a:tailEnd type="none" w="med" len="med"/>
                     </a:lnB>
                     <a:solidFill>
-                      <a:srgbClr val="FFFFFF"/>
+                      <a:srgbClr val="FAF7F2"/>
                     </a:solidFill>
                   </a:tcPr>
                 </a:tc>
@@ -7185,7 +7663,7 @@
                       <a:tailEnd type="none" w="med" len="med"/>
                     </a:lnB>
                     <a:solidFill>
-                      <a:srgbClr val="FFFFFF"/>
+                      <a:srgbClr val="FAF7F2"/>
                     </a:solidFill>
                   </a:tcPr>
                 </a:tc>
@@ -7253,7 +7731,7 @@
                       <a:tailEnd type="none" w="med" len="med"/>
                     </a:lnB>
                     <a:solidFill>
-                      <a:srgbClr val="FFFFFF"/>
+                      <a:srgbClr val="FAF7F2"/>
                     </a:solidFill>
                   </a:tcPr>
                 </a:tc>
@@ -7321,7 +7799,7 @@
                       <a:tailEnd type="none" w="med" len="med"/>
                     </a:lnB>
                     <a:solidFill>
-                      <a:srgbClr val="FFFFFF"/>
+                      <a:srgbClr val="FAF7F2"/>
                     </a:solidFill>
                   </a:tcPr>
                 </a:tc>
@@ -7389,7 +7867,7 @@
                       <a:tailEnd type="none" w="med" len="med"/>
                     </a:lnB>
                     <a:solidFill>
-                      <a:srgbClr val="FFFFFF"/>
+                      <a:srgbClr val="FAF7F2"/>
                     </a:solidFill>
                   </a:tcPr>
                 </a:tc>
@@ -7457,7 +7935,7 @@
                       <a:tailEnd type="none" w="med" len="med"/>
                     </a:lnB>
                     <a:solidFill>
-                      <a:srgbClr val="FFFFFF"/>
+                      <a:srgbClr val="FAF7F2"/>
                     </a:solidFill>
                   </a:tcPr>
                 </a:tc>
@@ -7479,484 +7957,6 @@
                           <a:cs typeface="Calibri" pitchFamily="34" charset="-120"/>
                         </a:rPr>
                         <a:t>$-9,560</a:t>
-                      </a:r>
-                      <a:endParaRPr lang="en-US" sz="1200" dirty="0">
-                        <a:latin typeface="Calibri" charset="0"/>
-                        <a:ea typeface="Calibri" charset="0"/>
-                        <a:cs typeface="Calibri" charset="0"/>
-                      </a:endParaRPr>
-                    </a:p>
-                  </a:txBody>
-                  <a:tcPr marL="91440" marR="91440" marT="45720" marB="45720" anchor="ctr">
-                    <a:lnL w="6350" cap="flat" cmpd="sng" algn="ctr">
-                      <a:solidFill>
-                        <a:srgbClr val="D6CFC4"/>
-                      </a:solidFill>
-                      <a:prstDash val="solid"/>
-                      <a:round/>
-                      <a:headEnd type="none" w="med" len="med"/>
-                      <a:tailEnd type="none" w="med" len="med"/>
-                    </a:lnL>
-                    <a:lnR w="6350" cap="flat" cmpd="sng" algn="ctr">
-                      <a:solidFill>
-                        <a:srgbClr val="D6CFC4"/>
-                      </a:solidFill>
-                      <a:prstDash val="solid"/>
-                      <a:round/>
-                      <a:headEnd type="none" w="med" len="med"/>
-                      <a:tailEnd type="none" w="med" len="med"/>
-                    </a:lnR>
-                    <a:lnT w="6350" cap="flat" cmpd="sng" algn="ctr">
-                      <a:solidFill>
-                        <a:srgbClr val="D6CFC4"/>
-                      </a:solidFill>
-                      <a:prstDash val="solid"/>
-                      <a:round/>
-                      <a:headEnd type="none" w="med" len="med"/>
-                      <a:tailEnd type="none" w="med" len="med"/>
-                    </a:lnT>
-                    <a:lnB w="6350" cap="flat" cmpd="sng" algn="ctr">
-                      <a:solidFill>
-                        <a:srgbClr val="D6CFC4"/>
-                      </a:solidFill>
-                      <a:prstDash val="solid"/>
-                      <a:round/>
-                      <a:headEnd type="none" w="med" len="med"/>
-                      <a:tailEnd type="none" w="med" len="med"/>
-                    </a:lnB>
-                    <a:solidFill>
-                      <a:srgbClr val="FFFFFF"/>
-                    </a:solidFill>
-                  </a:tcPr>
-                </a:tc>
-              </a:tr>
-              <a:tr h="457200">
-                <a:tc>
-                  <a:txBody>
-                    <a:bodyPr/>
-                    <a:lstStyle/>
-                    <a:p>
-                      <a:pPr algn="l" indent="0" marL="0">
-                        <a:buNone/>
-                      </a:pPr>
-                      <a:r>
-                        <a:rPr lang="en-US" sz="1200" b="1" dirty="0">
-                          <a:solidFill>
-                            <a:srgbClr val="2D2A26"/>
-                          </a:solidFill>
-                          <a:latin typeface="Century Gothic" pitchFamily="34" charset="0"/>
-                          <a:ea typeface="Century Gothic" pitchFamily="34" charset="-122"/>
-                          <a:cs typeface="Century Gothic" pitchFamily="34" charset="-120"/>
-                        </a:rPr>
-                        <a:t>Tanzania</a:t>
-                      </a:r>
-                      <a:endParaRPr lang="en-US" sz="1200" dirty="0">
-                        <a:latin typeface="Century Gothic" charset="0"/>
-                        <a:ea typeface="Century Gothic" charset="0"/>
-                        <a:cs typeface="Century Gothic" charset="0"/>
-                      </a:endParaRPr>
-                    </a:p>
-                  </a:txBody>
-                  <a:tcPr marL="91440" marR="91440" marT="45720" marB="45720" anchor="ctr">
-                    <a:lnL w="6350" cap="flat" cmpd="sng" algn="ctr">
-                      <a:solidFill>
-                        <a:srgbClr val="D6CFC4"/>
-                      </a:solidFill>
-                      <a:prstDash val="solid"/>
-                      <a:round/>
-                      <a:headEnd type="none" w="med" len="med"/>
-                      <a:tailEnd type="none" w="med" len="med"/>
-                    </a:lnL>
-                    <a:lnR w="6350" cap="flat" cmpd="sng" algn="ctr">
-                      <a:solidFill>
-                        <a:srgbClr val="D6CFC4"/>
-                      </a:solidFill>
-                      <a:prstDash val="solid"/>
-                      <a:round/>
-                      <a:headEnd type="none" w="med" len="med"/>
-                      <a:tailEnd type="none" w="med" len="med"/>
-                    </a:lnR>
-                    <a:lnT w="6350" cap="flat" cmpd="sng" algn="ctr">
-                      <a:solidFill>
-                        <a:srgbClr val="D6CFC4"/>
-                      </a:solidFill>
-                      <a:prstDash val="solid"/>
-                      <a:round/>
-                      <a:headEnd type="none" w="med" len="med"/>
-                      <a:tailEnd type="none" w="med" len="med"/>
-                    </a:lnT>
-                    <a:lnB w="6350" cap="flat" cmpd="sng" algn="ctr">
-                      <a:solidFill>
-                        <a:srgbClr val="D6CFC4"/>
-                      </a:solidFill>
-                      <a:prstDash val="solid"/>
-                      <a:round/>
-                      <a:headEnd type="none" w="med" len="med"/>
-                      <a:tailEnd type="none" w="med" len="med"/>
-                    </a:lnB>
-                    <a:solidFill>
-                      <a:srgbClr val="FAF7F2"/>
-                    </a:solidFill>
-                  </a:tcPr>
-                </a:tc>
-                <a:tc>
-                  <a:txBody>
-                    <a:bodyPr/>
-                    <a:lstStyle/>
-                    <a:p>
-                      <a:pPr algn="ctr" indent="0" marL="0">
-                        <a:buNone/>
-                      </a:pPr>
-                      <a:r>
-                        <a:rPr lang="en-US" sz="1200" dirty="0">
-                          <a:solidFill>
-                            <a:srgbClr val="2D2A26"/>
-                          </a:solidFill>
-                          <a:latin typeface="Calibri" pitchFamily="34" charset="0"/>
-                          <a:ea typeface="Calibri" pitchFamily="34" charset="-122"/>
-                          <a:cs typeface="Calibri" pitchFamily="34" charset="-120"/>
-                        </a:rPr>
-                        <a:t>—</a:t>
-                      </a:r>
-                      <a:endParaRPr lang="en-US" sz="1200" dirty="0">
-                        <a:latin typeface="Calibri" charset="0"/>
-                        <a:ea typeface="Calibri" charset="0"/>
-                        <a:cs typeface="Calibri" charset="0"/>
-                      </a:endParaRPr>
-                    </a:p>
-                  </a:txBody>
-                  <a:tcPr marL="91440" marR="91440" marT="45720" marB="45720" anchor="ctr">
-                    <a:lnL w="6350" cap="flat" cmpd="sng" algn="ctr">
-                      <a:solidFill>
-                        <a:srgbClr val="D6CFC4"/>
-                      </a:solidFill>
-                      <a:prstDash val="solid"/>
-                      <a:round/>
-                      <a:headEnd type="none" w="med" len="med"/>
-                      <a:tailEnd type="none" w="med" len="med"/>
-                    </a:lnL>
-                    <a:lnR w="6350" cap="flat" cmpd="sng" algn="ctr">
-                      <a:solidFill>
-                        <a:srgbClr val="D6CFC4"/>
-                      </a:solidFill>
-                      <a:prstDash val="solid"/>
-                      <a:round/>
-                      <a:headEnd type="none" w="med" len="med"/>
-                      <a:tailEnd type="none" w="med" len="med"/>
-                    </a:lnR>
-                    <a:lnT w="6350" cap="flat" cmpd="sng" algn="ctr">
-                      <a:solidFill>
-                        <a:srgbClr val="D6CFC4"/>
-                      </a:solidFill>
-                      <a:prstDash val="solid"/>
-                      <a:round/>
-                      <a:headEnd type="none" w="med" len="med"/>
-                      <a:tailEnd type="none" w="med" len="med"/>
-                    </a:lnT>
-                    <a:lnB w="6350" cap="flat" cmpd="sng" algn="ctr">
-                      <a:solidFill>
-                        <a:srgbClr val="D6CFC4"/>
-                      </a:solidFill>
-                      <a:prstDash val="solid"/>
-                      <a:round/>
-                      <a:headEnd type="none" w="med" len="med"/>
-                      <a:tailEnd type="none" w="med" len="med"/>
-                    </a:lnB>
-                    <a:solidFill>
-                      <a:srgbClr val="FAF7F2"/>
-                    </a:solidFill>
-                  </a:tcPr>
-                </a:tc>
-                <a:tc>
-                  <a:txBody>
-                    <a:bodyPr/>
-                    <a:lstStyle/>
-                    <a:p>
-                      <a:pPr algn="ctr" indent="0" marL="0">
-                        <a:buNone/>
-                      </a:pPr>
-                      <a:r>
-                        <a:rPr lang="en-US" sz="1200" dirty="0">
-                          <a:solidFill>
-                            <a:srgbClr val="2D2A26"/>
-                          </a:solidFill>
-                          <a:latin typeface="Calibri" pitchFamily="34" charset="0"/>
-                          <a:ea typeface="Calibri" pitchFamily="34" charset="-122"/>
-                          <a:cs typeface="Calibri" pitchFamily="34" charset="-120"/>
-                        </a:rPr>
-                        <a:t>—</a:t>
-                      </a:r>
-                      <a:endParaRPr lang="en-US" sz="1200" dirty="0">
-                        <a:latin typeface="Calibri" charset="0"/>
-                        <a:ea typeface="Calibri" charset="0"/>
-                        <a:cs typeface="Calibri" charset="0"/>
-                      </a:endParaRPr>
-                    </a:p>
-                  </a:txBody>
-                  <a:tcPr marL="91440" marR="91440" marT="45720" marB="45720" anchor="ctr">
-                    <a:lnL w="6350" cap="flat" cmpd="sng" algn="ctr">
-                      <a:solidFill>
-                        <a:srgbClr val="D6CFC4"/>
-                      </a:solidFill>
-                      <a:prstDash val="solid"/>
-                      <a:round/>
-                      <a:headEnd type="none" w="med" len="med"/>
-                      <a:tailEnd type="none" w="med" len="med"/>
-                    </a:lnL>
-                    <a:lnR w="6350" cap="flat" cmpd="sng" algn="ctr">
-                      <a:solidFill>
-                        <a:srgbClr val="D6CFC4"/>
-                      </a:solidFill>
-                      <a:prstDash val="solid"/>
-                      <a:round/>
-                      <a:headEnd type="none" w="med" len="med"/>
-                      <a:tailEnd type="none" w="med" len="med"/>
-                    </a:lnR>
-                    <a:lnT w="6350" cap="flat" cmpd="sng" algn="ctr">
-                      <a:solidFill>
-                        <a:srgbClr val="D6CFC4"/>
-                      </a:solidFill>
-                      <a:prstDash val="solid"/>
-                      <a:round/>
-                      <a:headEnd type="none" w="med" len="med"/>
-                      <a:tailEnd type="none" w="med" len="med"/>
-                    </a:lnT>
-                    <a:lnB w="6350" cap="flat" cmpd="sng" algn="ctr">
-                      <a:solidFill>
-                        <a:srgbClr val="D6CFC4"/>
-                      </a:solidFill>
-                      <a:prstDash val="solid"/>
-                      <a:round/>
-                      <a:headEnd type="none" w="med" len="med"/>
-                      <a:tailEnd type="none" w="med" len="med"/>
-                    </a:lnB>
-                    <a:solidFill>
-                      <a:srgbClr val="FAF7F2"/>
-                    </a:solidFill>
-                  </a:tcPr>
-                </a:tc>
-                <a:tc>
-                  <a:txBody>
-                    <a:bodyPr/>
-                    <a:lstStyle/>
-                    <a:p>
-                      <a:pPr algn="ctr" indent="0" marL="0">
-                        <a:buNone/>
-                      </a:pPr>
-                      <a:r>
-                        <a:rPr lang="en-US" sz="1200" dirty="0">
-                          <a:solidFill>
-                            <a:srgbClr val="2D2A26"/>
-                          </a:solidFill>
-                          <a:latin typeface="Calibri" pitchFamily="34" charset="0"/>
-                          <a:ea typeface="Calibri" pitchFamily="34" charset="-122"/>
-                          <a:cs typeface="Calibri" pitchFamily="34" charset="-120"/>
-                        </a:rPr>
-                        <a:t>—</a:t>
-                      </a:r>
-                      <a:endParaRPr lang="en-US" sz="1200" dirty="0">
-                        <a:latin typeface="Calibri" charset="0"/>
-                        <a:ea typeface="Calibri" charset="0"/>
-                        <a:cs typeface="Calibri" charset="0"/>
-                      </a:endParaRPr>
-                    </a:p>
-                  </a:txBody>
-                  <a:tcPr marL="91440" marR="91440" marT="45720" marB="45720" anchor="ctr">
-                    <a:lnL w="6350" cap="flat" cmpd="sng" algn="ctr">
-                      <a:solidFill>
-                        <a:srgbClr val="D6CFC4"/>
-                      </a:solidFill>
-                      <a:prstDash val="solid"/>
-                      <a:round/>
-                      <a:headEnd type="none" w="med" len="med"/>
-                      <a:tailEnd type="none" w="med" len="med"/>
-                    </a:lnL>
-                    <a:lnR w="6350" cap="flat" cmpd="sng" algn="ctr">
-                      <a:solidFill>
-                        <a:srgbClr val="D6CFC4"/>
-                      </a:solidFill>
-                      <a:prstDash val="solid"/>
-                      <a:round/>
-                      <a:headEnd type="none" w="med" len="med"/>
-                      <a:tailEnd type="none" w="med" len="med"/>
-                    </a:lnR>
-                    <a:lnT w="6350" cap="flat" cmpd="sng" algn="ctr">
-                      <a:solidFill>
-                        <a:srgbClr val="D6CFC4"/>
-                      </a:solidFill>
-                      <a:prstDash val="solid"/>
-                      <a:round/>
-                      <a:headEnd type="none" w="med" len="med"/>
-                      <a:tailEnd type="none" w="med" len="med"/>
-                    </a:lnT>
-                    <a:lnB w="6350" cap="flat" cmpd="sng" algn="ctr">
-                      <a:solidFill>
-                        <a:srgbClr val="D6CFC4"/>
-                      </a:solidFill>
-                      <a:prstDash val="solid"/>
-                      <a:round/>
-                      <a:headEnd type="none" w="med" len="med"/>
-                      <a:tailEnd type="none" w="med" len="med"/>
-                    </a:lnB>
-                    <a:solidFill>
-                      <a:srgbClr val="FAF7F2"/>
-                    </a:solidFill>
-                  </a:tcPr>
-                </a:tc>
-                <a:tc>
-                  <a:txBody>
-                    <a:bodyPr/>
-                    <a:lstStyle/>
-                    <a:p>
-                      <a:pPr algn="ctr" indent="0" marL="0">
-                        <a:buNone/>
-                      </a:pPr>
-                      <a:r>
-                        <a:rPr lang="en-US" sz="1200" dirty="0">
-                          <a:solidFill>
-                            <a:srgbClr val="2D2A26"/>
-                          </a:solidFill>
-                          <a:latin typeface="Calibri" pitchFamily="34" charset="0"/>
-                          <a:ea typeface="Calibri" pitchFamily="34" charset="-122"/>
-                          <a:cs typeface="Calibri" pitchFamily="34" charset="-120"/>
-                        </a:rPr>
-                        <a:t>—</a:t>
-                      </a:r>
-                      <a:endParaRPr lang="en-US" sz="1200" dirty="0">
-                        <a:latin typeface="Calibri" charset="0"/>
-                        <a:ea typeface="Calibri" charset="0"/>
-                        <a:cs typeface="Calibri" charset="0"/>
-                      </a:endParaRPr>
-                    </a:p>
-                  </a:txBody>
-                  <a:tcPr marL="91440" marR="91440" marT="45720" marB="45720" anchor="ctr">
-                    <a:lnL w="6350" cap="flat" cmpd="sng" algn="ctr">
-                      <a:solidFill>
-                        <a:srgbClr val="D6CFC4"/>
-                      </a:solidFill>
-                      <a:prstDash val="solid"/>
-                      <a:round/>
-                      <a:headEnd type="none" w="med" len="med"/>
-                      <a:tailEnd type="none" w="med" len="med"/>
-                    </a:lnL>
-                    <a:lnR w="6350" cap="flat" cmpd="sng" algn="ctr">
-                      <a:solidFill>
-                        <a:srgbClr val="D6CFC4"/>
-                      </a:solidFill>
-                      <a:prstDash val="solid"/>
-                      <a:round/>
-                      <a:headEnd type="none" w="med" len="med"/>
-                      <a:tailEnd type="none" w="med" len="med"/>
-                    </a:lnR>
-                    <a:lnT w="6350" cap="flat" cmpd="sng" algn="ctr">
-                      <a:solidFill>
-                        <a:srgbClr val="D6CFC4"/>
-                      </a:solidFill>
-                      <a:prstDash val="solid"/>
-                      <a:round/>
-                      <a:headEnd type="none" w="med" len="med"/>
-                      <a:tailEnd type="none" w="med" len="med"/>
-                    </a:lnT>
-                    <a:lnB w="6350" cap="flat" cmpd="sng" algn="ctr">
-                      <a:solidFill>
-                        <a:srgbClr val="D6CFC4"/>
-                      </a:solidFill>
-                      <a:prstDash val="solid"/>
-                      <a:round/>
-                      <a:headEnd type="none" w="med" len="med"/>
-                      <a:tailEnd type="none" w="med" len="med"/>
-                    </a:lnB>
-                    <a:solidFill>
-                      <a:srgbClr val="FAF7F2"/>
-                    </a:solidFill>
-                  </a:tcPr>
-                </a:tc>
-                <a:tc>
-                  <a:txBody>
-                    <a:bodyPr/>
-                    <a:lstStyle/>
-                    <a:p>
-                      <a:pPr algn="ctr" indent="0" marL="0">
-                        <a:buNone/>
-                      </a:pPr>
-                      <a:r>
-                        <a:rPr lang="en-US" sz="1200" dirty="0">
-                          <a:solidFill>
-                            <a:srgbClr val="2D2A26"/>
-                          </a:solidFill>
-                          <a:latin typeface="Calibri" pitchFamily="34" charset="0"/>
-                          <a:ea typeface="Calibri" pitchFamily="34" charset="-122"/>
-                          <a:cs typeface="Calibri" pitchFamily="34" charset="-120"/>
-                        </a:rPr>
-                        <a:t>N/M</a:t>
-                      </a:r>
-                      <a:endParaRPr lang="en-US" sz="1200" dirty="0">
-                        <a:latin typeface="Calibri" charset="0"/>
-                        <a:ea typeface="Calibri" charset="0"/>
-                        <a:cs typeface="Calibri" charset="0"/>
-                      </a:endParaRPr>
-                    </a:p>
-                  </a:txBody>
-                  <a:tcPr marL="91440" marR="91440" marT="45720" marB="45720" anchor="ctr">
-                    <a:lnL w="6350" cap="flat" cmpd="sng" algn="ctr">
-                      <a:solidFill>
-                        <a:srgbClr val="D6CFC4"/>
-                      </a:solidFill>
-                      <a:prstDash val="solid"/>
-                      <a:round/>
-                      <a:headEnd type="none" w="med" len="med"/>
-                      <a:tailEnd type="none" w="med" len="med"/>
-                    </a:lnL>
-                    <a:lnR w="6350" cap="flat" cmpd="sng" algn="ctr">
-                      <a:solidFill>
-                        <a:srgbClr val="D6CFC4"/>
-                      </a:solidFill>
-                      <a:prstDash val="solid"/>
-                      <a:round/>
-                      <a:headEnd type="none" w="med" len="med"/>
-                      <a:tailEnd type="none" w="med" len="med"/>
-                    </a:lnR>
-                    <a:lnT w="6350" cap="flat" cmpd="sng" algn="ctr">
-                      <a:solidFill>
-                        <a:srgbClr val="D6CFC4"/>
-                      </a:solidFill>
-                      <a:prstDash val="solid"/>
-                      <a:round/>
-                      <a:headEnd type="none" w="med" len="med"/>
-                      <a:tailEnd type="none" w="med" len="med"/>
-                    </a:lnT>
-                    <a:lnB w="6350" cap="flat" cmpd="sng" algn="ctr">
-                      <a:solidFill>
-                        <a:srgbClr val="D6CFC4"/>
-                      </a:solidFill>
-                      <a:prstDash val="solid"/>
-                      <a:round/>
-                      <a:headEnd type="none" w="med" len="med"/>
-                      <a:tailEnd type="none" w="med" len="med"/>
-                    </a:lnB>
-                    <a:solidFill>
-                      <a:srgbClr val="FAF7F2"/>
-                    </a:solidFill>
-                  </a:tcPr>
-                </a:tc>
-                <a:tc>
-                  <a:txBody>
-                    <a:bodyPr/>
-                    <a:lstStyle/>
-                    <a:p>
-                      <a:pPr algn="ctr" indent="0" marL="0">
-                        <a:buNone/>
-                      </a:pPr>
-                      <a:r>
-                        <a:rPr lang="en-US" sz="1200" dirty="0">
-                          <a:solidFill>
-                            <a:srgbClr val="2D2A26"/>
-                          </a:solidFill>
-                          <a:latin typeface="Calibri" pitchFamily="34" charset="0"/>
-                          <a:ea typeface="Calibri" pitchFamily="34" charset="-122"/>
-                          <a:cs typeface="Calibri" pitchFamily="34" charset="-120"/>
-                        </a:rPr>
-                        <a:t>—</a:t>
                       </a:r>
                       <a:endParaRPr lang="en-US" sz="1200" dirty="0">
                         <a:latin typeface="Calibri" charset="0"/>
@@ -8572,7 +8572,7 @@
                           <a:ea typeface="Calibri" pitchFamily="34" charset="-122"/>
                           <a:cs typeface="Calibri" pitchFamily="34" charset="-120"/>
                         </a:rPr>
-                        <a:t>$1,188,863</a:t>
+                        <a:t>$2,096,094</a:t>
                       </a:r>
                       <a:endParaRPr lang="en-US" sz="1200" dirty="0">
                         <a:latin typeface="Calibri" charset="0"/>
@@ -8640,7 +8640,7 @@
                           <a:ea typeface="Calibri" pitchFamily="34" charset="-122"/>
                           <a:cs typeface="Calibri" pitchFamily="34" charset="-120"/>
                         </a:rPr>
-                        <a:t>$-236,332</a:t>
+                        <a:t>$-451,024</a:t>
                       </a:r>
                       <a:endParaRPr lang="en-US" sz="1200" dirty="0">
                         <a:latin typeface="Calibri" charset="0"/>
@@ -8708,7 +8708,7 @@
                           <a:ea typeface="Calibri" pitchFamily="34" charset="-122"/>
                           <a:cs typeface="Calibri" pitchFamily="34" charset="-120"/>
                         </a:rPr>
-                        <a:t>$-782,678</a:t>
+                        <a:t>$-1,377,257</a:t>
                       </a:r>
                       <a:endParaRPr lang="en-US" sz="1200" dirty="0">
                         <a:latin typeface="Calibri" charset="0"/>
@@ -8776,7 +8776,7 @@
                           <a:ea typeface="Calibri" pitchFamily="34" charset="-122"/>
                           <a:cs typeface="Calibri" pitchFamily="34" charset="-120"/>
                         </a:rPr>
-                        <a:t>$169,853</a:t>
+                        <a:t>$267,813</a:t>
                       </a:r>
                       <a:endParaRPr lang="en-US" sz="1200" dirty="0">
                         <a:latin typeface="Calibri" charset="0"/>
@@ -8844,7 +8844,7 @@
                           <a:ea typeface="Calibri" pitchFamily="34" charset="-122"/>
                           <a:cs typeface="Calibri" pitchFamily="34" charset="-120"/>
                         </a:rPr>
-                        <a:t>14.3%</a:t>
+                        <a:t>12.8%</a:t>
                       </a:r>
                       <a:endParaRPr lang="en-US" sz="1200" dirty="0">
                         <a:latin typeface="Calibri" charset="0"/>
@@ -8912,7 +8912,7 @@
                           <a:ea typeface="Calibri" pitchFamily="34" charset="-122"/>
                           <a:cs typeface="Calibri" pitchFamily="34" charset="-120"/>
                         </a:rPr>
-                        <a:t>$45,158</a:t>
+                        <a:t>$152,051</a:t>
                       </a:r>
                       <a:endParaRPr lang="en-US" sz="1200" dirty="0">
                         <a:latin typeface="Calibri" charset="0"/>
@@ -9097,7 +9097,7 @@
                 <a:ea typeface="Century Gothic" pitchFamily="34" charset="-122"/>
                 <a:cs typeface="Century Gothic" pitchFamily="34" charset="-120"/>
               </a:rPr>
-              <a:t>$1,188,863</a:t>
+              <a:t>$2,096,094</a:t>
             </a:r>
             <a:endParaRPr lang="en-US" sz="2600" dirty="0"/>
           </a:p>
@@ -9232,7 +9232,7 @@
                 <a:ea typeface="Century Gothic" pitchFamily="34" charset="-122"/>
                 <a:cs typeface="Century Gothic" pitchFamily="34" charset="-120"/>
               </a:rPr>
-              <a:t>$169,853</a:t>
+              <a:t>$267,813</a:t>
             </a:r>
             <a:endParaRPr lang="en-US" sz="2600" dirty="0"/>
           </a:p>
@@ -9367,7 +9367,7 @@
                 <a:ea typeface="Century Gothic" pitchFamily="34" charset="-122"/>
                 <a:cs typeface="Century Gothic" pitchFamily="34" charset="-120"/>
               </a:rPr>
-              <a:t>14.3%</a:t>
+              <a:t>12.8%</a:t>
             </a:r>
             <a:endParaRPr lang="en-US" sz="2600" dirty="0"/>
           </a:p>
@@ -9850,45 +9850,6 @@
             <a:r>
               <a:rPr lang="en-US" sz="1200" b="1" dirty="0">
                 <a:solidFill>
-                  <a:srgbClr val="718096"/>
-                </a:solidFill>
-                <a:latin typeface="Calibri" pitchFamily="34" charset="0"/>
-                <a:ea typeface="Calibri" pitchFamily="34" charset="-122"/>
-                <a:cs typeface="Calibri" pitchFamily="34" charset="-120"/>
-              </a:rPr>
-              <a:t>—</a:t>
-            </a:r>
-            <a:endParaRPr lang="en-US" sz="1200" dirty="0"/>
-          </a:p>
-        </p:txBody>
-      </p:sp>
-      <p:sp>
-        <p:nvSpPr>
-          <p:cNvPr id="16" name="Text 13"/>
-          <p:cNvSpPr/>
-          <p:nvPr/>
-        </p:nvSpPr>
-        <p:spPr>
-          <a:xfrm>
-            <a:off x="2514600" y="5943600"/>
-            <a:ext cx="2377440" cy="347472"/>
-          </a:xfrm>
-          <a:prstGeom prst="rect">
-            <a:avLst/>
-          </a:prstGeom>
-          <a:noFill/>
-          <a:ln/>
-        </p:spPr>
-        <p:txBody>
-          <a:bodyPr wrap="square" rtlCol="0" anchor="ctr"/>
-          <a:lstStyle/>
-          <a:p>
-            <a:pPr algn="ctr" indent="0" marL="0">
-              <a:buNone/>
-            </a:pPr>
-            <a:r>
-              <a:rPr lang="en-US" sz="1200" b="1" dirty="0">
-                <a:solidFill>
                   <a:srgbClr val="C0392B"/>
                 </a:solidFill>
                 <a:latin typeface="Calibri" pitchFamily="34" charset="0"/>
@@ -9903,13 +9864,13 @@
       </p:sp>
       <p:sp>
         <p:nvSpPr>
-          <p:cNvPr id="17" name="Text 14"/>
-          <p:cNvSpPr/>
-          <p:nvPr/>
-        </p:nvSpPr>
-        <p:spPr>
-          <a:xfrm>
-            <a:off x="4892040" y="5943600"/>
+          <p:cNvPr id="16" name="Text 13"/>
+          <p:cNvSpPr/>
+          <p:nvPr/>
+        </p:nvSpPr>
+        <p:spPr>
+          <a:xfrm>
+            <a:off x="2514600" y="5943600"/>
             <a:ext cx="2377440" cy="347472"/>
           </a:xfrm>
           <a:prstGeom prst="rect">
@@ -9942,13 +9903,13 @@
       </p:sp>
       <p:sp>
         <p:nvSpPr>
-          <p:cNvPr id="18" name="Text 15"/>
-          <p:cNvSpPr/>
-          <p:nvPr/>
-        </p:nvSpPr>
-        <p:spPr>
-          <a:xfrm>
-            <a:off x="7269480" y="5943600"/>
+          <p:cNvPr id="17" name="Text 14"/>
+          <p:cNvSpPr/>
+          <p:nvPr/>
+        </p:nvSpPr>
+        <p:spPr>
+          <a:xfrm>
+            <a:off x="4892040" y="5943600"/>
             <a:ext cx="2377440" cy="347472"/>
           </a:xfrm>
           <a:prstGeom prst="rect">
@@ -9981,13 +9942,13 @@
       </p:sp>
       <p:sp>
         <p:nvSpPr>
-          <p:cNvPr id="19" name="Text 16"/>
-          <p:cNvSpPr/>
-          <p:nvPr/>
-        </p:nvSpPr>
-        <p:spPr>
-          <a:xfrm>
-            <a:off x="9646920" y="5943600"/>
+          <p:cNvPr id="18" name="Text 15"/>
+          <p:cNvSpPr/>
+          <p:nvPr/>
+        </p:nvSpPr>
+        <p:spPr>
+          <a:xfrm>
+            <a:off x="7269480" y="5943600"/>
             <a:ext cx="2377440" cy="347472"/>
           </a:xfrm>
           <a:prstGeom prst="rect">
@@ -10013,6 +9974,45 @@
                 <a:cs typeface="Calibri" pitchFamily="34" charset="-120"/>
               </a:rPr>
               <a:t>-9.9%</a:t>
+            </a:r>
+            <a:endParaRPr lang="en-US" sz="1200" dirty="0"/>
+          </a:p>
+        </p:txBody>
+      </p:sp>
+      <p:sp>
+        <p:nvSpPr>
+          <p:cNvPr id="19" name="Text 16"/>
+          <p:cNvSpPr/>
+          <p:nvPr/>
+        </p:nvSpPr>
+        <p:spPr>
+          <a:xfrm>
+            <a:off x="9646920" y="5943600"/>
+            <a:ext cx="2377440" cy="347472"/>
+          </a:xfrm>
+          <a:prstGeom prst="rect">
+            <a:avLst/>
+          </a:prstGeom>
+          <a:noFill/>
+          <a:ln/>
+        </p:spPr>
+        <p:txBody>
+          <a:bodyPr wrap="square" rtlCol="0" anchor="ctr"/>
+          <a:lstStyle/>
+          <a:p>
+            <a:pPr algn="ctr" indent="0" marL="0">
+              <a:buNone/>
+            </a:pPr>
+            <a:r>
+              <a:rPr lang="en-US" sz="1200" b="1" dirty="0">
+                <a:solidFill>
+                  <a:srgbClr val="1A7A6E"/>
+                </a:solidFill>
+                <a:latin typeface="Calibri" pitchFamily="34" charset="0"/>
+                <a:ea typeface="Calibri" pitchFamily="34" charset="-122"/>
+                <a:cs typeface="Calibri" pitchFamily="34" charset="-120"/>
+              </a:rPr>
+              <a:t>-3.5%</a:t>
             </a:r>
             <a:endParaRPr lang="en-US" sz="1200" dirty="0"/>
           </a:p>
@@ -10456,45 +10456,6 @@
             <a:r>
               <a:rPr lang="en-US" sz="1200" b="1" dirty="0">
                 <a:solidFill>
-                  <a:srgbClr val="718096"/>
-                </a:solidFill>
-                <a:latin typeface="Calibri" pitchFamily="34" charset="0"/>
-                <a:ea typeface="Calibri" pitchFamily="34" charset="-122"/>
-                <a:cs typeface="Calibri" pitchFamily="34" charset="-120"/>
-              </a:rPr>
-              <a:t>—</a:t>
-            </a:r>
-            <a:endParaRPr lang="en-US" sz="1200" dirty="0"/>
-          </a:p>
-        </p:txBody>
-      </p:sp>
-      <p:sp>
-        <p:nvSpPr>
-          <p:cNvPr id="16" name="Text 13"/>
-          <p:cNvSpPr/>
-          <p:nvPr/>
-        </p:nvSpPr>
-        <p:spPr>
-          <a:xfrm>
-            <a:off x="2514600" y="5486400"/>
-            <a:ext cx="2377440" cy="347472"/>
-          </a:xfrm>
-          <a:prstGeom prst="rect">
-            <a:avLst/>
-          </a:prstGeom>
-          <a:noFill/>
-          <a:ln/>
-        </p:spPr>
-        <p:txBody>
-          <a:bodyPr wrap="square" rtlCol="0" anchor="ctr"/>
-          <a:lstStyle/>
-          <a:p>
-            <a:pPr algn="ctr" indent="0" marL="0">
-              <a:buNone/>
-            </a:pPr>
-            <a:r>
-              <a:rPr lang="en-US" sz="1200" b="1" dirty="0">
-                <a:solidFill>
                   <a:srgbClr val="C0392B"/>
                 </a:solidFill>
                 <a:latin typeface="Calibri" pitchFamily="34" charset="0"/>
@@ -10509,13 +10470,13 @@
       </p:sp>
       <p:sp>
         <p:nvSpPr>
-          <p:cNvPr id="17" name="Text 14"/>
-          <p:cNvSpPr/>
-          <p:nvPr/>
-        </p:nvSpPr>
-        <p:spPr>
-          <a:xfrm>
-            <a:off x="4892040" y="5486400"/>
+          <p:cNvPr id="16" name="Text 13"/>
+          <p:cNvSpPr/>
+          <p:nvPr/>
+        </p:nvSpPr>
+        <p:spPr>
+          <a:xfrm>
+            <a:off x="2514600" y="5486400"/>
             <a:ext cx="2377440" cy="347472"/>
           </a:xfrm>
           <a:prstGeom prst="rect">
@@ -10548,13 +10509,13 @@
       </p:sp>
       <p:sp>
         <p:nvSpPr>
-          <p:cNvPr id="18" name="Text 15"/>
-          <p:cNvSpPr/>
-          <p:nvPr/>
-        </p:nvSpPr>
-        <p:spPr>
-          <a:xfrm>
-            <a:off x="7269480" y="5486400"/>
+          <p:cNvPr id="17" name="Text 14"/>
+          <p:cNvSpPr/>
+          <p:nvPr/>
+        </p:nvSpPr>
+        <p:spPr>
+          <a:xfrm>
+            <a:off x="4892040" y="5486400"/>
             <a:ext cx="2377440" cy="347472"/>
           </a:xfrm>
           <a:prstGeom prst="rect">
@@ -10587,13 +10548,13 @@
       </p:sp>
       <p:sp>
         <p:nvSpPr>
-          <p:cNvPr id="19" name="Text 16"/>
-          <p:cNvSpPr/>
-          <p:nvPr/>
-        </p:nvSpPr>
-        <p:spPr>
-          <a:xfrm>
-            <a:off x="9646920" y="5486400"/>
+          <p:cNvPr id="18" name="Text 15"/>
+          <p:cNvSpPr/>
+          <p:nvPr/>
+        </p:nvSpPr>
+        <p:spPr>
+          <a:xfrm>
+            <a:off x="7269480" y="5486400"/>
             <a:ext cx="2377440" cy="347472"/>
           </a:xfrm>
           <a:prstGeom prst="rect">
@@ -10626,6 +10587,45 @@
       </p:sp>
       <p:sp>
         <p:nvSpPr>
+          <p:cNvPr id="19" name="Text 16"/>
+          <p:cNvSpPr/>
+          <p:nvPr/>
+        </p:nvSpPr>
+        <p:spPr>
+          <a:xfrm>
+            <a:off x="9646920" y="5486400"/>
+            <a:ext cx="2377440" cy="347472"/>
+          </a:xfrm>
+          <a:prstGeom prst="rect">
+            <a:avLst/>
+          </a:prstGeom>
+          <a:noFill/>
+          <a:ln/>
+        </p:spPr>
+        <p:txBody>
+          <a:bodyPr wrap="square" rtlCol="0" anchor="ctr"/>
+          <a:lstStyle/>
+          <a:p>
+            <a:pPr algn="ctr" indent="0" marL="0">
+              <a:buNone/>
+            </a:pPr>
+            <a:r>
+              <a:rPr lang="en-US" sz="1200" b="1" dirty="0">
+                <a:solidFill>
+                  <a:srgbClr val="C0392B"/>
+                </a:solidFill>
+                <a:latin typeface="Calibri" pitchFamily="34" charset="0"/>
+                <a:ea typeface="Calibri" pitchFamily="34" charset="-122"/>
+                <a:cs typeface="Calibri" pitchFamily="34" charset="-120"/>
+              </a:rPr>
+              <a:t>+25.2%</a:t>
+            </a:r>
+            <a:endParaRPr lang="en-US" sz="1200" dirty="0"/>
+          </a:p>
+        </p:txBody>
+      </p:sp>
+      <p:sp>
+        <p:nvSpPr>
           <p:cNvPr id="20" name="Shape 17"/>
           <p:cNvSpPr/>
           <p:nvPr/>
@@ -10740,45 +10740,6 @@
             <a:r>
               <a:rPr lang="en-US" sz="1200" b="1" dirty="0">
                 <a:solidFill>
-                  <a:srgbClr val="718096"/>
-                </a:solidFill>
-                <a:latin typeface="Calibri" pitchFamily="34" charset="0"/>
-                <a:ea typeface="Calibri" pitchFamily="34" charset="-122"/>
-                <a:cs typeface="Calibri" pitchFamily="34" charset="-120"/>
-              </a:rPr>
-              <a:t>—</a:t>
-            </a:r>
-            <a:endParaRPr lang="en-US" sz="1200" dirty="0"/>
-          </a:p>
-        </p:txBody>
-      </p:sp>
-      <p:sp>
-        <p:nvSpPr>
-          <p:cNvPr id="24" name="Text 21"/>
-          <p:cNvSpPr/>
-          <p:nvPr/>
-        </p:nvSpPr>
-        <p:spPr>
-          <a:xfrm>
-            <a:off x="2514600" y="6199632"/>
-            <a:ext cx="2377440" cy="347472"/>
-          </a:xfrm>
-          <a:prstGeom prst="rect">
-            <a:avLst/>
-          </a:prstGeom>
-          <a:noFill/>
-          <a:ln/>
-        </p:spPr>
-        <p:txBody>
-          <a:bodyPr wrap="square" rtlCol="0" anchor="ctr"/>
-          <a:lstStyle/>
-          <a:p>
-            <a:pPr algn="ctr" indent="0" marL="0">
-              <a:buNone/>
-            </a:pPr>
-            <a:r>
-              <a:rPr lang="en-US" sz="1200" b="1" dirty="0">
-                <a:solidFill>
                   <a:srgbClr val="C0392B"/>
                 </a:solidFill>
                 <a:latin typeface="Calibri" pitchFamily="34" charset="0"/>
@@ -10793,13 +10754,13 @@
       </p:sp>
       <p:sp>
         <p:nvSpPr>
-          <p:cNvPr id="25" name="Text 22"/>
-          <p:cNvSpPr/>
-          <p:nvPr/>
-        </p:nvSpPr>
-        <p:spPr>
-          <a:xfrm>
-            <a:off x="4892040" y="6199632"/>
+          <p:cNvPr id="24" name="Text 21"/>
+          <p:cNvSpPr/>
+          <p:nvPr/>
+        </p:nvSpPr>
+        <p:spPr>
+          <a:xfrm>
+            <a:off x="2514600" y="6199632"/>
             <a:ext cx="2377440" cy="347472"/>
           </a:xfrm>
           <a:prstGeom prst="rect">
@@ -10832,13 +10793,13 @@
       </p:sp>
       <p:sp>
         <p:nvSpPr>
-          <p:cNvPr id="26" name="Text 23"/>
-          <p:cNvSpPr/>
-          <p:nvPr/>
-        </p:nvSpPr>
-        <p:spPr>
-          <a:xfrm>
-            <a:off x="7269480" y="6199632"/>
+          <p:cNvPr id="25" name="Text 22"/>
+          <p:cNvSpPr/>
+          <p:nvPr/>
+        </p:nvSpPr>
+        <p:spPr>
+          <a:xfrm>
+            <a:off x="4892040" y="6199632"/>
             <a:ext cx="2377440" cy="347472"/>
           </a:xfrm>
           <a:prstGeom prst="rect">
@@ -10871,13 +10832,13 @@
       </p:sp>
       <p:sp>
         <p:nvSpPr>
-          <p:cNvPr id="27" name="Text 24"/>
-          <p:cNvSpPr/>
-          <p:nvPr/>
-        </p:nvSpPr>
-        <p:spPr>
-          <a:xfrm>
-            <a:off x="9646920" y="6199632"/>
+          <p:cNvPr id="26" name="Text 23"/>
+          <p:cNvSpPr/>
+          <p:nvPr/>
+        </p:nvSpPr>
+        <p:spPr>
+          <a:xfrm>
+            <a:off x="7269480" y="6199632"/>
             <a:ext cx="2377440" cy="347472"/>
           </a:xfrm>
           <a:prstGeom prst="rect">
@@ -10903,6 +10864,45 @@
                 <a:cs typeface="Calibri" pitchFamily="34" charset="-120"/>
               </a:rPr>
               <a:t>-100.0%</a:t>
+            </a:r>
+            <a:endParaRPr lang="en-US" sz="1200" dirty="0"/>
+          </a:p>
+        </p:txBody>
+      </p:sp>
+      <p:sp>
+        <p:nvSpPr>
+          <p:cNvPr id="27" name="Text 24"/>
+          <p:cNvSpPr/>
+          <p:nvPr/>
+        </p:nvSpPr>
+        <p:spPr>
+          <a:xfrm>
+            <a:off x="9646920" y="6199632"/>
+            <a:ext cx="2377440" cy="347472"/>
+          </a:xfrm>
+          <a:prstGeom prst="rect">
+            <a:avLst/>
+          </a:prstGeom>
+          <a:noFill/>
+          <a:ln/>
+        </p:spPr>
+        <p:txBody>
+          <a:bodyPr wrap="square" rtlCol="0" anchor="ctr"/>
+          <a:lstStyle/>
+          <a:p>
+            <a:pPr algn="ctr" indent="0" marL="0">
+              <a:buNone/>
+            </a:pPr>
+            <a:r>
+              <a:rPr lang="en-US" sz="1200" b="1" dirty="0">
+                <a:solidFill>
+                  <a:srgbClr val="1A7A6E"/>
+                </a:solidFill>
+                <a:latin typeface="Calibri" pitchFamily="34" charset="0"/>
+                <a:ea typeface="Calibri" pitchFamily="34" charset="-122"/>
+                <a:cs typeface="Calibri" pitchFamily="34" charset="-120"/>
+              </a:rPr>
+              <a:t>+4.8%</a:t>
             </a:r>
             <a:endParaRPr lang="en-US" sz="1200" dirty="0"/>
           </a:p>
@@ -11346,45 +11346,6 @@
             <a:r>
               <a:rPr lang="en-US" sz="1200" b="1" dirty="0">
                 <a:solidFill>
-                  <a:srgbClr val="718096"/>
-                </a:solidFill>
-                <a:latin typeface="Calibri" pitchFamily="34" charset="0"/>
-                <a:ea typeface="Calibri" pitchFamily="34" charset="-122"/>
-                <a:cs typeface="Calibri" pitchFamily="34" charset="-120"/>
-              </a:rPr>
-              <a:t>—</a:t>
-            </a:r>
-            <a:endParaRPr lang="en-US" sz="1200" dirty="0"/>
-          </a:p>
-        </p:txBody>
-      </p:sp>
-      <p:sp>
-        <p:nvSpPr>
-          <p:cNvPr id="16" name="Text 13"/>
-          <p:cNvSpPr/>
-          <p:nvPr/>
-        </p:nvSpPr>
-        <p:spPr>
-          <a:xfrm>
-            <a:off x="2514600" y="5486400"/>
-            <a:ext cx="2377440" cy="347472"/>
-          </a:xfrm>
-          <a:prstGeom prst="rect">
-            <a:avLst/>
-          </a:prstGeom>
-          <a:noFill/>
-          <a:ln/>
-        </p:spPr>
-        <p:txBody>
-          <a:bodyPr wrap="square" rtlCol="0" anchor="ctr"/>
-          <a:lstStyle/>
-          <a:p>
-            <a:pPr algn="ctr" indent="0" marL="0">
-              <a:buNone/>
-            </a:pPr>
-            <a:r>
-              <a:rPr lang="en-US" sz="1200" b="1" dirty="0">
-                <a:solidFill>
                   <a:srgbClr val="1A7A6E"/>
                 </a:solidFill>
                 <a:latin typeface="Calibri" pitchFamily="34" charset="0"/>
@@ -11399,13 +11360,13 @@
       </p:sp>
       <p:sp>
         <p:nvSpPr>
-          <p:cNvPr id="17" name="Text 14"/>
-          <p:cNvSpPr/>
-          <p:nvPr/>
-        </p:nvSpPr>
-        <p:spPr>
-          <a:xfrm>
-            <a:off x="4892040" y="5486400"/>
+          <p:cNvPr id="16" name="Text 13"/>
+          <p:cNvSpPr/>
+          <p:nvPr/>
+        </p:nvSpPr>
+        <p:spPr>
+          <a:xfrm>
+            <a:off x="2514600" y="5486400"/>
             <a:ext cx="2377440" cy="347472"/>
           </a:xfrm>
           <a:prstGeom prst="rect">
@@ -11438,13 +11399,13 @@
       </p:sp>
       <p:sp>
         <p:nvSpPr>
-          <p:cNvPr id="18" name="Text 15"/>
-          <p:cNvSpPr/>
-          <p:nvPr/>
-        </p:nvSpPr>
-        <p:spPr>
-          <a:xfrm>
-            <a:off x="7269480" y="5486400"/>
+          <p:cNvPr id="17" name="Text 14"/>
+          <p:cNvSpPr/>
+          <p:nvPr/>
+        </p:nvSpPr>
+        <p:spPr>
+          <a:xfrm>
+            <a:off x="4892040" y="5486400"/>
             <a:ext cx="2377440" cy="347472"/>
           </a:xfrm>
           <a:prstGeom prst="rect">
@@ -11477,13 +11438,13 @@
       </p:sp>
       <p:sp>
         <p:nvSpPr>
-          <p:cNvPr id="19" name="Text 16"/>
-          <p:cNvSpPr/>
-          <p:nvPr/>
-        </p:nvSpPr>
-        <p:spPr>
-          <a:xfrm>
-            <a:off x="9646920" y="5486400"/>
+          <p:cNvPr id="18" name="Text 15"/>
+          <p:cNvSpPr/>
+          <p:nvPr/>
+        </p:nvSpPr>
+        <p:spPr>
+          <a:xfrm>
+            <a:off x="7269480" y="5486400"/>
             <a:ext cx="2377440" cy="347472"/>
           </a:xfrm>
           <a:prstGeom prst="rect">
@@ -11516,6 +11477,45 @@
       </p:sp>
       <p:sp>
         <p:nvSpPr>
+          <p:cNvPr id="19" name="Text 16"/>
+          <p:cNvSpPr/>
+          <p:nvPr/>
+        </p:nvSpPr>
+        <p:spPr>
+          <a:xfrm>
+            <a:off x="9646920" y="5486400"/>
+            <a:ext cx="2377440" cy="347472"/>
+          </a:xfrm>
+          <a:prstGeom prst="rect">
+            <a:avLst/>
+          </a:prstGeom>
+          <a:noFill/>
+          <a:ln/>
+        </p:spPr>
+        <p:txBody>
+          <a:bodyPr wrap="square" rtlCol="0" anchor="ctr"/>
+          <a:lstStyle/>
+          <a:p>
+            <a:pPr algn="ctr" indent="0" marL="0">
+              <a:buNone/>
+            </a:pPr>
+            <a:r>
+              <a:rPr lang="en-US" sz="1200" b="1" dirty="0">
+                <a:solidFill>
+                  <a:srgbClr val="C0392B"/>
+                </a:solidFill>
+                <a:latin typeface="Calibri" pitchFamily="34" charset="0"/>
+                <a:ea typeface="Calibri" pitchFamily="34" charset="-122"/>
+                <a:cs typeface="Calibri" pitchFamily="34" charset="-120"/>
+              </a:rPr>
+              <a:t>+26.3%</a:t>
+            </a:r>
+            <a:endParaRPr lang="en-US" sz="1200" dirty="0"/>
+          </a:p>
+        </p:txBody>
+      </p:sp>
+      <p:sp>
+        <p:nvSpPr>
           <p:cNvPr id="20" name="Shape 17"/>
           <p:cNvSpPr/>
           <p:nvPr/>
@@ -11630,45 +11630,6 @@
             <a:r>
               <a:rPr lang="en-US" sz="1200" b="1" dirty="0">
                 <a:solidFill>
-                  <a:srgbClr val="718096"/>
-                </a:solidFill>
-                <a:latin typeface="Calibri" pitchFamily="34" charset="0"/>
-                <a:ea typeface="Calibri" pitchFamily="34" charset="-122"/>
-                <a:cs typeface="Calibri" pitchFamily="34" charset="-120"/>
-              </a:rPr>
-              <a:t>—</a:t>
-            </a:r>
-            <a:endParaRPr lang="en-US" sz="1200" dirty="0"/>
-          </a:p>
-        </p:txBody>
-      </p:sp>
-      <p:sp>
-        <p:nvSpPr>
-          <p:cNvPr id="24" name="Text 21"/>
-          <p:cNvSpPr/>
-          <p:nvPr/>
-        </p:nvSpPr>
-        <p:spPr>
-          <a:xfrm>
-            <a:off x="2514600" y="6199632"/>
-            <a:ext cx="2377440" cy="347472"/>
-          </a:xfrm>
-          <a:prstGeom prst="rect">
-            <a:avLst/>
-          </a:prstGeom>
-          <a:noFill/>
-          <a:ln/>
-        </p:spPr>
-        <p:txBody>
-          <a:bodyPr wrap="square" rtlCol="0" anchor="ctr"/>
-          <a:lstStyle/>
-          <a:p>
-            <a:pPr algn="ctr" indent="0" marL="0">
-              <a:buNone/>
-            </a:pPr>
-            <a:r>
-              <a:rPr lang="en-US" sz="1200" b="1" dirty="0">
-                <a:solidFill>
                   <a:srgbClr val="C0392B"/>
                 </a:solidFill>
                 <a:latin typeface="Calibri" pitchFamily="34" charset="0"/>
@@ -11683,13 +11644,13 @@
       </p:sp>
       <p:sp>
         <p:nvSpPr>
-          <p:cNvPr id="25" name="Text 22"/>
-          <p:cNvSpPr/>
-          <p:nvPr/>
-        </p:nvSpPr>
-        <p:spPr>
-          <a:xfrm>
-            <a:off x="4892040" y="6199632"/>
+          <p:cNvPr id="24" name="Text 21"/>
+          <p:cNvSpPr/>
+          <p:nvPr/>
+        </p:nvSpPr>
+        <p:spPr>
+          <a:xfrm>
+            <a:off x="2514600" y="6199632"/>
             <a:ext cx="2377440" cy="347472"/>
           </a:xfrm>
           <a:prstGeom prst="rect">
@@ -11722,13 +11683,13 @@
       </p:sp>
       <p:sp>
         <p:nvSpPr>
-          <p:cNvPr id="26" name="Text 23"/>
-          <p:cNvSpPr/>
-          <p:nvPr/>
-        </p:nvSpPr>
-        <p:spPr>
-          <a:xfrm>
-            <a:off x="7269480" y="6199632"/>
+          <p:cNvPr id="25" name="Text 22"/>
+          <p:cNvSpPr/>
+          <p:nvPr/>
+        </p:nvSpPr>
+        <p:spPr>
+          <a:xfrm>
+            <a:off x="4892040" y="6199632"/>
             <a:ext cx="2377440" cy="347472"/>
           </a:xfrm>
           <a:prstGeom prst="rect">
@@ -11761,13 +11722,13 @@
       </p:sp>
       <p:sp>
         <p:nvSpPr>
-          <p:cNvPr id="27" name="Text 24"/>
-          <p:cNvSpPr/>
-          <p:nvPr/>
-        </p:nvSpPr>
-        <p:spPr>
-          <a:xfrm>
-            <a:off x="9646920" y="6199632"/>
+          <p:cNvPr id="26" name="Text 23"/>
+          <p:cNvSpPr/>
+          <p:nvPr/>
+        </p:nvSpPr>
+        <p:spPr>
+          <a:xfrm>
+            <a:off x="7269480" y="6199632"/>
             <a:ext cx="2377440" cy="347472"/>
           </a:xfrm>
           <a:prstGeom prst="rect">
@@ -11793,6 +11754,45 @@
                 <a:cs typeface="Calibri" pitchFamily="34" charset="-120"/>
               </a:rPr>
               <a:t>-100.0%</a:t>
+            </a:r>
+            <a:endParaRPr lang="en-US" sz="1200" dirty="0"/>
+          </a:p>
+        </p:txBody>
+      </p:sp>
+      <p:sp>
+        <p:nvSpPr>
+          <p:cNvPr id="27" name="Text 24"/>
+          <p:cNvSpPr/>
+          <p:nvPr/>
+        </p:nvSpPr>
+        <p:spPr>
+          <a:xfrm>
+            <a:off x="9646920" y="6199632"/>
+            <a:ext cx="2377440" cy="347472"/>
+          </a:xfrm>
+          <a:prstGeom prst="rect">
+            <a:avLst/>
+          </a:prstGeom>
+          <a:noFill/>
+          <a:ln/>
+        </p:spPr>
+        <p:txBody>
+          <a:bodyPr wrap="square" rtlCol="0" anchor="ctr"/>
+          <a:lstStyle/>
+          <a:p>
+            <a:pPr algn="ctr" indent="0" marL="0">
+              <a:buNone/>
+            </a:pPr>
+            <a:r>
+              <a:rPr lang="en-US" sz="1200" b="1" dirty="0">
+                <a:solidFill>
+                  <a:srgbClr val="1A7A6E"/>
+                </a:solidFill>
+                <a:latin typeface="Calibri" pitchFamily="34" charset="0"/>
+                <a:ea typeface="Calibri" pitchFamily="34" charset="-122"/>
+                <a:cs typeface="Calibri" pitchFamily="34" charset="-120"/>
+              </a:rPr>
+              <a:t>+4.8%</a:t>
             </a:r>
             <a:endParaRPr lang="en-US" sz="1200" dirty="0"/>
           </a:p>
@@ -12281,6 +12281,45 @@
                 <a:ea typeface="Calibri" pitchFamily="34" charset="-122"/>
                 <a:cs typeface="Calibri" pitchFamily="34" charset="-120"/>
               </a:rPr>
+              <a:t>+2.9%</a:t>
+            </a:r>
+            <a:endParaRPr lang="en-US" sz="1200" dirty="0"/>
+          </a:p>
+        </p:txBody>
+      </p:sp>
+      <p:sp>
+        <p:nvSpPr>
+          <p:cNvPr id="17" name="Text 14"/>
+          <p:cNvSpPr/>
+          <p:nvPr/>
+        </p:nvSpPr>
+        <p:spPr>
+          <a:xfrm>
+            <a:off x="3172968" y="5925312"/>
+            <a:ext cx="1517904" cy="347472"/>
+          </a:xfrm>
+          <a:prstGeom prst="rect">
+            <a:avLst/>
+          </a:prstGeom>
+          <a:noFill/>
+          <a:ln/>
+        </p:spPr>
+        <p:txBody>
+          <a:bodyPr wrap="square" rtlCol="0" anchor="ctr"/>
+          <a:lstStyle/>
+          <a:p>
+            <a:pPr algn="ctr" indent="0" marL="0">
+              <a:buNone/>
+            </a:pPr>
+            <a:r>
+              <a:rPr lang="en-US" sz="1200" b="1" dirty="0">
+                <a:solidFill>
+                  <a:srgbClr val="1A7A6E"/>
+                </a:solidFill>
+                <a:latin typeface="Calibri" pitchFamily="34" charset="0"/>
+                <a:ea typeface="Calibri" pitchFamily="34" charset="-122"/>
+                <a:cs typeface="Calibri" pitchFamily="34" charset="-120"/>
+              </a:rPr>
               <a:t>+1.5%</a:t>
             </a:r>
             <a:endParaRPr lang="en-US" sz="1200" dirty="0"/>
@@ -12289,13 +12328,13 @@
       </p:sp>
       <p:sp>
         <p:nvSpPr>
-          <p:cNvPr id="17" name="Text 14"/>
-          <p:cNvSpPr/>
-          <p:nvPr/>
-        </p:nvSpPr>
-        <p:spPr>
-          <a:xfrm>
-            <a:off x="3172968" y="5925312"/>
+          <p:cNvPr id="18" name="Text 15"/>
+          <p:cNvSpPr/>
+          <p:nvPr/>
+        </p:nvSpPr>
+        <p:spPr>
+          <a:xfrm>
+            <a:off x="4690872" y="5925312"/>
             <a:ext cx="1517904" cy="347472"/>
           </a:xfrm>
           <a:prstGeom prst="rect">
@@ -12328,13 +12367,13 @@
       </p:sp>
       <p:sp>
         <p:nvSpPr>
-          <p:cNvPr id="18" name="Text 15"/>
-          <p:cNvSpPr/>
-          <p:nvPr/>
-        </p:nvSpPr>
-        <p:spPr>
-          <a:xfrm>
-            <a:off x="4690872" y="5925312"/>
+          <p:cNvPr id="19" name="Text 16"/>
+          <p:cNvSpPr/>
+          <p:nvPr/>
+        </p:nvSpPr>
+        <p:spPr>
+          <a:xfrm>
+            <a:off x="6208776" y="5925312"/>
             <a:ext cx="1517904" cy="347472"/>
           </a:xfrm>
           <a:prstGeom prst="rect">
@@ -12360,45 +12399,6 @@
                 <a:cs typeface="Calibri" pitchFamily="34" charset="-120"/>
               </a:rPr>
               <a:t>-8.2%</a:t>
-            </a:r>
-            <a:endParaRPr lang="en-US" sz="1200" dirty="0"/>
-          </a:p>
-        </p:txBody>
-      </p:sp>
-      <p:sp>
-        <p:nvSpPr>
-          <p:cNvPr id="19" name="Text 16"/>
-          <p:cNvSpPr/>
-          <p:nvPr/>
-        </p:nvSpPr>
-        <p:spPr>
-          <a:xfrm>
-            <a:off x="6208776" y="5925312"/>
-            <a:ext cx="1517904" cy="347472"/>
-          </a:xfrm>
-          <a:prstGeom prst="rect">
-            <a:avLst/>
-          </a:prstGeom>
-          <a:noFill/>
-          <a:ln/>
-        </p:spPr>
-        <p:txBody>
-          <a:bodyPr wrap="square" rtlCol="0" anchor="ctr"/>
-          <a:lstStyle/>
-          <a:p>
-            <a:pPr algn="ctr" indent="0" marL="0">
-              <a:buNone/>
-            </a:pPr>
-            <a:r>
-              <a:rPr lang="en-US" sz="1200" b="1" dirty="0">
-                <a:solidFill>
-                  <a:srgbClr val="718096"/>
-                </a:solidFill>
-                <a:latin typeface="Calibri" pitchFamily="34" charset="0"/>
-                <a:ea typeface="Calibri" pitchFamily="34" charset="-122"/>
-                <a:cs typeface="Calibri" pitchFamily="34" charset="-120"/>
-              </a:rPr>
-              <a:t>—</a:t>
             </a:r>
             <a:endParaRPr lang="en-US" sz="1200" dirty="0"/>
           </a:p>
@@ -12494,7 +12494,7 @@
                 <a:ea typeface="Century Gothic" pitchFamily="34" charset="-122"/>
                 <a:cs typeface="Century Gothic" pitchFamily="34" charset="-120"/>
               </a:rPr>
-              <a:t>13,171</a:t>
+              <a:t>23,232</a:t>
             </a:r>
             <a:endParaRPr lang="en-US" sz="2600" dirty="0"/>
           </a:p>
@@ -12629,7 +12629,7 @@
                 <a:ea typeface="Century Gothic" pitchFamily="34" charset="-122"/>
                 <a:cs typeface="Century Gothic" pitchFamily="34" charset="-120"/>
               </a:rPr>
-              <a:t>63</a:t>
+              <a:t>67</a:t>
             </a:r>
             <a:endParaRPr lang="en-US" sz="2600" dirty="0"/>
           </a:p>
@@ -12764,7 +12764,7 @@
                 <a:ea typeface="Century Gothic" pitchFamily="34" charset="-122"/>
                 <a:cs typeface="Century Gothic" pitchFamily="34" charset="-120"/>
               </a:rPr>
-              <a:t>+0.0%</a:t>
+              <a:t>+1.5%</a:t>
             </a:r>
             <a:endParaRPr lang="en-US" sz="2600" dirty="0"/>
           </a:p>
@@ -12931,7 +12931,7 @@
                 <a:ea typeface="Calibri" pitchFamily="34" charset="-122"/>
                 <a:cs typeface="Calibri" pitchFamily="34" charset="-120"/>
               </a:rPr>
-              <a:t>Group total: 13,171 applications (+3.8% vs prior month).</a:t>
+              <a:t>Group total: 23,232 applications (+3.3% vs prior month).</a:t>
             </a:r>
             <a:endParaRPr lang="en-US" sz="1200" dirty="0"/>
           </a:p>
@@ -13785,7 +13785,7 @@
                 <a:ea typeface="Century Gothic" pitchFamily="34" charset="-122"/>
                 <a:cs typeface="Century Gothic" pitchFamily="34" charset="-120"/>
               </a:rPr>
-              <a:t>90.0%</a:t>
+              <a:t>51.0%</a:t>
             </a:r>
             <a:endParaRPr lang="en-US" sz="2600" dirty="0"/>
           </a:p>
@@ -14548,6 +14548,45 @@
             <a:r>
               <a:rPr lang="en-US" sz="1200" b="1" dirty="0">
                 <a:solidFill>
+                  <a:srgbClr val="C0392B"/>
+                </a:solidFill>
+                <a:latin typeface="Calibri" pitchFamily="34" charset="0"/>
+                <a:ea typeface="Calibri" pitchFamily="34" charset="-122"/>
+                <a:cs typeface="Calibri" pitchFamily="34" charset="-120"/>
+              </a:rPr>
+              <a:t>-13.6%</a:t>
+            </a:r>
+            <a:endParaRPr lang="en-US" sz="1200" dirty="0"/>
+          </a:p>
+        </p:txBody>
+      </p:sp>
+      <p:sp>
+        <p:nvSpPr>
+          <p:cNvPr id="16" name="Text 13"/>
+          <p:cNvSpPr/>
+          <p:nvPr/>
+        </p:nvSpPr>
+        <p:spPr>
+          <a:xfrm>
+            <a:off x="1655064" y="5925312"/>
+            <a:ext cx="1517904" cy="347472"/>
+          </a:xfrm>
+          <a:prstGeom prst="rect">
+            <a:avLst/>
+          </a:prstGeom>
+          <a:noFill/>
+          <a:ln/>
+        </p:spPr>
+        <p:txBody>
+          <a:bodyPr wrap="square" rtlCol="0" anchor="ctr"/>
+          <a:lstStyle/>
+          <a:p>
+            <a:pPr algn="ctr" indent="0" marL="0">
+              <a:buNone/>
+            </a:pPr>
+            <a:r>
+              <a:rPr lang="en-US" sz="1200" b="1" dirty="0">
+                <a:solidFill>
                   <a:srgbClr val="1A7A6E"/>
                 </a:solidFill>
                 <a:latin typeface="Calibri" pitchFamily="34" charset="0"/>
@@ -14562,13 +14601,13 @@
       </p:sp>
       <p:sp>
         <p:nvSpPr>
-          <p:cNvPr id="16" name="Text 13"/>
-          <p:cNvSpPr/>
-          <p:nvPr/>
-        </p:nvSpPr>
-        <p:spPr>
-          <a:xfrm>
-            <a:off x="1655064" y="5925312"/>
+          <p:cNvPr id="17" name="Text 14"/>
+          <p:cNvSpPr/>
+          <p:nvPr/>
+        </p:nvSpPr>
+        <p:spPr>
+          <a:xfrm>
+            <a:off x="3172968" y="5925312"/>
             <a:ext cx="1517904" cy="347472"/>
           </a:xfrm>
           <a:prstGeom prst="rect">
@@ -14601,13 +14640,13 @@
       </p:sp>
       <p:sp>
         <p:nvSpPr>
-          <p:cNvPr id="17" name="Text 14"/>
-          <p:cNvSpPr/>
-          <p:nvPr/>
-        </p:nvSpPr>
-        <p:spPr>
-          <a:xfrm>
-            <a:off x="3172968" y="5925312"/>
+          <p:cNvPr id="18" name="Text 15"/>
+          <p:cNvSpPr/>
+          <p:nvPr/>
+        </p:nvSpPr>
+        <p:spPr>
+          <a:xfrm>
+            <a:off x="4690872" y="5925312"/>
             <a:ext cx="1517904" cy="347472"/>
           </a:xfrm>
           <a:prstGeom prst="rect">
@@ -14633,45 +14672,6 @@
                 <a:cs typeface="Calibri" pitchFamily="34" charset="-120"/>
               </a:rPr>
               <a:t>-4.8%</a:t>
-            </a:r>
-            <a:endParaRPr lang="en-US" sz="1200" dirty="0"/>
-          </a:p>
-        </p:txBody>
-      </p:sp>
-      <p:sp>
-        <p:nvSpPr>
-          <p:cNvPr id="18" name="Text 15"/>
-          <p:cNvSpPr/>
-          <p:nvPr/>
-        </p:nvSpPr>
-        <p:spPr>
-          <a:xfrm>
-            <a:off x="4690872" y="5925312"/>
-            <a:ext cx="1517904" cy="347472"/>
-          </a:xfrm>
-          <a:prstGeom prst="rect">
-            <a:avLst/>
-          </a:prstGeom>
-          <a:noFill/>
-          <a:ln/>
-        </p:spPr>
-        <p:txBody>
-          <a:bodyPr wrap="square" rtlCol="0" anchor="ctr"/>
-          <a:lstStyle/>
-          <a:p>
-            <a:pPr algn="ctr" indent="0" marL="0">
-              <a:buNone/>
-            </a:pPr>
-            <a:r>
-              <a:rPr lang="en-US" sz="1200" b="1" dirty="0">
-                <a:solidFill>
-                  <a:srgbClr val="718096"/>
-                </a:solidFill>
-                <a:latin typeface="Calibri" pitchFamily="34" charset="0"/>
-                <a:ea typeface="Calibri" pitchFamily="34" charset="-122"/>
-                <a:cs typeface="Calibri" pitchFamily="34" charset="-120"/>
-              </a:rPr>
-              <a:t>—</a:t>
             </a:r>
             <a:endParaRPr lang="en-US" sz="1200" dirty="0"/>
           </a:p>
@@ -14806,7 +14806,7 @@
                 <a:ea typeface="Century Gothic" pitchFamily="34" charset="-122"/>
                 <a:cs typeface="Century Gothic" pitchFamily="34" charset="-120"/>
               </a:rPr>
-              <a:t>$1,381,841</a:t>
+              <a:t>$3,573,689</a:t>
             </a:r>
             <a:endParaRPr lang="en-US" sz="2600" dirty="0"/>
           </a:p>
@@ -14941,7 +14941,7 @@
                 <a:ea typeface="Century Gothic" pitchFamily="34" charset="-122"/>
                 <a:cs typeface="Century Gothic" pitchFamily="34" charset="-120"/>
               </a:rPr>
-              <a:t>-56.0%</a:t>
+              <a:t>-37.1%</a:t>
             </a:r>
             <a:endParaRPr lang="en-US" sz="2600" dirty="0"/>
           </a:p>
@@ -15076,7 +15076,7 @@
                 <a:ea typeface="Century Gothic" pitchFamily="34" charset="-122"/>
                 <a:cs typeface="Century Gothic" pitchFamily="34" charset="-120"/>
               </a:rPr>
-              <a:t>23</a:t>
+              <a:t>42</a:t>
             </a:r>
             <a:endParaRPr lang="en-US" sz="2600" dirty="0"/>
           </a:p>
@@ -15268,6 +15268,109 @@
                 <a:ea typeface="Calibri" pitchFamily="34" charset="-122"/>
                 <a:cs typeface="Calibri" pitchFamily="34" charset="-120"/>
               </a:rPr>
+              <a:t>Tanzania</a:t>
+            </a:r>
+            <a:endParaRPr lang="en-US" sz="1100" dirty="0"/>
+          </a:p>
+        </p:txBody>
+      </p:sp>
+      <p:sp>
+        <p:nvSpPr>
+          <p:cNvPr id="37" name="Text 34"/>
+          <p:cNvSpPr/>
+          <p:nvPr/>
+        </p:nvSpPr>
+        <p:spPr>
+          <a:xfrm>
+            <a:off x="7955280" y="4261104"/>
+            <a:ext cx="1234440" cy="292608"/>
+          </a:xfrm>
+          <a:prstGeom prst="rect">
+            <a:avLst/>
+          </a:prstGeom>
+          <a:noFill/>
+          <a:ln/>
+        </p:spPr>
+        <p:txBody>
+          <a:bodyPr wrap="square" rtlCol="0" anchor="ctr"/>
+          <a:lstStyle/>
+          <a:p>
+            <a:pPr algn="ctr" indent="0" marL="0">
+              <a:buNone/>
+            </a:pPr>
+            <a:r>
+              <a:rPr lang="en-US" sz="1100" b="1" dirty="0">
+                <a:solidFill>
+                  <a:srgbClr val="5D300F"/>
+                </a:solidFill>
+                <a:latin typeface="Century Gothic" pitchFamily="34" charset="0"/>
+                <a:ea typeface="Century Gothic" pitchFamily="34" charset="-122"/>
+                <a:cs typeface="Century Gothic" pitchFamily="34" charset="-120"/>
+              </a:rPr>
+              <a:t>139</a:t>
+            </a:r>
+            <a:endParaRPr lang="en-US" sz="1100" dirty="0"/>
+          </a:p>
+        </p:txBody>
+      </p:sp>
+      <p:sp>
+        <p:nvSpPr>
+          <p:cNvPr id="38" name="Shape 35"/>
+          <p:cNvSpPr/>
+          <p:nvPr/>
+        </p:nvSpPr>
+        <p:spPr>
+          <a:xfrm>
+            <a:off x="9308592" y="4023360"/>
+            <a:ext cx="1234440" cy="530352"/>
+          </a:xfrm>
+          <a:prstGeom prst="rect">
+            <a:avLst/>
+          </a:prstGeom>
+          <a:solidFill>
+            <a:srgbClr val="FFF9D9"/>
+          </a:solidFill>
+          <a:ln w="12700">
+            <a:solidFill>
+              <a:srgbClr val="D6CFC4"/>
+            </a:solidFill>
+            <a:prstDash val="solid"/>
+          </a:ln>
+        </p:spPr>
+      </p:sp>
+      <p:sp>
+        <p:nvSpPr>
+          <p:cNvPr id="39" name="Text 36"/>
+          <p:cNvSpPr/>
+          <p:nvPr/>
+        </p:nvSpPr>
+        <p:spPr>
+          <a:xfrm>
+            <a:off x="9308592" y="4023360"/>
+            <a:ext cx="1234440" cy="237744"/>
+          </a:xfrm>
+          <a:prstGeom prst="rect">
+            <a:avLst/>
+          </a:prstGeom>
+          <a:noFill/>
+          <a:ln/>
+        </p:spPr>
+        <p:txBody>
+          <a:bodyPr wrap="square" rtlCol="0" anchor="b"/>
+          <a:lstStyle/>
+          <a:p>
+            <a:pPr algn="ctr" indent="0" marL="0">
+              <a:buNone/>
+            </a:pPr>
+            <a:r>
+              <a:rPr lang="en-US" sz="1100" dirty="0">
+                <a:solidFill>
+                  <a:srgbClr val="718096"/>
+                </a:solidFill>
+                <a:latin typeface="Calibri" pitchFamily="34" charset="0"/>
+                <a:ea typeface="Calibri" pitchFamily="34" charset="-122"/>
+                <a:cs typeface="Calibri" pitchFamily="34" charset="-120"/>
+              </a:rPr>
               <a:t>Sierra Leone</a:t>
             </a:r>
             <a:endParaRPr lang="en-US" sz="1100" dirty="0"/>
@@ -15276,13 +15379,13 @@
       </p:sp>
       <p:sp>
         <p:nvSpPr>
-          <p:cNvPr id="37" name="Text 34"/>
-          <p:cNvSpPr/>
-          <p:nvPr/>
-        </p:nvSpPr>
-        <p:spPr>
-          <a:xfrm>
-            <a:off x="7955280" y="4261104"/>
+          <p:cNvPr id="40" name="Text 37"/>
+          <p:cNvSpPr/>
+          <p:nvPr/>
+        </p:nvSpPr>
+        <p:spPr>
+          <a:xfrm>
+            <a:off x="9308592" y="4261104"/>
             <a:ext cx="1234440" cy="292608"/>
           </a:xfrm>
           <a:prstGeom prst="rect">
@@ -15315,13 +15418,13 @@
       </p:sp>
       <p:sp>
         <p:nvSpPr>
-          <p:cNvPr id="38" name="Shape 35"/>
-          <p:cNvSpPr/>
-          <p:nvPr/>
-        </p:nvSpPr>
-        <p:spPr>
-          <a:xfrm>
-            <a:off x="9308592" y="4023360"/>
+          <p:cNvPr id="41" name="Shape 38"/>
+          <p:cNvSpPr/>
+          <p:nvPr/>
+        </p:nvSpPr>
+        <p:spPr>
+          <a:xfrm>
+            <a:off x="10661904" y="4023360"/>
             <a:ext cx="1234440" cy="530352"/>
           </a:xfrm>
           <a:prstGeom prst="rect">
@@ -15340,13 +15443,13 @@
       </p:sp>
       <p:sp>
         <p:nvSpPr>
-          <p:cNvPr id="39" name="Text 36"/>
-          <p:cNvSpPr/>
-          <p:nvPr/>
-        </p:nvSpPr>
-        <p:spPr>
-          <a:xfrm>
-            <a:off x="9308592" y="4023360"/>
+          <p:cNvPr id="42" name="Text 39"/>
+          <p:cNvSpPr/>
+          <p:nvPr/>
+        </p:nvSpPr>
+        <p:spPr>
+          <a:xfrm>
+            <a:off x="10661904" y="4023360"/>
             <a:ext cx="1234440" cy="237744"/>
           </a:xfrm>
           <a:prstGeom prst="rect">
@@ -15379,13 +15482,13 @@
       </p:sp>
       <p:sp>
         <p:nvSpPr>
-          <p:cNvPr id="40" name="Text 37"/>
-          <p:cNvSpPr/>
-          <p:nvPr/>
-        </p:nvSpPr>
-        <p:spPr>
-          <a:xfrm>
-            <a:off x="9308592" y="4261104"/>
+          <p:cNvPr id="43" name="Text 40"/>
+          <p:cNvSpPr/>
+          <p:nvPr/>
+        </p:nvSpPr>
+        <p:spPr>
+          <a:xfrm>
+            <a:off x="10661904" y="4261104"/>
             <a:ext cx="1234440" cy="292608"/>
           </a:xfrm>
           <a:prstGeom prst="rect">
@@ -15418,13 +15521,13 @@
       </p:sp>
       <p:sp>
         <p:nvSpPr>
-          <p:cNvPr id="41" name="Shape 38"/>
-          <p:cNvSpPr/>
-          <p:nvPr/>
-        </p:nvSpPr>
-        <p:spPr>
-          <a:xfrm>
-            <a:off x="10661904" y="4023360"/>
+          <p:cNvPr id="44" name="Shape 41"/>
+          <p:cNvSpPr/>
+          <p:nvPr/>
+        </p:nvSpPr>
+        <p:spPr>
+          <a:xfrm>
+            <a:off x="7955280" y="4617720"/>
             <a:ext cx="1234440" cy="530352"/>
           </a:xfrm>
           <a:prstGeom prst="rect">
@@ -15443,13 +15546,13 @@
       </p:sp>
       <p:sp>
         <p:nvSpPr>
-          <p:cNvPr id="42" name="Text 39"/>
-          <p:cNvSpPr/>
-          <p:nvPr/>
-        </p:nvSpPr>
-        <p:spPr>
-          <a:xfrm>
-            <a:off x="10661904" y="4023360"/>
+          <p:cNvPr id="45" name="Text 42"/>
+          <p:cNvSpPr/>
+          <p:nvPr/>
+        </p:nvSpPr>
+        <p:spPr>
+          <a:xfrm>
+            <a:off x="7955280" y="4617720"/>
             <a:ext cx="1234440" cy="237744"/>
           </a:xfrm>
           <a:prstGeom prst="rect">
@@ -15482,13 +15585,13 @@
       </p:sp>
       <p:sp>
         <p:nvSpPr>
-          <p:cNvPr id="43" name="Text 40"/>
-          <p:cNvSpPr/>
-          <p:nvPr/>
-        </p:nvSpPr>
-        <p:spPr>
-          <a:xfrm>
-            <a:off x="10661904" y="4261104"/>
+          <p:cNvPr id="46" name="Text 43"/>
+          <p:cNvSpPr/>
+          <p:nvPr/>
+        </p:nvSpPr>
+        <p:spPr>
+          <a:xfrm>
+            <a:off x="7955280" y="4855464"/>
             <a:ext cx="1234440" cy="292608"/>
           </a:xfrm>
           <a:prstGeom prst="rect">
@@ -15521,109 +15624,6 @@
       </p:sp>
       <p:sp>
         <p:nvSpPr>
-          <p:cNvPr id="44" name="Shape 41"/>
-          <p:cNvSpPr/>
-          <p:nvPr/>
-        </p:nvSpPr>
-        <p:spPr>
-          <a:xfrm>
-            <a:off x="7955280" y="4617720"/>
-            <a:ext cx="1234440" cy="530352"/>
-          </a:xfrm>
-          <a:prstGeom prst="rect">
-            <a:avLst/>
-          </a:prstGeom>
-          <a:solidFill>
-            <a:srgbClr val="FFF9D9"/>
-          </a:solidFill>
-          <a:ln w="12700">
-            <a:solidFill>
-              <a:srgbClr val="D6CFC4"/>
-            </a:solidFill>
-            <a:prstDash val="solid"/>
-          </a:ln>
-        </p:spPr>
-      </p:sp>
-      <p:sp>
-        <p:nvSpPr>
-          <p:cNvPr id="45" name="Text 42"/>
-          <p:cNvSpPr/>
-          <p:nvPr/>
-        </p:nvSpPr>
-        <p:spPr>
-          <a:xfrm>
-            <a:off x="7955280" y="4617720"/>
-            <a:ext cx="1234440" cy="237744"/>
-          </a:xfrm>
-          <a:prstGeom prst="rect">
-            <a:avLst/>
-          </a:prstGeom>
-          <a:noFill/>
-          <a:ln/>
-        </p:spPr>
-        <p:txBody>
-          <a:bodyPr wrap="square" rtlCol="0" anchor="b"/>
-          <a:lstStyle/>
-          <a:p>
-            <a:pPr algn="ctr" indent="0" marL="0">
-              <a:buNone/>
-            </a:pPr>
-            <a:r>
-              <a:rPr lang="en-US" sz="1100" dirty="0">
-                <a:solidFill>
-                  <a:srgbClr val="718096"/>
-                </a:solidFill>
-                <a:latin typeface="Calibri" pitchFamily="34" charset="0"/>
-                <a:ea typeface="Calibri" pitchFamily="34" charset="-122"/>
-                <a:cs typeface="Calibri" pitchFamily="34" charset="-120"/>
-              </a:rPr>
-              <a:t>Tanzania</a:t>
-            </a:r>
-            <a:endParaRPr lang="en-US" sz="1100" dirty="0"/>
-          </a:p>
-        </p:txBody>
-      </p:sp>
-      <p:sp>
-        <p:nvSpPr>
-          <p:cNvPr id="46" name="Text 43"/>
-          <p:cNvSpPr/>
-          <p:nvPr/>
-        </p:nvSpPr>
-        <p:spPr>
-          <a:xfrm>
-            <a:off x="7955280" y="4855464"/>
-            <a:ext cx="1234440" cy="292608"/>
-          </a:xfrm>
-          <a:prstGeom prst="rect">
-            <a:avLst/>
-          </a:prstGeom>
-          <a:noFill/>
-          <a:ln/>
-        </p:spPr>
-        <p:txBody>
-          <a:bodyPr wrap="square" rtlCol="0" anchor="ctr"/>
-          <a:lstStyle/>
-          <a:p>
-            <a:pPr algn="ctr" indent="0" marL="0">
-              <a:buNone/>
-            </a:pPr>
-            <a:r>
-              <a:rPr lang="en-US" sz="1100" b="1" dirty="0">
-                <a:solidFill>
-                  <a:srgbClr val="5D300F"/>
-                </a:solidFill>
-                <a:latin typeface="Century Gothic" pitchFamily="34" charset="0"/>
-                <a:ea typeface="Century Gothic" pitchFamily="34" charset="-122"/>
-                <a:cs typeface="Century Gothic" pitchFamily="34" charset="-120"/>
-              </a:rPr>
-              <a:t>—</a:t>
-            </a:r>
-            <a:endParaRPr lang="en-US" sz="1100" dirty="0"/>
-          </a:p>
-        </p:txBody>
-      </p:sp>
-      <p:sp>
-        <p:nvSpPr>
           <p:cNvPr id="47" name="Shape 44"/>
           <p:cNvSpPr/>
           <p:nvPr/>
@@ -15847,7 +15847,7 @@
                 <a:ea typeface="Calibri" pitchFamily="34" charset="-122"/>
                 <a:cs typeface="Calibri" pitchFamily="34" charset="-120"/>
               </a:rPr>
-              <a:t>Total disbursed: $1,381,841 (-56.0% vs prior month).</a:t>
+              <a:t>Total disbursed: $3,573,689 (-37.1% vs prior month).</a:t>
             </a:r>
             <a:endParaRPr lang="en-US" sz="1200" dirty="0"/>
           </a:p>
@@ -15864,7 +15864,7 @@
                 <a:ea typeface="Calibri" pitchFamily="34" charset="-122"/>
                 <a:cs typeface="Calibri" pitchFamily="34" charset="-120"/>
               </a:rPr>
-              <a:t>Sierra Leone had the highest disbursements ($647,525).</a:t>
+              <a:t>Tanzania had the highest disbursements ($2,191,848).</a:t>
             </a:r>
             <a:endParaRPr lang="en-US" sz="1200" dirty="0"/>
           </a:p>
@@ -16419,6 +16419,45 @@
                 <a:ea typeface="Calibri" pitchFamily="34" charset="-122"/>
                 <a:cs typeface="Calibri" pitchFamily="34" charset="-120"/>
               </a:rPr>
+              <a:t>-4.9%</a:t>
+            </a:r>
+            <a:endParaRPr lang="en-US" sz="1200" dirty="0"/>
+          </a:p>
+        </p:txBody>
+      </p:sp>
+      <p:sp>
+        <p:nvSpPr>
+          <p:cNvPr id="20" name="Text 16"/>
+          <p:cNvSpPr/>
+          <p:nvPr/>
+        </p:nvSpPr>
+        <p:spPr>
+          <a:xfrm>
+            <a:off x="1298448" y="5925312"/>
+            <a:ext cx="1161288" cy="347472"/>
+          </a:xfrm>
+          <a:prstGeom prst="rect">
+            <a:avLst/>
+          </a:prstGeom>
+          <a:noFill/>
+          <a:ln/>
+        </p:spPr>
+        <p:txBody>
+          <a:bodyPr wrap="square" rtlCol="0" anchor="ctr"/>
+          <a:lstStyle/>
+          <a:p>
+            <a:pPr algn="ctr" indent="0" marL="0">
+              <a:buNone/>
+            </a:pPr>
+            <a:r>
+              <a:rPr lang="en-US" sz="1200" b="1" dirty="0">
+                <a:solidFill>
+                  <a:srgbClr val="C0392B"/>
+                </a:solidFill>
+                <a:latin typeface="Calibri" pitchFamily="34" charset="0"/>
+                <a:ea typeface="Calibri" pitchFamily="34" charset="-122"/>
+                <a:cs typeface="Calibri" pitchFamily="34" charset="-120"/>
+              </a:rPr>
               <a:t>-5.2%</a:t>
             </a:r>
             <a:endParaRPr lang="en-US" sz="1200" dirty="0"/>
@@ -16427,13 +16466,13 @@
       </p:sp>
       <p:sp>
         <p:nvSpPr>
-          <p:cNvPr id="20" name="Text 16"/>
-          <p:cNvSpPr/>
-          <p:nvPr/>
-        </p:nvSpPr>
-        <p:spPr>
-          <a:xfrm>
-            <a:off x="1298448" y="5925312"/>
+          <p:cNvPr id="21" name="Text 17"/>
+          <p:cNvSpPr/>
+          <p:nvPr/>
+        </p:nvSpPr>
+        <p:spPr>
+          <a:xfrm>
+            <a:off x="2459736" y="5925312"/>
             <a:ext cx="1161288" cy="347472"/>
           </a:xfrm>
           <a:prstGeom prst="rect">
@@ -16466,13 +16505,13 @@
       </p:sp>
       <p:sp>
         <p:nvSpPr>
-          <p:cNvPr id="21" name="Text 17"/>
-          <p:cNvSpPr/>
-          <p:nvPr/>
-        </p:nvSpPr>
-        <p:spPr>
-          <a:xfrm>
-            <a:off x="2459736" y="5925312"/>
+          <p:cNvPr id="22" name="Text 18"/>
+          <p:cNvSpPr/>
+          <p:nvPr/>
+        </p:nvSpPr>
+        <p:spPr>
+          <a:xfrm>
+            <a:off x="3621024" y="5925312"/>
             <a:ext cx="1161288" cy="347472"/>
           </a:xfrm>
           <a:prstGeom prst="rect">
@@ -16505,45 +16544,6 @@
       </p:sp>
       <p:sp>
         <p:nvSpPr>
-          <p:cNvPr id="22" name="Text 18"/>
-          <p:cNvSpPr/>
-          <p:nvPr/>
-        </p:nvSpPr>
-        <p:spPr>
-          <a:xfrm>
-            <a:off x="3621024" y="5925312"/>
-            <a:ext cx="1161288" cy="347472"/>
-          </a:xfrm>
-          <a:prstGeom prst="rect">
-            <a:avLst/>
-          </a:prstGeom>
-          <a:noFill/>
-          <a:ln/>
-        </p:spPr>
-        <p:txBody>
-          <a:bodyPr wrap="square" rtlCol="0" anchor="ctr"/>
-          <a:lstStyle/>
-          <a:p>
-            <a:pPr algn="ctr" indent="0" marL="0">
-              <a:buNone/>
-            </a:pPr>
-            <a:r>
-              <a:rPr lang="en-US" sz="1200" b="1" dirty="0">
-                <a:solidFill>
-                  <a:srgbClr val="718096"/>
-                </a:solidFill>
-                <a:latin typeface="Calibri" pitchFamily="34" charset="0"/>
-                <a:ea typeface="Calibri" pitchFamily="34" charset="-122"/>
-                <a:cs typeface="Calibri" pitchFamily="34" charset="-120"/>
-              </a:rPr>
-              <a:t>—</a:t>
-            </a:r>
-            <a:endParaRPr lang="en-US" sz="1200" dirty="0"/>
-          </a:p>
-        </p:txBody>
-      </p:sp>
-      <p:sp>
-        <p:nvSpPr>
           <p:cNvPr id="23" name="Text 19"/>
           <p:cNvSpPr/>
           <p:nvPr/>
@@ -16703,6 +16703,45 @@
                 <a:ea typeface="Calibri" pitchFamily="34" charset="-122"/>
                 <a:cs typeface="Calibri" pitchFamily="34" charset="-120"/>
               </a:rPr>
+              <a:t>+4.8%</a:t>
+            </a:r>
+            <a:endParaRPr lang="en-US" sz="1200" dirty="0"/>
+          </a:p>
+        </p:txBody>
+      </p:sp>
+      <p:sp>
+        <p:nvSpPr>
+          <p:cNvPr id="28" name="Text 24"/>
+          <p:cNvSpPr/>
+          <p:nvPr/>
+        </p:nvSpPr>
+        <p:spPr>
+          <a:xfrm>
+            <a:off x="7333488" y="5925312"/>
+            <a:ext cx="1161288" cy="347472"/>
+          </a:xfrm>
+          <a:prstGeom prst="rect">
+            <a:avLst/>
+          </a:prstGeom>
+          <a:noFill/>
+          <a:ln/>
+        </p:spPr>
+        <p:txBody>
+          <a:bodyPr wrap="square" rtlCol="0" anchor="ctr"/>
+          <a:lstStyle/>
+          <a:p>
+            <a:pPr algn="ctr" indent="0" marL="0">
+              <a:buNone/>
+            </a:pPr>
+            <a:r>
+              <a:rPr lang="en-US" sz="1200" b="1" dirty="0">
+                <a:solidFill>
+                  <a:srgbClr val="1A7A6E"/>
+                </a:solidFill>
+                <a:latin typeface="Calibri" pitchFamily="34" charset="0"/>
+                <a:ea typeface="Calibri" pitchFamily="34" charset="-122"/>
+                <a:cs typeface="Calibri" pitchFamily="34" charset="-120"/>
+              </a:rPr>
               <a:t>+13.0%</a:t>
             </a:r>
             <a:endParaRPr lang="en-US" sz="1200" dirty="0"/>
@@ -16711,13 +16750,13 @@
       </p:sp>
       <p:sp>
         <p:nvSpPr>
-          <p:cNvPr id="28" name="Text 24"/>
-          <p:cNvSpPr/>
-          <p:nvPr/>
-        </p:nvSpPr>
-        <p:spPr>
-          <a:xfrm>
-            <a:off x="7333488" y="5925312"/>
+          <p:cNvPr id="29" name="Text 25"/>
+          <p:cNvSpPr/>
+          <p:nvPr/>
+        </p:nvSpPr>
+        <p:spPr>
+          <a:xfrm>
+            <a:off x="8494776" y="5925312"/>
             <a:ext cx="1161288" cy="347472"/>
           </a:xfrm>
           <a:prstGeom prst="rect">
@@ -16750,13 +16789,13 @@
       </p:sp>
       <p:sp>
         <p:nvSpPr>
-          <p:cNvPr id="29" name="Text 25"/>
-          <p:cNvSpPr/>
-          <p:nvPr/>
-        </p:nvSpPr>
-        <p:spPr>
-          <a:xfrm>
-            <a:off x="8494776" y="5925312"/>
+          <p:cNvPr id="30" name="Text 26"/>
+          <p:cNvSpPr/>
+          <p:nvPr/>
+        </p:nvSpPr>
+        <p:spPr>
+          <a:xfrm>
+            <a:off x="9656064" y="5925312"/>
             <a:ext cx="1161288" cy="347472"/>
           </a:xfrm>
           <a:prstGeom prst="rect">
@@ -16782,45 +16821,6 @@
                 <a:cs typeface="Calibri" pitchFamily="34" charset="-120"/>
               </a:rPr>
               <a:t>+5.0%</a:t>
-            </a:r>
-            <a:endParaRPr lang="en-US" sz="1200" dirty="0"/>
-          </a:p>
-        </p:txBody>
-      </p:sp>
-      <p:sp>
-        <p:nvSpPr>
-          <p:cNvPr id="30" name="Text 26"/>
-          <p:cNvSpPr/>
-          <p:nvPr/>
-        </p:nvSpPr>
-        <p:spPr>
-          <a:xfrm>
-            <a:off x="9656064" y="5925312"/>
-            <a:ext cx="1161288" cy="347472"/>
-          </a:xfrm>
-          <a:prstGeom prst="rect">
-            <a:avLst/>
-          </a:prstGeom>
-          <a:noFill/>
-          <a:ln/>
-        </p:spPr>
-        <p:txBody>
-          <a:bodyPr wrap="square" rtlCol="0" anchor="ctr"/>
-          <a:lstStyle/>
-          <a:p>
-            <a:pPr algn="ctr" indent="0" marL="0">
-              <a:buNone/>
-            </a:pPr>
-            <a:r>
-              <a:rPr lang="en-US" sz="1200" b="1" dirty="0">
-                <a:solidFill>
-                  <a:srgbClr val="718096"/>
-                </a:solidFill>
-                <a:latin typeface="Calibri" pitchFamily="34" charset="0"/>
-                <a:ea typeface="Calibri" pitchFamily="34" charset="-122"/>
-                <a:cs typeface="Calibri" pitchFamily="34" charset="-120"/>
-              </a:rPr>
-              <a:t>—</a:t>
             </a:r>
             <a:endParaRPr lang="en-US" sz="1200" dirty="0"/>
           </a:p>
@@ -17303,6 +17303,45 @@
             <a:r>
               <a:rPr lang="en-US" sz="1200" b="1" dirty="0">
                 <a:solidFill>
+                  <a:srgbClr val="C0392B"/>
+                </a:solidFill>
+                <a:latin typeface="Calibri" pitchFamily="34" charset="0"/>
+                <a:ea typeface="Calibri" pitchFamily="34" charset="-122"/>
+                <a:cs typeface="Calibri" pitchFamily="34" charset="-120"/>
+              </a:rPr>
+              <a:t>↑</a:t>
+            </a:r>
+            <a:endParaRPr lang="en-US" sz="1200" dirty="0"/>
+          </a:p>
+        </p:txBody>
+      </p:sp>
+      <p:sp>
+        <p:nvSpPr>
+          <p:cNvPr id="16" name="Text 13"/>
+          <p:cNvSpPr/>
+          <p:nvPr/>
+        </p:nvSpPr>
+        <p:spPr>
+          <a:xfrm>
+            <a:off x="1655064" y="5925312"/>
+            <a:ext cx="1517904" cy="347472"/>
+          </a:xfrm>
+          <a:prstGeom prst="rect">
+            <a:avLst/>
+          </a:prstGeom>
+          <a:noFill/>
+          <a:ln/>
+        </p:spPr>
+        <p:txBody>
+          <a:bodyPr wrap="square" rtlCol="0" anchor="ctr"/>
+          <a:lstStyle/>
+          <a:p>
+            <a:pPr algn="ctr" indent="0" marL="0">
+              <a:buNone/>
+            </a:pPr>
+            <a:r>
+              <a:rPr lang="en-US" sz="1200" b="1" dirty="0">
+                <a:solidFill>
                   <a:srgbClr val="1A7A6E"/>
                 </a:solidFill>
                 <a:latin typeface="Calibri" pitchFamily="34" charset="0"/>
@@ -17317,13 +17356,13 @@
       </p:sp>
       <p:sp>
         <p:nvSpPr>
-          <p:cNvPr id="16" name="Text 13"/>
-          <p:cNvSpPr/>
-          <p:nvPr/>
-        </p:nvSpPr>
-        <p:spPr>
-          <a:xfrm>
-            <a:off x="1655064" y="5925312"/>
+          <p:cNvPr id="17" name="Text 14"/>
+          <p:cNvSpPr/>
+          <p:nvPr/>
+        </p:nvSpPr>
+        <p:spPr>
+          <a:xfrm>
+            <a:off x="3172968" y="5925312"/>
             <a:ext cx="1517904" cy="347472"/>
           </a:xfrm>
           <a:prstGeom prst="rect">
@@ -17356,13 +17395,13 @@
       </p:sp>
       <p:sp>
         <p:nvSpPr>
-          <p:cNvPr id="17" name="Text 14"/>
-          <p:cNvSpPr/>
-          <p:nvPr/>
-        </p:nvSpPr>
-        <p:spPr>
-          <a:xfrm>
-            <a:off x="3172968" y="5925312"/>
+          <p:cNvPr id="18" name="Text 15"/>
+          <p:cNvSpPr/>
+          <p:nvPr/>
+        </p:nvSpPr>
+        <p:spPr>
+          <a:xfrm>
+            <a:off x="4690872" y="5925312"/>
             <a:ext cx="1517904" cy="347472"/>
           </a:xfrm>
           <a:prstGeom prst="rect">
@@ -17382,45 +17421,6 @@
               <a:rPr lang="en-US" sz="1200" b="1" dirty="0">
                 <a:solidFill>
                   <a:srgbClr val="1A7A6E"/>
-                </a:solidFill>
-                <a:latin typeface="Calibri" pitchFamily="34" charset="0"/>
-                <a:ea typeface="Calibri" pitchFamily="34" charset="-122"/>
-                <a:cs typeface="Calibri" pitchFamily="34" charset="-120"/>
-              </a:rPr>
-              <a:t>—</a:t>
-            </a:r>
-            <a:endParaRPr lang="en-US" sz="1200" dirty="0"/>
-          </a:p>
-        </p:txBody>
-      </p:sp>
-      <p:sp>
-        <p:nvSpPr>
-          <p:cNvPr id="18" name="Text 15"/>
-          <p:cNvSpPr/>
-          <p:nvPr/>
-        </p:nvSpPr>
-        <p:spPr>
-          <a:xfrm>
-            <a:off x="4690872" y="5925312"/>
-            <a:ext cx="1517904" cy="347472"/>
-          </a:xfrm>
-          <a:prstGeom prst="rect">
-            <a:avLst/>
-          </a:prstGeom>
-          <a:noFill/>
-          <a:ln/>
-        </p:spPr>
-        <p:txBody>
-          <a:bodyPr wrap="square" rtlCol="0" anchor="ctr"/>
-          <a:lstStyle/>
-          <a:p>
-            <a:pPr algn="ctr" indent="0" marL="0">
-              <a:buNone/>
-            </a:pPr>
-            <a:r>
-              <a:rPr lang="en-US" sz="1200" b="1" dirty="0">
-                <a:solidFill>
-                  <a:srgbClr val="718096"/>
                 </a:solidFill>
                 <a:latin typeface="Calibri" pitchFamily="34" charset="0"/>
                 <a:ea typeface="Calibri" pitchFamily="34" charset="-122"/>
@@ -17696,7 +17696,7 @@
                 <a:ea typeface="Century Gothic" pitchFamily="34" charset="-122"/>
                 <a:cs typeface="Century Gothic" pitchFamily="34" charset="-120"/>
               </a:rPr>
-              <a:t>—</a:t>
+              <a:t>↑</a:t>
             </a:r>
             <a:endParaRPr lang="en-US" sz="2600" dirty="0"/>
           </a:p>
@@ -17880,7 +17880,7 @@
                 <a:ea typeface="Calibri" pitchFamily="34" charset="-122"/>
                 <a:cs typeface="Calibri" pitchFamily="34" charset="-120"/>
               </a:rPr>
-              <a:t>Fastest: Uganda (3 days). Slowest: Sierra Leone (5 days).</a:t>
+              <a:t>Fastest: Tanzania (3 days). Slowest: Sierra Leone (5 days).</a:t>
             </a:r>
             <a:endParaRPr lang="en-US" sz="1200" dirty="0"/>
           </a:p>
@@ -18324,6 +18324,45 @@
             <a:r>
               <a:rPr lang="en-US" sz="1200" b="1" dirty="0">
                 <a:solidFill>
+                  <a:srgbClr val="C0392B"/>
+                </a:solidFill>
+                <a:latin typeface="Calibri" pitchFamily="34" charset="0"/>
+                <a:ea typeface="Calibri" pitchFamily="34" charset="-122"/>
+                <a:cs typeface="Calibri" pitchFamily="34" charset="-120"/>
+              </a:rPr>
+              <a:t>-8.8%</a:t>
+            </a:r>
+            <a:endParaRPr lang="en-US" sz="1200" dirty="0"/>
+          </a:p>
+        </p:txBody>
+      </p:sp>
+      <p:sp>
+        <p:nvSpPr>
+          <p:cNvPr id="16" name="Text 13"/>
+          <p:cNvSpPr/>
+          <p:nvPr/>
+        </p:nvSpPr>
+        <p:spPr>
+          <a:xfrm>
+            <a:off x="1655064" y="5925312"/>
+            <a:ext cx="1517904" cy="347472"/>
+          </a:xfrm>
+          <a:prstGeom prst="rect">
+            <a:avLst/>
+          </a:prstGeom>
+          <a:noFill/>
+          <a:ln/>
+        </p:spPr>
+        <p:txBody>
+          <a:bodyPr wrap="square" rtlCol="0" anchor="ctr"/>
+          <a:lstStyle/>
+          <a:p>
+            <a:pPr algn="ctr" indent="0" marL="0">
+              <a:buNone/>
+            </a:pPr>
+            <a:r>
+              <a:rPr lang="en-US" sz="1200" b="1" dirty="0">
+                <a:solidFill>
                   <a:srgbClr val="1A7A6E"/>
                 </a:solidFill>
                 <a:latin typeface="Calibri" pitchFamily="34" charset="0"/>
@@ -18338,13 +18377,13 @@
       </p:sp>
       <p:sp>
         <p:nvSpPr>
-          <p:cNvPr id="16" name="Text 13"/>
-          <p:cNvSpPr/>
-          <p:nvPr/>
-        </p:nvSpPr>
-        <p:spPr>
-          <a:xfrm>
-            <a:off x="1655064" y="5925312"/>
+          <p:cNvPr id="17" name="Text 14"/>
+          <p:cNvSpPr/>
+          <p:nvPr/>
+        </p:nvSpPr>
+        <p:spPr>
+          <a:xfrm>
+            <a:off x="3172968" y="5925312"/>
             <a:ext cx="1517904" cy="347472"/>
           </a:xfrm>
           <a:prstGeom prst="rect">
@@ -18377,13 +18416,13 @@
       </p:sp>
       <p:sp>
         <p:nvSpPr>
-          <p:cNvPr id="17" name="Text 14"/>
-          <p:cNvSpPr/>
-          <p:nvPr/>
-        </p:nvSpPr>
-        <p:spPr>
-          <a:xfrm>
-            <a:off x="3172968" y="5925312"/>
+          <p:cNvPr id="18" name="Text 15"/>
+          <p:cNvSpPr/>
+          <p:nvPr/>
+        </p:nvSpPr>
+        <p:spPr>
+          <a:xfrm>
+            <a:off x="4690872" y="5925312"/>
             <a:ext cx="1517904" cy="347472"/>
           </a:xfrm>
           <a:prstGeom prst="rect">
@@ -18416,13 +18455,13 @@
       </p:sp>
       <p:sp>
         <p:nvSpPr>
-          <p:cNvPr id="18" name="Text 15"/>
-          <p:cNvSpPr/>
-          <p:nvPr/>
-        </p:nvSpPr>
-        <p:spPr>
-          <a:xfrm>
-            <a:off x="4690872" y="5925312"/>
+          <p:cNvPr id="19" name="Text 16"/>
+          <p:cNvSpPr/>
+          <p:nvPr/>
+        </p:nvSpPr>
+        <p:spPr>
+          <a:xfrm>
+            <a:off x="6208776" y="5925312"/>
             <a:ext cx="1517904" cy="347472"/>
           </a:xfrm>
           <a:prstGeom prst="rect">
@@ -18448,45 +18487,6 @@
                 <a:cs typeface="Calibri" pitchFamily="34" charset="-120"/>
               </a:rPr>
               <a:t>-5.9%</a:t>
-            </a:r>
-            <a:endParaRPr lang="en-US" sz="1200" dirty="0"/>
-          </a:p>
-        </p:txBody>
-      </p:sp>
-      <p:sp>
-        <p:nvSpPr>
-          <p:cNvPr id="19" name="Text 16"/>
-          <p:cNvSpPr/>
-          <p:nvPr/>
-        </p:nvSpPr>
-        <p:spPr>
-          <a:xfrm>
-            <a:off x="6208776" y="5925312"/>
-            <a:ext cx="1517904" cy="347472"/>
-          </a:xfrm>
-          <a:prstGeom prst="rect">
-            <a:avLst/>
-          </a:prstGeom>
-          <a:noFill/>
-          <a:ln/>
-        </p:spPr>
-        <p:txBody>
-          <a:bodyPr wrap="square" rtlCol="0" anchor="ctr"/>
-          <a:lstStyle/>
-          <a:p>
-            <a:pPr algn="ctr" indent="0" marL="0">
-              <a:buNone/>
-            </a:pPr>
-            <a:r>
-              <a:rPr lang="en-US" sz="1200" b="1" dirty="0">
-                <a:solidFill>
-                  <a:srgbClr val="718096"/>
-                </a:solidFill>
-                <a:latin typeface="Calibri" pitchFamily="34" charset="0"/>
-                <a:ea typeface="Calibri" pitchFamily="34" charset="-122"/>
-                <a:cs typeface="Calibri" pitchFamily="34" charset="-120"/>
-              </a:rPr>
-              <a:t>—</a:t>
             </a:r>
             <a:endParaRPr lang="en-US" sz="1200" dirty="0"/>
           </a:p>
@@ -18582,7 +18582,7 @@
                 <a:ea typeface="Century Gothic" pitchFamily="34" charset="-122"/>
                 <a:cs typeface="Century Gothic" pitchFamily="34" charset="-120"/>
               </a:rPr>
-              <a:t>$7,114,864</a:t>
+              <a:t>$12,138,549</a:t>
             </a:r>
             <a:endParaRPr lang="en-US" sz="2600" dirty="0"/>
           </a:p>
@@ -18717,7 +18717,7 @@
                 <a:ea typeface="Century Gothic" pitchFamily="34" charset="-122"/>
                 <a:cs typeface="Century Gothic" pitchFamily="34" charset="-120"/>
               </a:rPr>
-              <a:t>-0.8%</a:t>
+              <a:t>-4.3%</a:t>
             </a:r>
             <a:endParaRPr lang="en-US" sz="2600" dirty="0"/>
           </a:p>
@@ -18884,7 +18884,7 @@
                 <a:ea typeface="Calibri" pitchFamily="34" charset="-122"/>
                 <a:cs typeface="Calibri" pitchFamily="34" charset="-120"/>
               </a:rPr>
-              <a:t>Total loan book: $7,114,864 (-0.8% vs prior month).</a:t>
+              <a:t>Total loan book: $12,138,549 (-4.3% vs prior month).</a:t>
             </a:r>
             <a:endParaRPr lang="en-US" sz="1200" dirty="0"/>
           </a:p>
@@ -18901,7 +18901,7 @@
                 <a:ea typeface="Calibri" pitchFamily="34" charset="-122"/>
                 <a:cs typeface="Calibri" pitchFamily="34" charset="-120"/>
               </a:rPr>
-              <a:t>Kenya has the largest loan book ($4,041,137).</a:t>
+              <a:t>Tanzania has the largest loan book ($5,023,684).</a:t>
             </a:r>
             <a:endParaRPr lang="en-US" sz="1200" dirty="0"/>
           </a:p>
@@ -19533,280 +19533,6 @@
                           <a:ea typeface="Century Gothic" pitchFamily="34" charset="-122"/>
                           <a:cs typeface="Century Gothic" pitchFamily="34" charset="-120"/>
                         </a:rPr>
-                        <a:t>Tanzania</a:t>
-                      </a:r>
-                      <a:endParaRPr lang="en-US" sz="1200" dirty="0">
-                        <a:latin typeface="Century Gothic" charset="0"/>
-                        <a:ea typeface="Century Gothic" charset="0"/>
-                        <a:cs typeface="Century Gothic" charset="0"/>
-                      </a:endParaRPr>
-                    </a:p>
-                  </a:txBody>
-                  <a:tcPr marL="91440" marR="91440" marT="45720" marB="45720" anchor="ctr">
-                    <a:lnL w="6350" cap="flat" cmpd="sng" algn="ctr">
-                      <a:solidFill>
-                        <a:srgbClr val="D6CFC4"/>
-                      </a:solidFill>
-                      <a:prstDash val="solid"/>
-                      <a:round/>
-                      <a:headEnd type="none" w="med" len="med"/>
-                      <a:tailEnd type="none" w="med" len="med"/>
-                    </a:lnL>
-                    <a:lnR w="6350" cap="flat" cmpd="sng" algn="ctr">
-                      <a:solidFill>
-                        <a:srgbClr val="D6CFC4"/>
-                      </a:solidFill>
-                      <a:prstDash val="solid"/>
-                      <a:round/>
-                      <a:headEnd type="none" w="med" len="med"/>
-                      <a:tailEnd type="none" w="med" len="med"/>
-                    </a:lnR>
-                    <a:lnT w="6350" cap="flat" cmpd="sng" algn="ctr">
-                      <a:solidFill>
-                        <a:srgbClr val="D6CFC4"/>
-                      </a:solidFill>
-                      <a:prstDash val="solid"/>
-                      <a:round/>
-                      <a:headEnd type="none" w="med" len="med"/>
-                      <a:tailEnd type="none" w="med" len="med"/>
-                    </a:lnT>
-                    <a:lnB w="6350" cap="flat" cmpd="sng" algn="ctr">
-                      <a:solidFill>
-                        <a:srgbClr val="D6CFC4"/>
-                      </a:solidFill>
-                      <a:prstDash val="solid"/>
-                      <a:round/>
-                      <a:headEnd type="none" w="med" len="med"/>
-                      <a:tailEnd type="none" w="med" len="med"/>
-                    </a:lnB>
-                    <a:solidFill>
-                      <a:srgbClr val="FFFFFF"/>
-                    </a:solidFill>
-                  </a:tcPr>
-                </a:tc>
-                <a:tc>
-                  <a:txBody>
-                    <a:bodyPr/>
-                    <a:lstStyle/>
-                    <a:p>
-                      <a:pPr algn="ctr" indent="0" marL="0">
-                        <a:buNone/>
-                      </a:pPr>
-                      <a:r>
-                        <a:rPr lang="en-US" sz="1200" dirty="0">
-                          <a:solidFill>
-                            <a:srgbClr val="2D2A26"/>
-                          </a:solidFill>
-                          <a:latin typeface="Calibri" pitchFamily="34" charset="0"/>
-                          <a:ea typeface="Calibri" pitchFamily="34" charset="-122"/>
-                          <a:cs typeface="Calibri" pitchFamily="34" charset="-120"/>
-                        </a:rPr>
-                        <a:t>—</a:t>
-                      </a:r>
-                      <a:endParaRPr lang="en-US" sz="1200" dirty="0">
-                        <a:latin typeface="Calibri" charset="0"/>
-                        <a:ea typeface="Calibri" charset="0"/>
-                        <a:cs typeface="Calibri" charset="0"/>
-                      </a:endParaRPr>
-                    </a:p>
-                  </a:txBody>
-                  <a:tcPr marL="91440" marR="91440" marT="45720" marB="45720" anchor="ctr">
-                    <a:lnL w="6350" cap="flat" cmpd="sng" algn="ctr">
-                      <a:solidFill>
-                        <a:srgbClr val="D6CFC4"/>
-                      </a:solidFill>
-                      <a:prstDash val="solid"/>
-                      <a:round/>
-                      <a:headEnd type="none" w="med" len="med"/>
-                      <a:tailEnd type="none" w="med" len="med"/>
-                    </a:lnL>
-                    <a:lnR w="6350" cap="flat" cmpd="sng" algn="ctr">
-                      <a:solidFill>
-                        <a:srgbClr val="D6CFC4"/>
-                      </a:solidFill>
-                      <a:prstDash val="solid"/>
-                      <a:round/>
-                      <a:headEnd type="none" w="med" len="med"/>
-                      <a:tailEnd type="none" w="med" len="med"/>
-                    </a:lnR>
-                    <a:lnT w="6350" cap="flat" cmpd="sng" algn="ctr">
-                      <a:solidFill>
-                        <a:srgbClr val="D6CFC4"/>
-                      </a:solidFill>
-                      <a:prstDash val="solid"/>
-                      <a:round/>
-                      <a:headEnd type="none" w="med" len="med"/>
-                      <a:tailEnd type="none" w="med" len="med"/>
-                    </a:lnT>
-                    <a:lnB w="6350" cap="flat" cmpd="sng" algn="ctr">
-                      <a:solidFill>
-                        <a:srgbClr val="D6CFC4"/>
-                      </a:solidFill>
-                      <a:prstDash val="solid"/>
-                      <a:round/>
-                      <a:headEnd type="none" w="med" len="med"/>
-                      <a:tailEnd type="none" w="med" len="med"/>
-                    </a:lnB>
-                    <a:solidFill>
-                      <a:srgbClr val="FFFFFF"/>
-                    </a:solidFill>
-                  </a:tcPr>
-                </a:tc>
-                <a:tc>
-                  <a:txBody>
-                    <a:bodyPr/>
-                    <a:lstStyle/>
-                    <a:p>
-                      <a:pPr algn="ctr" indent="0" marL="0">
-                        <a:buNone/>
-                      </a:pPr>
-                      <a:r>
-                        <a:rPr lang="en-US" sz="1200" dirty="0">
-                          <a:solidFill>
-                            <a:srgbClr val="2D2A26"/>
-                          </a:solidFill>
-                          <a:latin typeface="Calibri" pitchFamily="34" charset="0"/>
-                          <a:ea typeface="Calibri" pitchFamily="34" charset="-122"/>
-                          <a:cs typeface="Calibri" pitchFamily="34" charset="-120"/>
-                        </a:rPr>
-                        <a:t>—</a:t>
-                      </a:r>
-                      <a:endParaRPr lang="en-US" sz="1200" dirty="0">
-                        <a:latin typeface="Calibri" charset="0"/>
-                        <a:ea typeface="Calibri" charset="0"/>
-                        <a:cs typeface="Calibri" charset="0"/>
-                      </a:endParaRPr>
-                    </a:p>
-                  </a:txBody>
-                  <a:tcPr marL="91440" marR="91440" marT="45720" marB="45720" anchor="ctr">
-                    <a:lnL w="6350" cap="flat" cmpd="sng" algn="ctr">
-                      <a:solidFill>
-                        <a:srgbClr val="D6CFC4"/>
-                      </a:solidFill>
-                      <a:prstDash val="solid"/>
-                      <a:round/>
-                      <a:headEnd type="none" w="med" len="med"/>
-                      <a:tailEnd type="none" w="med" len="med"/>
-                    </a:lnL>
-                    <a:lnR w="6350" cap="flat" cmpd="sng" algn="ctr">
-                      <a:solidFill>
-                        <a:srgbClr val="D6CFC4"/>
-                      </a:solidFill>
-                      <a:prstDash val="solid"/>
-                      <a:round/>
-                      <a:headEnd type="none" w="med" len="med"/>
-                      <a:tailEnd type="none" w="med" len="med"/>
-                    </a:lnR>
-                    <a:lnT w="6350" cap="flat" cmpd="sng" algn="ctr">
-                      <a:solidFill>
-                        <a:srgbClr val="D6CFC4"/>
-                      </a:solidFill>
-                      <a:prstDash val="solid"/>
-                      <a:round/>
-                      <a:headEnd type="none" w="med" len="med"/>
-                      <a:tailEnd type="none" w="med" len="med"/>
-                    </a:lnT>
-                    <a:lnB w="6350" cap="flat" cmpd="sng" algn="ctr">
-                      <a:solidFill>
-                        <a:srgbClr val="D6CFC4"/>
-                      </a:solidFill>
-                      <a:prstDash val="solid"/>
-                      <a:round/>
-                      <a:headEnd type="none" w="med" len="med"/>
-                      <a:tailEnd type="none" w="med" len="med"/>
-                    </a:lnB>
-                    <a:solidFill>
-                      <a:srgbClr val="FFFFFF"/>
-                    </a:solidFill>
-                  </a:tcPr>
-                </a:tc>
-                <a:tc>
-                  <a:txBody>
-                    <a:bodyPr/>
-                    <a:lstStyle/>
-                    <a:p>
-                      <a:pPr algn="ctr" indent="0" marL="0">
-                        <a:buNone/>
-                      </a:pPr>
-                      <a:r>
-                        <a:rPr lang="en-US" sz="1200" dirty="0">
-                          <a:solidFill>
-                            <a:srgbClr val="718096"/>
-                          </a:solidFill>
-                          <a:latin typeface="Calibri" pitchFamily="34" charset="0"/>
-                          <a:ea typeface="Calibri" pitchFamily="34" charset="-122"/>
-                          <a:cs typeface="Calibri" pitchFamily="34" charset="-120"/>
-                        </a:rPr>
-                        <a:t>—</a:t>
-                      </a:r>
-                      <a:endParaRPr lang="en-US" sz="1200" dirty="0">
-                        <a:latin typeface="Calibri" charset="0"/>
-                        <a:ea typeface="Calibri" charset="0"/>
-                        <a:cs typeface="Calibri" charset="0"/>
-                      </a:endParaRPr>
-                    </a:p>
-                  </a:txBody>
-                  <a:tcPr marL="91440" marR="91440" marT="45720" marB="45720" anchor="ctr">
-                    <a:lnL w="6350" cap="flat" cmpd="sng" algn="ctr">
-                      <a:solidFill>
-                        <a:srgbClr val="D6CFC4"/>
-                      </a:solidFill>
-                      <a:prstDash val="solid"/>
-                      <a:round/>
-                      <a:headEnd type="none" w="med" len="med"/>
-                      <a:tailEnd type="none" w="med" len="med"/>
-                    </a:lnL>
-                    <a:lnR w="6350" cap="flat" cmpd="sng" algn="ctr">
-                      <a:solidFill>
-                        <a:srgbClr val="D6CFC4"/>
-                      </a:solidFill>
-                      <a:prstDash val="solid"/>
-                      <a:round/>
-                      <a:headEnd type="none" w="med" len="med"/>
-                      <a:tailEnd type="none" w="med" len="med"/>
-                    </a:lnR>
-                    <a:lnT w="6350" cap="flat" cmpd="sng" algn="ctr">
-                      <a:solidFill>
-                        <a:srgbClr val="D6CFC4"/>
-                      </a:solidFill>
-                      <a:prstDash val="solid"/>
-                      <a:round/>
-                      <a:headEnd type="none" w="med" len="med"/>
-                      <a:tailEnd type="none" w="med" len="med"/>
-                    </a:lnT>
-                    <a:lnB w="6350" cap="flat" cmpd="sng" algn="ctr">
-                      <a:solidFill>
-                        <a:srgbClr val="D6CFC4"/>
-                      </a:solidFill>
-                      <a:prstDash val="solid"/>
-                      <a:round/>
-                      <a:headEnd type="none" w="med" len="med"/>
-                      <a:tailEnd type="none" w="med" len="med"/>
-                    </a:lnB>
-                    <a:solidFill>
-                      <a:srgbClr val="FFFFFF"/>
-                    </a:solidFill>
-                  </a:tcPr>
-                </a:tc>
-              </a:tr>
-              <a:tr h="384048">
-                <a:tc>
-                  <a:txBody>
-                    <a:bodyPr/>
-                    <a:lstStyle/>
-                    <a:p>
-                      <a:pPr algn="l" indent="0" marL="0">
-                        <a:buNone/>
-                      </a:pPr>
-                      <a:r>
-                        <a:rPr lang="en-US" sz="1200" b="1" dirty="0">
-                          <a:solidFill>
-                            <a:srgbClr val="2D2A26"/>
-                          </a:solidFill>
-                          <a:latin typeface="Century Gothic" pitchFamily="34" charset="0"/>
-                          <a:ea typeface="Century Gothic" pitchFamily="34" charset="-122"/>
-                          <a:cs typeface="Century Gothic" pitchFamily="34" charset="-120"/>
-                        </a:rPr>
                         <a:t>Sierra Leone</a:t>
                       </a:r>
                       <a:endParaRPr lang="en-US" sz="1200" dirty="0">
@@ -19854,7 +19580,7 @@
                       <a:tailEnd type="none" w="med" len="med"/>
                     </a:lnB>
                     <a:solidFill>
-                      <a:srgbClr val="FFF9D9"/>
+                      <a:srgbClr val="FFFFFF"/>
                     </a:solidFill>
                   </a:tcPr>
                 </a:tc>
@@ -19922,6 +19648,212 @@
                       <a:tailEnd type="none" w="med" len="med"/>
                     </a:lnB>
                     <a:solidFill>
+                      <a:srgbClr val="FFFFFF"/>
+                    </a:solidFill>
+                  </a:tcPr>
+                </a:tc>
+                <a:tc>
+                  <a:txBody>
+                    <a:bodyPr/>
+                    <a:lstStyle/>
+                    <a:p>
+                      <a:pPr algn="ctr" indent="0" marL="0">
+                        <a:buNone/>
+                      </a:pPr>
+                      <a:r>
+                        <a:rPr lang="en-US" sz="1200" dirty="0">
+                          <a:solidFill>
+                            <a:srgbClr val="2D2A26"/>
+                          </a:solidFill>
+                          <a:latin typeface="Calibri" pitchFamily="34" charset="0"/>
+                          <a:ea typeface="Calibri" pitchFamily="34" charset="-122"/>
+                          <a:cs typeface="Calibri" pitchFamily="34" charset="-120"/>
+                        </a:rPr>
+                        <a:t>1.6%</a:t>
+                      </a:r>
+                      <a:endParaRPr lang="en-US" sz="1200" dirty="0">
+                        <a:latin typeface="Calibri" charset="0"/>
+                        <a:ea typeface="Calibri" charset="0"/>
+                        <a:cs typeface="Calibri" charset="0"/>
+                      </a:endParaRPr>
+                    </a:p>
+                  </a:txBody>
+                  <a:tcPr marL="91440" marR="91440" marT="45720" marB="45720" anchor="ctr">
+                    <a:lnL w="6350" cap="flat" cmpd="sng" algn="ctr">
+                      <a:solidFill>
+                        <a:srgbClr val="D6CFC4"/>
+                      </a:solidFill>
+                      <a:prstDash val="solid"/>
+                      <a:round/>
+                      <a:headEnd type="none" w="med" len="med"/>
+                      <a:tailEnd type="none" w="med" len="med"/>
+                    </a:lnL>
+                    <a:lnR w="6350" cap="flat" cmpd="sng" algn="ctr">
+                      <a:solidFill>
+                        <a:srgbClr val="D6CFC4"/>
+                      </a:solidFill>
+                      <a:prstDash val="solid"/>
+                      <a:round/>
+                      <a:headEnd type="none" w="med" len="med"/>
+                      <a:tailEnd type="none" w="med" len="med"/>
+                    </a:lnR>
+                    <a:lnT w="6350" cap="flat" cmpd="sng" algn="ctr">
+                      <a:solidFill>
+                        <a:srgbClr val="D6CFC4"/>
+                      </a:solidFill>
+                      <a:prstDash val="solid"/>
+                      <a:round/>
+                      <a:headEnd type="none" w="med" len="med"/>
+                      <a:tailEnd type="none" w="med" len="med"/>
+                    </a:lnT>
+                    <a:lnB w="6350" cap="flat" cmpd="sng" algn="ctr">
+                      <a:solidFill>
+                        <a:srgbClr val="D6CFC4"/>
+                      </a:solidFill>
+                      <a:prstDash val="solid"/>
+                      <a:round/>
+                      <a:headEnd type="none" w="med" len="med"/>
+                      <a:tailEnd type="none" w="med" len="med"/>
+                    </a:lnB>
+                    <a:solidFill>
+                      <a:srgbClr val="FFFFFF"/>
+                    </a:solidFill>
+                  </a:tcPr>
+                </a:tc>
+                <a:tc>
+                  <a:txBody>
+                    <a:bodyPr/>
+                    <a:lstStyle/>
+                    <a:p>
+                      <a:pPr algn="ctr" indent="0" marL="0">
+                        <a:buNone/>
+                      </a:pPr>
+                      <a:r>
+                        <a:rPr lang="en-US" sz="1200" dirty="0">
+                          <a:solidFill>
+                            <a:srgbClr val="C0392B"/>
+                          </a:solidFill>
+                          <a:latin typeface="Calibri" pitchFamily="34" charset="0"/>
+                          <a:ea typeface="Calibri" pitchFamily="34" charset="-122"/>
+                          <a:cs typeface="Calibri" pitchFamily="34" charset="-120"/>
+                        </a:rPr>
+                        <a:t>↑</a:t>
+                      </a:r>
+                      <a:endParaRPr lang="en-US" sz="1200" dirty="0">
+                        <a:latin typeface="Calibri" charset="0"/>
+                        <a:ea typeface="Calibri" charset="0"/>
+                        <a:cs typeface="Calibri" charset="0"/>
+                      </a:endParaRPr>
+                    </a:p>
+                  </a:txBody>
+                  <a:tcPr marL="91440" marR="91440" marT="45720" marB="45720" anchor="ctr">
+                    <a:lnL w="6350" cap="flat" cmpd="sng" algn="ctr">
+                      <a:solidFill>
+                        <a:srgbClr val="D6CFC4"/>
+                      </a:solidFill>
+                      <a:prstDash val="solid"/>
+                      <a:round/>
+                      <a:headEnd type="none" w="med" len="med"/>
+                      <a:tailEnd type="none" w="med" len="med"/>
+                    </a:lnL>
+                    <a:lnR w="6350" cap="flat" cmpd="sng" algn="ctr">
+                      <a:solidFill>
+                        <a:srgbClr val="D6CFC4"/>
+                      </a:solidFill>
+                      <a:prstDash val="solid"/>
+                      <a:round/>
+                      <a:headEnd type="none" w="med" len="med"/>
+                      <a:tailEnd type="none" w="med" len="med"/>
+                    </a:lnR>
+                    <a:lnT w="6350" cap="flat" cmpd="sng" algn="ctr">
+                      <a:solidFill>
+                        <a:srgbClr val="D6CFC4"/>
+                      </a:solidFill>
+                      <a:prstDash val="solid"/>
+                      <a:round/>
+                      <a:headEnd type="none" w="med" len="med"/>
+                      <a:tailEnd type="none" w="med" len="med"/>
+                    </a:lnT>
+                    <a:lnB w="6350" cap="flat" cmpd="sng" algn="ctr">
+                      <a:solidFill>
+                        <a:srgbClr val="D6CFC4"/>
+                      </a:solidFill>
+                      <a:prstDash val="solid"/>
+                      <a:round/>
+                      <a:headEnd type="none" w="med" len="med"/>
+                      <a:tailEnd type="none" w="med" len="med"/>
+                    </a:lnB>
+                    <a:solidFill>
+                      <a:srgbClr val="FFFFFF"/>
+                    </a:solidFill>
+                  </a:tcPr>
+                </a:tc>
+              </a:tr>
+              <a:tr h="384048">
+                <a:tc>
+                  <a:txBody>
+                    <a:bodyPr/>
+                    <a:lstStyle/>
+                    <a:p>
+                      <a:pPr algn="l" indent="0" marL="0">
+                        <a:buNone/>
+                      </a:pPr>
+                      <a:r>
+                        <a:rPr lang="en-US" sz="1200" b="1" dirty="0">
+                          <a:solidFill>
+                            <a:srgbClr val="2D2A26"/>
+                          </a:solidFill>
+                          <a:latin typeface="Century Gothic" pitchFamily="34" charset="0"/>
+                          <a:ea typeface="Century Gothic" pitchFamily="34" charset="-122"/>
+                          <a:cs typeface="Century Gothic" pitchFamily="34" charset="-120"/>
+                        </a:rPr>
+                        <a:t>Kenya</a:t>
+                      </a:r>
+                      <a:endParaRPr lang="en-US" sz="1200" dirty="0">
+                        <a:latin typeface="Century Gothic" charset="0"/>
+                        <a:ea typeface="Century Gothic" charset="0"/>
+                        <a:cs typeface="Century Gothic" charset="0"/>
+                      </a:endParaRPr>
+                    </a:p>
+                  </a:txBody>
+                  <a:tcPr marL="91440" marR="91440" marT="45720" marB="45720" anchor="ctr">
+                    <a:lnL w="6350" cap="flat" cmpd="sng" algn="ctr">
+                      <a:solidFill>
+                        <a:srgbClr val="D6CFC4"/>
+                      </a:solidFill>
+                      <a:prstDash val="solid"/>
+                      <a:round/>
+                      <a:headEnd type="none" w="med" len="med"/>
+                      <a:tailEnd type="none" w="med" len="med"/>
+                    </a:lnL>
+                    <a:lnR w="6350" cap="flat" cmpd="sng" algn="ctr">
+                      <a:solidFill>
+                        <a:srgbClr val="D6CFC4"/>
+                      </a:solidFill>
+                      <a:prstDash val="solid"/>
+                      <a:round/>
+                      <a:headEnd type="none" w="med" len="med"/>
+                      <a:tailEnd type="none" w="med" len="med"/>
+                    </a:lnR>
+                    <a:lnT w="6350" cap="flat" cmpd="sng" algn="ctr">
+                      <a:solidFill>
+                        <a:srgbClr val="D6CFC4"/>
+                      </a:solidFill>
+                      <a:prstDash val="solid"/>
+                      <a:round/>
+                      <a:headEnd type="none" w="med" len="med"/>
+                      <a:tailEnd type="none" w="med" len="med"/>
+                    </a:lnT>
+                    <a:lnB w="6350" cap="flat" cmpd="sng" algn="ctr">
+                      <a:solidFill>
+                        <a:srgbClr val="D6CFC4"/>
+                      </a:solidFill>
+                      <a:prstDash val="solid"/>
+                      <a:round/>
+                      <a:headEnd type="none" w="med" len="med"/>
+                      <a:tailEnd type="none" w="med" len="med"/>
+                    </a:lnB>
+                    <a:solidFill>
                       <a:srgbClr val="FFF9D9"/>
                     </a:solidFill>
                   </a:tcPr>
@@ -19943,7 +19875,75 @@
                           <a:ea typeface="Calibri" pitchFamily="34" charset="-122"/>
                           <a:cs typeface="Calibri" pitchFamily="34" charset="-120"/>
                         </a:rPr>
-                        <a:t>1.6%</a:t>
+                        <a:t>7.6%</a:t>
+                      </a:r>
+                      <a:endParaRPr lang="en-US" sz="1200" dirty="0">
+                        <a:latin typeface="Calibri" charset="0"/>
+                        <a:ea typeface="Calibri" charset="0"/>
+                        <a:cs typeface="Calibri" charset="0"/>
+                      </a:endParaRPr>
+                    </a:p>
+                  </a:txBody>
+                  <a:tcPr marL="91440" marR="91440" marT="45720" marB="45720" anchor="ctr">
+                    <a:lnL w="6350" cap="flat" cmpd="sng" algn="ctr">
+                      <a:solidFill>
+                        <a:srgbClr val="D6CFC4"/>
+                      </a:solidFill>
+                      <a:prstDash val="solid"/>
+                      <a:round/>
+                      <a:headEnd type="none" w="med" len="med"/>
+                      <a:tailEnd type="none" w="med" len="med"/>
+                    </a:lnL>
+                    <a:lnR w="6350" cap="flat" cmpd="sng" algn="ctr">
+                      <a:solidFill>
+                        <a:srgbClr val="D6CFC4"/>
+                      </a:solidFill>
+                      <a:prstDash val="solid"/>
+                      <a:round/>
+                      <a:headEnd type="none" w="med" len="med"/>
+                      <a:tailEnd type="none" w="med" len="med"/>
+                    </a:lnR>
+                    <a:lnT w="6350" cap="flat" cmpd="sng" algn="ctr">
+                      <a:solidFill>
+                        <a:srgbClr val="D6CFC4"/>
+                      </a:solidFill>
+                      <a:prstDash val="solid"/>
+                      <a:round/>
+                      <a:headEnd type="none" w="med" len="med"/>
+                      <a:tailEnd type="none" w="med" len="med"/>
+                    </a:lnT>
+                    <a:lnB w="6350" cap="flat" cmpd="sng" algn="ctr">
+                      <a:solidFill>
+                        <a:srgbClr val="D6CFC4"/>
+                      </a:solidFill>
+                      <a:prstDash val="solid"/>
+                      <a:round/>
+                      <a:headEnd type="none" w="med" len="med"/>
+                      <a:tailEnd type="none" w="med" len="med"/>
+                    </a:lnB>
+                    <a:solidFill>
+                      <a:srgbClr val="FFF9D9"/>
+                    </a:solidFill>
+                  </a:tcPr>
+                </a:tc>
+                <a:tc>
+                  <a:txBody>
+                    <a:bodyPr/>
+                    <a:lstStyle/>
+                    <a:p>
+                      <a:pPr algn="ctr" indent="0" marL="0">
+                        <a:buNone/>
+                      </a:pPr>
+                      <a:r>
+                        <a:rPr lang="en-US" sz="1200" dirty="0">
+                          <a:solidFill>
+                            <a:srgbClr val="2D2A26"/>
+                          </a:solidFill>
+                          <a:latin typeface="Calibri" pitchFamily="34" charset="0"/>
+                          <a:ea typeface="Calibri" pitchFamily="34" charset="-122"/>
+                          <a:cs typeface="Calibri" pitchFamily="34" charset="-120"/>
+                        </a:rPr>
+                        <a:t>8.0%</a:t>
                       </a:r>
                       <a:endParaRPr lang="en-US" sz="1200" dirty="0">
                         <a:latin typeface="Calibri" charset="0"/>
@@ -20081,7 +20081,7 @@
                           <a:ea typeface="Century Gothic" pitchFamily="34" charset="-122"/>
                           <a:cs typeface="Century Gothic" pitchFamily="34" charset="-120"/>
                         </a:rPr>
-                        <a:t>Kenya</a:t>
+                        <a:t>Tanzania</a:t>
                       </a:r>
                       <a:endParaRPr lang="en-US" sz="1200" dirty="0">
                         <a:latin typeface="Century Gothic" charset="0"/>
@@ -20149,7 +20149,7 @@
                           <a:ea typeface="Calibri" pitchFamily="34" charset="-122"/>
                           <a:cs typeface="Calibri" pitchFamily="34" charset="-120"/>
                         </a:rPr>
-                        <a:t>7.6%</a:t>
+                        <a:t>8.7%</a:t>
                       </a:r>
                       <a:endParaRPr lang="en-US" sz="1200" dirty="0">
                         <a:latin typeface="Calibri" charset="0"/>
@@ -20217,7 +20217,7 @@
                           <a:ea typeface="Calibri" pitchFamily="34" charset="-122"/>
                           <a:cs typeface="Calibri" pitchFamily="34" charset="-120"/>
                         </a:rPr>
-                        <a:t>8.0%</a:t>
+                        <a:t>9.7%</a:t>
                       </a:r>
                       <a:endParaRPr lang="en-US" sz="1200" dirty="0">
                         <a:latin typeface="Calibri" charset="0"/>
@@ -20971,7 +20971,7 @@
                           <a:ea typeface="Calibri" pitchFamily="34" charset="-122"/>
                           <a:cs typeface="Calibri" pitchFamily="34" charset="-120"/>
                         </a:rPr>
-                        <a:t>7.8%</a:t>
+                        <a:t>8.2%</a:t>
                       </a:r>
                       <a:endParaRPr lang="en-US" sz="1200" dirty="0">
                         <a:latin typeface="Calibri" charset="0"/>
@@ -21039,7 +21039,7 @@
                           <a:ea typeface="Calibri" pitchFamily="34" charset="-122"/>
                           <a:cs typeface="Calibri" pitchFamily="34" charset="-120"/>
                         </a:rPr>
-                        <a:t>8.2%</a:t>
+                        <a:t>8.8%</a:t>
                       </a:r>
                       <a:endParaRPr lang="en-US" sz="1200" dirty="0">
                         <a:latin typeface="Calibri" charset="0"/>
@@ -21789,280 +21789,6 @@
                           <a:ea typeface="Century Gothic" pitchFamily="34" charset="-122"/>
                           <a:cs typeface="Century Gothic" pitchFamily="34" charset="-120"/>
                         </a:rPr>
-                        <a:t>Tanzania</a:t>
-                      </a:r>
-                      <a:endParaRPr lang="en-US" sz="1200" dirty="0">
-                        <a:latin typeface="Century Gothic" charset="0"/>
-                        <a:ea typeface="Century Gothic" charset="0"/>
-                        <a:cs typeface="Century Gothic" charset="0"/>
-                      </a:endParaRPr>
-                    </a:p>
-                  </a:txBody>
-                  <a:tcPr marL="91440" marR="91440" marT="45720" marB="45720" anchor="ctr">
-                    <a:lnL w="6350" cap="flat" cmpd="sng" algn="ctr">
-                      <a:solidFill>
-                        <a:srgbClr val="D6CFC4"/>
-                      </a:solidFill>
-                      <a:prstDash val="solid"/>
-                      <a:round/>
-                      <a:headEnd type="none" w="med" len="med"/>
-                      <a:tailEnd type="none" w="med" len="med"/>
-                    </a:lnL>
-                    <a:lnR w="6350" cap="flat" cmpd="sng" algn="ctr">
-                      <a:solidFill>
-                        <a:srgbClr val="D6CFC4"/>
-                      </a:solidFill>
-                      <a:prstDash val="solid"/>
-                      <a:round/>
-                      <a:headEnd type="none" w="med" len="med"/>
-                      <a:tailEnd type="none" w="med" len="med"/>
-                    </a:lnR>
-                    <a:lnT w="6350" cap="flat" cmpd="sng" algn="ctr">
-                      <a:solidFill>
-                        <a:srgbClr val="D6CFC4"/>
-                      </a:solidFill>
-                      <a:prstDash val="solid"/>
-                      <a:round/>
-                      <a:headEnd type="none" w="med" len="med"/>
-                      <a:tailEnd type="none" w="med" len="med"/>
-                    </a:lnT>
-                    <a:lnB w="6350" cap="flat" cmpd="sng" algn="ctr">
-                      <a:solidFill>
-                        <a:srgbClr val="D6CFC4"/>
-                      </a:solidFill>
-                      <a:prstDash val="solid"/>
-                      <a:round/>
-                      <a:headEnd type="none" w="med" len="med"/>
-                      <a:tailEnd type="none" w="med" len="med"/>
-                    </a:lnB>
-                    <a:solidFill>
-                      <a:srgbClr val="FFFFFF"/>
-                    </a:solidFill>
-                  </a:tcPr>
-                </a:tc>
-                <a:tc>
-                  <a:txBody>
-                    <a:bodyPr/>
-                    <a:lstStyle/>
-                    <a:p>
-                      <a:pPr algn="ctr" indent="0" marL="0">
-                        <a:buNone/>
-                      </a:pPr>
-                      <a:r>
-                        <a:rPr lang="en-US" sz="1200" dirty="0">
-                          <a:solidFill>
-                            <a:srgbClr val="2D2A26"/>
-                          </a:solidFill>
-                          <a:latin typeface="Calibri" pitchFamily="34" charset="0"/>
-                          <a:ea typeface="Calibri" pitchFamily="34" charset="-122"/>
-                          <a:cs typeface="Calibri" pitchFamily="34" charset="-120"/>
-                        </a:rPr>
-                        <a:t>—</a:t>
-                      </a:r>
-                      <a:endParaRPr lang="en-US" sz="1200" dirty="0">
-                        <a:latin typeface="Calibri" charset="0"/>
-                        <a:ea typeface="Calibri" charset="0"/>
-                        <a:cs typeface="Calibri" charset="0"/>
-                      </a:endParaRPr>
-                    </a:p>
-                  </a:txBody>
-                  <a:tcPr marL="91440" marR="91440" marT="45720" marB="45720" anchor="ctr">
-                    <a:lnL w="6350" cap="flat" cmpd="sng" algn="ctr">
-                      <a:solidFill>
-                        <a:srgbClr val="D6CFC4"/>
-                      </a:solidFill>
-                      <a:prstDash val="solid"/>
-                      <a:round/>
-                      <a:headEnd type="none" w="med" len="med"/>
-                      <a:tailEnd type="none" w="med" len="med"/>
-                    </a:lnL>
-                    <a:lnR w="6350" cap="flat" cmpd="sng" algn="ctr">
-                      <a:solidFill>
-                        <a:srgbClr val="D6CFC4"/>
-                      </a:solidFill>
-                      <a:prstDash val="solid"/>
-                      <a:round/>
-                      <a:headEnd type="none" w="med" len="med"/>
-                      <a:tailEnd type="none" w="med" len="med"/>
-                    </a:lnR>
-                    <a:lnT w="6350" cap="flat" cmpd="sng" algn="ctr">
-                      <a:solidFill>
-                        <a:srgbClr val="D6CFC4"/>
-                      </a:solidFill>
-                      <a:prstDash val="solid"/>
-                      <a:round/>
-                      <a:headEnd type="none" w="med" len="med"/>
-                      <a:tailEnd type="none" w="med" len="med"/>
-                    </a:lnT>
-                    <a:lnB w="6350" cap="flat" cmpd="sng" algn="ctr">
-                      <a:solidFill>
-                        <a:srgbClr val="D6CFC4"/>
-                      </a:solidFill>
-                      <a:prstDash val="solid"/>
-                      <a:round/>
-                      <a:headEnd type="none" w="med" len="med"/>
-                      <a:tailEnd type="none" w="med" len="med"/>
-                    </a:lnB>
-                    <a:solidFill>
-                      <a:srgbClr val="FFFFFF"/>
-                    </a:solidFill>
-                  </a:tcPr>
-                </a:tc>
-                <a:tc>
-                  <a:txBody>
-                    <a:bodyPr/>
-                    <a:lstStyle/>
-                    <a:p>
-                      <a:pPr algn="ctr" indent="0" marL="0">
-                        <a:buNone/>
-                      </a:pPr>
-                      <a:r>
-                        <a:rPr lang="en-US" sz="1200" dirty="0">
-                          <a:solidFill>
-                            <a:srgbClr val="2D2A26"/>
-                          </a:solidFill>
-                          <a:latin typeface="Calibri" pitchFamily="34" charset="0"/>
-                          <a:ea typeface="Calibri" pitchFamily="34" charset="-122"/>
-                          <a:cs typeface="Calibri" pitchFamily="34" charset="-120"/>
-                        </a:rPr>
-                        <a:t>—</a:t>
-                      </a:r>
-                      <a:endParaRPr lang="en-US" sz="1200" dirty="0">
-                        <a:latin typeface="Calibri" charset="0"/>
-                        <a:ea typeface="Calibri" charset="0"/>
-                        <a:cs typeface="Calibri" charset="0"/>
-                      </a:endParaRPr>
-                    </a:p>
-                  </a:txBody>
-                  <a:tcPr marL="91440" marR="91440" marT="45720" marB="45720" anchor="ctr">
-                    <a:lnL w="6350" cap="flat" cmpd="sng" algn="ctr">
-                      <a:solidFill>
-                        <a:srgbClr val="D6CFC4"/>
-                      </a:solidFill>
-                      <a:prstDash val="solid"/>
-                      <a:round/>
-                      <a:headEnd type="none" w="med" len="med"/>
-                      <a:tailEnd type="none" w="med" len="med"/>
-                    </a:lnL>
-                    <a:lnR w="6350" cap="flat" cmpd="sng" algn="ctr">
-                      <a:solidFill>
-                        <a:srgbClr val="D6CFC4"/>
-                      </a:solidFill>
-                      <a:prstDash val="solid"/>
-                      <a:round/>
-                      <a:headEnd type="none" w="med" len="med"/>
-                      <a:tailEnd type="none" w="med" len="med"/>
-                    </a:lnR>
-                    <a:lnT w="6350" cap="flat" cmpd="sng" algn="ctr">
-                      <a:solidFill>
-                        <a:srgbClr val="D6CFC4"/>
-                      </a:solidFill>
-                      <a:prstDash val="solid"/>
-                      <a:round/>
-                      <a:headEnd type="none" w="med" len="med"/>
-                      <a:tailEnd type="none" w="med" len="med"/>
-                    </a:lnT>
-                    <a:lnB w="6350" cap="flat" cmpd="sng" algn="ctr">
-                      <a:solidFill>
-                        <a:srgbClr val="D6CFC4"/>
-                      </a:solidFill>
-                      <a:prstDash val="solid"/>
-                      <a:round/>
-                      <a:headEnd type="none" w="med" len="med"/>
-                      <a:tailEnd type="none" w="med" len="med"/>
-                    </a:lnB>
-                    <a:solidFill>
-                      <a:srgbClr val="FFFFFF"/>
-                    </a:solidFill>
-                  </a:tcPr>
-                </a:tc>
-                <a:tc>
-                  <a:txBody>
-                    <a:bodyPr/>
-                    <a:lstStyle/>
-                    <a:p>
-                      <a:pPr algn="ctr" indent="0" marL="0">
-                        <a:buNone/>
-                      </a:pPr>
-                      <a:r>
-                        <a:rPr lang="en-US" sz="1200" dirty="0">
-                          <a:solidFill>
-                            <a:srgbClr val="718096"/>
-                          </a:solidFill>
-                          <a:latin typeface="Calibri" pitchFamily="34" charset="0"/>
-                          <a:ea typeface="Calibri" pitchFamily="34" charset="-122"/>
-                          <a:cs typeface="Calibri" pitchFamily="34" charset="-120"/>
-                        </a:rPr>
-                        <a:t>—</a:t>
-                      </a:r>
-                      <a:endParaRPr lang="en-US" sz="1200" dirty="0">
-                        <a:latin typeface="Calibri" charset="0"/>
-                        <a:ea typeface="Calibri" charset="0"/>
-                        <a:cs typeface="Calibri" charset="0"/>
-                      </a:endParaRPr>
-                    </a:p>
-                  </a:txBody>
-                  <a:tcPr marL="91440" marR="91440" marT="45720" marB="45720" anchor="ctr">
-                    <a:lnL w="6350" cap="flat" cmpd="sng" algn="ctr">
-                      <a:solidFill>
-                        <a:srgbClr val="D6CFC4"/>
-                      </a:solidFill>
-                      <a:prstDash val="solid"/>
-                      <a:round/>
-                      <a:headEnd type="none" w="med" len="med"/>
-                      <a:tailEnd type="none" w="med" len="med"/>
-                    </a:lnL>
-                    <a:lnR w="6350" cap="flat" cmpd="sng" algn="ctr">
-                      <a:solidFill>
-                        <a:srgbClr val="D6CFC4"/>
-                      </a:solidFill>
-                      <a:prstDash val="solid"/>
-                      <a:round/>
-                      <a:headEnd type="none" w="med" len="med"/>
-                      <a:tailEnd type="none" w="med" len="med"/>
-                    </a:lnR>
-                    <a:lnT w="6350" cap="flat" cmpd="sng" algn="ctr">
-                      <a:solidFill>
-                        <a:srgbClr val="D6CFC4"/>
-                      </a:solidFill>
-                      <a:prstDash val="solid"/>
-                      <a:round/>
-                      <a:headEnd type="none" w="med" len="med"/>
-                      <a:tailEnd type="none" w="med" len="med"/>
-                    </a:lnT>
-                    <a:lnB w="6350" cap="flat" cmpd="sng" algn="ctr">
-                      <a:solidFill>
-                        <a:srgbClr val="D6CFC4"/>
-                      </a:solidFill>
-                      <a:prstDash val="solid"/>
-                      <a:round/>
-                      <a:headEnd type="none" w="med" len="med"/>
-                      <a:tailEnd type="none" w="med" len="med"/>
-                    </a:lnB>
-                    <a:solidFill>
-                      <a:srgbClr val="FFFFFF"/>
-                    </a:solidFill>
-                  </a:tcPr>
-                </a:tc>
-              </a:tr>
-              <a:tr h="384048">
-                <a:tc>
-                  <a:txBody>
-                    <a:bodyPr/>
-                    <a:lstStyle/>
-                    <a:p>
-                      <a:pPr algn="l" indent="0" marL="0">
-                        <a:buNone/>
-                      </a:pPr>
-                      <a:r>
-                        <a:rPr lang="en-US" sz="1200" b="1" dirty="0">
-                          <a:solidFill>
-                            <a:srgbClr val="2D2A26"/>
-                          </a:solidFill>
-                          <a:latin typeface="Century Gothic" pitchFamily="34" charset="0"/>
-                          <a:ea typeface="Century Gothic" pitchFamily="34" charset="-122"/>
-                          <a:cs typeface="Century Gothic" pitchFamily="34" charset="-120"/>
-                        </a:rPr>
                         <a:t>Sierra Leone</a:t>
                       </a:r>
                       <a:endParaRPr lang="en-US" sz="1200" dirty="0">
@@ -22110,7 +21836,7 @@
                       <a:tailEnd type="none" w="med" len="med"/>
                     </a:lnB>
                     <a:solidFill>
-                      <a:srgbClr val="FFF9D9"/>
+                      <a:srgbClr val="FFFFFF"/>
                     </a:solidFill>
                   </a:tcPr>
                 </a:tc>
@@ -22178,6 +21904,212 @@
                       <a:tailEnd type="none" w="med" len="med"/>
                     </a:lnB>
                     <a:solidFill>
+                      <a:srgbClr val="FFFFFF"/>
+                    </a:solidFill>
+                  </a:tcPr>
+                </a:tc>
+                <a:tc>
+                  <a:txBody>
+                    <a:bodyPr/>
+                    <a:lstStyle/>
+                    <a:p>
+                      <a:pPr algn="ctr" indent="0" marL="0">
+                        <a:buNone/>
+                      </a:pPr>
+                      <a:r>
+                        <a:rPr lang="en-US" sz="1200" dirty="0">
+                          <a:solidFill>
+                            <a:srgbClr val="2D2A26"/>
+                          </a:solidFill>
+                          <a:latin typeface="Calibri" pitchFamily="34" charset="0"/>
+                          <a:ea typeface="Calibri" pitchFamily="34" charset="-122"/>
+                          <a:cs typeface="Calibri" pitchFamily="34" charset="-120"/>
+                        </a:rPr>
+                        <a:t>1.7%</a:t>
+                      </a:r>
+                      <a:endParaRPr lang="en-US" sz="1200" dirty="0">
+                        <a:latin typeface="Calibri" charset="0"/>
+                        <a:ea typeface="Calibri" charset="0"/>
+                        <a:cs typeface="Calibri" charset="0"/>
+                      </a:endParaRPr>
+                    </a:p>
+                  </a:txBody>
+                  <a:tcPr marL="91440" marR="91440" marT="45720" marB="45720" anchor="ctr">
+                    <a:lnL w="6350" cap="flat" cmpd="sng" algn="ctr">
+                      <a:solidFill>
+                        <a:srgbClr val="D6CFC4"/>
+                      </a:solidFill>
+                      <a:prstDash val="solid"/>
+                      <a:round/>
+                      <a:headEnd type="none" w="med" len="med"/>
+                      <a:tailEnd type="none" w="med" len="med"/>
+                    </a:lnL>
+                    <a:lnR w="6350" cap="flat" cmpd="sng" algn="ctr">
+                      <a:solidFill>
+                        <a:srgbClr val="D6CFC4"/>
+                      </a:solidFill>
+                      <a:prstDash val="solid"/>
+                      <a:round/>
+                      <a:headEnd type="none" w="med" len="med"/>
+                      <a:tailEnd type="none" w="med" len="med"/>
+                    </a:lnR>
+                    <a:lnT w="6350" cap="flat" cmpd="sng" algn="ctr">
+                      <a:solidFill>
+                        <a:srgbClr val="D6CFC4"/>
+                      </a:solidFill>
+                      <a:prstDash val="solid"/>
+                      <a:round/>
+                      <a:headEnd type="none" w="med" len="med"/>
+                      <a:tailEnd type="none" w="med" len="med"/>
+                    </a:lnT>
+                    <a:lnB w="6350" cap="flat" cmpd="sng" algn="ctr">
+                      <a:solidFill>
+                        <a:srgbClr val="D6CFC4"/>
+                      </a:solidFill>
+                      <a:prstDash val="solid"/>
+                      <a:round/>
+                      <a:headEnd type="none" w="med" len="med"/>
+                      <a:tailEnd type="none" w="med" len="med"/>
+                    </a:lnB>
+                    <a:solidFill>
+                      <a:srgbClr val="FFFFFF"/>
+                    </a:solidFill>
+                  </a:tcPr>
+                </a:tc>
+                <a:tc>
+                  <a:txBody>
+                    <a:bodyPr/>
+                    <a:lstStyle/>
+                    <a:p>
+                      <a:pPr algn="ctr" indent="0" marL="0">
+                        <a:buNone/>
+                      </a:pPr>
+                      <a:r>
+                        <a:rPr lang="en-US" sz="1200" dirty="0">
+                          <a:solidFill>
+                            <a:srgbClr val="1A7A6E"/>
+                          </a:solidFill>
+                          <a:latin typeface="Calibri" pitchFamily="34" charset="0"/>
+                          <a:ea typeface="Calibri" pitchFamily="34" charset="-122"/>
+                          <a:cs typeface="Calibri" pitchFamily="34" charset="-120"/>
+                        </a:rPr>
+                        <a:t>↓</a:t>
+                      </a:r>
+                      <a:endParaRPr lang="en-US" sz="1200" dirty="0">
+                        <a:latin typeface="Calibri" charset="0"/>
+                        <a:ea typeface="Calibri" charset="0"/>
+                        <a:cs typeface="Calibri" charset="0"/>
+                      </a:endParaRPr>
+                    </a:p>
+                  </a:txBody>
+                  <a:tcPr marL="91440" marR="91440" marT="45720" marB="45720" anchor="ctr">
+                    <a:lnL w="6350" cap="flat" cmpd="sng" algn="ctr">
+                      <a:solidFill>
+                        <a:srgbClr val="D6CFC4"/>
+                      </a:solidFill>
+                      <a:prstDash val="solid"/>
+                      <a:round/>
+                      <a:headEnd type="none" w="med" len="med"/>
+                      <a:tailEnd type="none" w="med" len="med"/>
+                    </a:lnL>
+                    <a:lnR w="6350" cap="flat" cmpd="sng" algn="ctr">
+                      <a:solidFill>
+                        <a:srgbClr val="D6CFC4"/>
+                      </a:solidFill>
+                      <a:prstDash val="solid"/>
+                      <a:round/>
+                      <a:headEnd type="none" w="med" len="med"/>
+                      <a:tailEnd type="none" w="med" len="med"/>
+                    </a:lnR>
+                    <a:lnT w="6350" cap="flat" cmpd="sng" algn="ctr">
+                      <a:solidFill>
+                        <a:srgbClr val="D6CFC4"/>
+                      </a:solidFill>
+                      <a:prstDash val="solid"/>
+                      <a:round/>
+                      <a:headEnd type="none" w="med" len="med"/>
+                      <a:tailEnd type="none" w="med" len="med"/>
+                    </a:lnT>
+                    <a:lnB w="6350" cap="flat" cmpd="sng" algn="ctr">
+                      <a:solidFill>
+                        <a:srgbClr val="D6CFC4"/>
+                      </a:solidFill>
+                      <a:prstDash val="solid"/>
+                      <a:round/>
+                      <a:headEnd type="none" w="med" len="med"/>
+                      <a:tailEnd type="none" w="med" len="med"/>
+                    </a:lnB>
+                    <a:solidFill>
+                      <a:srgbClr val="FFFFFF"/>
+                    </a:solidFill>
+                  </a:tcPr>
+                </a:tc>
+              </a:tr>
+              <a:tr h="384048">
+                <a:tc>
+                  <a:txBody>
+                    <a:bodyPr/>
+                    <a:lstStyle/>
+                    <a:p>
+                      <a:pPr algn="l" indent="0" marL="0">
+                        <a:buNone/>
+                      </a:pPr>
+                      <a:r>
+                        <a:rPr lang="en-US" sz="1200" b="1" dirty="0">
+                          <a:solidFill>
+                            <a:srgbClr val="2D2A26"/>
+                          </a:solidFill>
+                          <a:latin typeface="Century Gothic" pitchFamily="34" charset="0"/>
+                          <a:ea typeface="Century Gothic" pitchFamily="34" charset="-122"/>
+                          <a:cs typeface="Century Gothic" pitchFamily="34" charset="-120"/>
+                        </a:rPr>
+                        <a:t>Kenya</a:t>
+                      </a:r>
+                      <a:endParaRPr lang="en-US" sz="1200" dirty="0">
+                        <a:latin typeface="Century Gothic" charset="0"/>
+                        <a:ea typeface="Century Gothic" charset="0"/>
+                        <a:cs typeface="Century Gothic" charset="0"/>
+                      </a:endParaRPr>
+                    </a:p>
+                  </a:txBody>
+                  <a:tcPr marL="91440" marR="91440" marT="45720" marB="45720" anchor="ctr">
+                    <a:lnL w="6350" cap="flat" cmpd="sng" algn="ctr">
+                      <a:solidFill>
+                        <a:srgbClr val="D6CFC4"/>
+                      </a:solidFill>
+                      <a:prstDash val="solid"/>
+                      <a:round/>
+                      <a:headEnd type="none" w="med" len="med"/>
+                      <a:tailEnd type="none" w="med" len="med"/>
+                    </a:lnL>
+                    <a:lnR w="6350" cap="flat" cmpd="sng" algn="ctr">
+                      <a:solidFill>
+                        <a:srgbClr val="D6CFC4"/>
+                      </a:solidFill>
+                      <a:prstDash val="solid"/>
+                      <a:round/>
+                      <a:headEnd type="none" w="med" len="med"/>
+                      <a:tailEnd type="none" w="med" len="med"/>
+                    </a:lnR>
+                    <a:lnT w="6350" cap="flat" cmpd="sng" algn="ctr">
+                      <a:solidFill>
+                        <a:srgbClr val="D6CFC4"/>
+                      </a:solidFill>
+                      <a:prstDash val="solid"/>
+                      <a:round/>
+                      <a:headEnd type="none" w="med" len="med"/>
+                      <a:tailEnd type="none" w="med" len="med"/>
+                    </a:lnT>
+                    <a:lnB w="6350" cap="flat" cmpd="sng" algn="ctr">
+                      <a:solidFill>
+                        <a:srgbClr val="D6CFC4"/>
+                      </a:solidFill>
+                      <a:prstDash val="solid"/>
+                      <a:round/>
+                      <a:headEnd type="none" w="med" len="med"/>
+                      <a:tailEnd type="none" w="med" len="med"/>
+                    </a:lnB>
+                    <a:solidFill>
                       <a:srgbClr val="FFF9D9"/>
                     </a:solidFill>
                   </a:tcPr>
@@ -22199,7 +22131,75 @@
                           <a:ea typeface="Calibri" pitchFamily="34" charset="-122"/>
                           <a:cs typeface="Calibri" pitchFamily="34" charset="-120"/>
                         </a:rPr>
-                        <a:t>1.7%</a:t>
+                        <a:t>9.3%</a:t>
+                      </a:r>
+                      <a:endParaRPr lang="en-US" sz="1200" dirty="0">
+                        <a:latin typeface="Calibri" charset="0"/>
+                        <a:ea typeface="Calibri" charset="0"/>
+                        <a:cs typeface="Calibri" charset="0"/>
+                      </a:endParaRPr>
+                    </a:p>
+                  </a:txBody>
+                  <a:tcPr marL="91440" marR="91440" marT="45720" marB="45720" anchor="ctr">
+                    <a:lnL w="6350" cap="flat" cmpd="sng" algn="ctr">
+                      <a:solidFill>
+                        <a:srgbClr val="D6CFC4"/>
+                      </a:solidFill>
+                      <a:prstDash val="solid"/>
+                      <a:round/>
+                      <a:headEnd type="none" w="med" len="med"/>
+                      <a:tailEnd type="none" w="med" len="med"/>
+                    </a:lnL>
+                    <a:lnR w="6350" cap="flat" cmpd="sng" algn="ctr">
+                      <a:solidFill>
+                        <a:srgbClr val="D6CFC4"/>
+                      </a:solidFill>
+                      <a:prstDash val="solid"/>
+                      <a:round/>
+                      <a:headEnd type="none" w="med" len="med"/>
+                      <a:tailEnd type="none" w="med" len="med"/>
+                    </a:lnR>
+                    <a:lnT w="6350" cap="flat" cmpd="sng" algn="ctr">
+                      <a:solidFill>
+                        <a:srgbClr val="D6CFC4"/>
+                      </a:solidFill>
+                      <a:prstDash val="solid"/>
+                      <a:round/>
+                      <a:headEnd type="none" w="med" len="med"/>
+                      <a:tailEnd type="none" w="med" len="med"/>
+                    </a:lnT>
+                    <a:lnB w="6350" cap="flat" cmpd="sng" algn="ctr">
+                      <a:solidFill>
+                        <a:srgbClr val="D6CFC4"/>
+                      </a:solidFill>
+                      <a:prstDash val="solid"/>
+                      <a:round/>
+                      <a:headEnd type="none" w="med" len="med"/>
+                      <a:tailEnd type="none" w="med" len="med"/>
+                    </a:lnB>
+                    <a:solidFill>
+                      <a:srgbClr val="FFF9D9"/>
+                    </a:solidFill>
+                  </a:tcPr>
+                </a:tc>
+                <a:tc>
+                  <a:txBody>
+                    <a:bodyPr/>
+                    <a:lstStyle/>
+                    <a:p>
+                      <a:pPr algn="ctr" indent="0" marL="0">
+                        <a:buNone/>
+                      </a:pPr>
+                      <a:r>
+                        <a:rPr lang="en-US" sz="1200" dirty="0">
+                          <a:solidFill>
+                            <a:srgbClr val="2D2A26"/>
+                          </a:solidFill>
+                          <a:latin typeface="Calibri" pitchFamily="34" charset="0"/>
+                          <a:ea typeface="Calibri" pitchFamily="34" charset="-122"/>
+                          <a:cs typeface="Calibri" pitchFamily="34" charset="-120"/>
+                        </a:rPr>
+                        <a:t>8.5%</a:t>
                       </a:r>
                       <a:endParaRPr lang="en-US" sz="1200" dirty="0">
                         <a:latin typeface="Calibri" charset="0"/>
@@ -22337,7 +22337,7 @@
                           <a:ea typeface="Century Gothic" pitchFamily="34" charset="-122"/>
                           <a:cs typeface="Century Gothic" pitchFamily="34" charset="-120"/>
                         </a:rPr>
-                        <a:t>Kenya</a:t>
+                        <a:t>Tanzania</a:t>
                       </a:r>
                       <a:endParaRPr lang="en-US" sz="1200" dirty="0">
                         <a:latin typeface="Century Gothic" charset="0"/>
@@ -22405,7 +22405,7 @@
                           <a:ea typeface="Calibri" pitchFamily="34" charset="-122"/>
                           <a:cs typeface="Calibri" pitchFamily="34" charset="-120"/>
                         </a:rPr>
-                        <a:t>9.3%</a:t>
+                        <a:t>12.3%</a:t>
                       </a:r>
                       <a:endParaRPr lang="en-US" sz="1200" dirty="0">
                         <a:latin typeface="Calibri" charset="0"/>
@@ -22473,7 +22473,7 @@
                           <a:ea typeface="Calibri" pitchFamily="34" charset="-122"/>
                           <a:cs typeface="Calibri" pitchFamily="34" charset="-120"/>
                         </a:rPr>
-                        <a:t>8.5%</a:t>
+                        <a:t>10.6%</a:t>
                       </a:r>
                       <a:endParaRPr lang="en-US" sz="1200" dirty="0">
                         <a:latin typeface="Calibri" charset="0"/>
@@ -23227,7 +23227,7 @@
                           <a:ea typeface="Calibri" pitchFamily="34" charset="-122"/>
                           <a:cs typeface="Calibri" pitchFamily="34" charset="-120"/>
                         </a:rPr>
-                        <a:t>9.5%</a:t>
+                        <a:t>10.7%</a:t>
                       </a:r>
                       <a:endParaRPr lang="en-US" sz="1200" dirty="0">
                         <a:latin typeface="Calibri" charset="0"/>
@@ -23295,7 +23295,7 @@
                           <a:ea typeface="Calibri" pitchFamily="34" charset="-122"/>
                           <a:cs typeface="Calibri" pitchFamily="34" charset="-120"/>
                         </a:rPr>
-                        <a:t>8.8%</a:t>
+                        <a:t>9.6%</a:t>
                       </a:r>
                       <a:endParaRPr lang="en-US" sz="1200" dirty="0">
                         <a:latin typeface="Calibri" charset="0"/>

</xml_diff>

<commit_message>
Auto-build: 2026-08-07 20:09 UTC
</commit_message>
<xml_diff>
--- a/reports/2026-07.pptx
+++ b/reports/2026-07.pptx
@@ -1141,16 +1141,16 @@
                     <c:v>Tanzania</c:v>
                   </c:pt>
                   <c:pt idx="1">
+                    <c:v>Kenya</c:v>
+                  </c:pt>
+                  <c:pt idx="2">
                     <c:v>Sierra Leone</c:v>
                   </c:pt>
-                  <c:pt idx="2">
+                  <c:pt idx="3">
                     <c:v>Uganda</c:v>
                   </c:pt>
-                  <c:pt idx="3">
+                  <c:pt idx="4">
                     <c:v>Nigeria</c:v>
-                  </c:pt>
-                  <c:pt idx="4">
-                    <c:v>Kenya</c:v>
                   </c:pt>
                 </c:lvl>
               </c:multiLvlStrCache>
@@ -1166,16 +1166,16 @@
                   <c:v>2191848.288</c:v>
                 </c:pt>
                 <c:pt idx="1">
+                  <c:v>1934748.975</c:v>
+                </c:pt>
+                <c:pt idx="2">
                   <c:v>647524.7959</c:v>
                 </c:pt>
-                <c:pt idx="2">
+                <c:pt idx="3">
                   <c:v>576396.6555</c:v>
                 </c:pt>
-                <c:pt idx="3">
+                <c:pt idx="4">
                   <c:v>157919.708</c:v>
-                </c:pt>
-                <c:pt idx="4">
-                  <c:v>0</c:v>
                 </c:pt>
               </c:numCache>
             </c:numRef>
@@ -1441,16 +1441,16 @@
                     <c:v>Tanzania</c:v>
                   </c:pt>
                   <c:pt idx="1">
+                    <c:v>Kenya</c:v>
+                  </c:pt>
+                  <c:pt idx="2">
                     <c:v>Sierra Leone</c:v>
                   </c:pt>
-                  <c:pt idx="2">
+                  <c:pt idx="3">
                     <c:v>Uganda</c:v>
                   </c:pt>
-                  <c:pt idx="3">
+                  <c:pt idx="4">
                     <c:v>Nigeria</c:v>
-                  </c:pt>
-                  <c:pt idx="4">
-                    <c:v>Kenya</c:v>
                   </c:pt>
                 </c:lvl>
               </c:multiLvlStrCache>
@@ -1466,16 +1466,16 @@
                   <c:v>225.290193</c:v>
                 </c:pt>
                 <c:pt idx="1">
+                  <c:v>277.343603</c:v>
+                </c:pt>
+                <c:pt idx="2">
                   <c:v>490.549088</c:v>
                 </c:pt>
-                <c:pt idx="2">
+                <c:pt idx="3">
                   <c:v>222.97743</c:v>
                 </c:pt>
-                <c:pt idx="3">
+                <c:pt idx="4">
                   <c:v>186.006723</c:v>
-                </c:pt>
-                <c:pt idx="4">
-                  <c:v>0</c:v>
                 </c:pt>
               </c:numCache>
             </c:numRef>
@@ -1741,16 +1741,16 @@
                     <c:v>Tanzania</c:v>
                   </c:pt>
                   <c:pt idx="1">
+                    <c:v>Kenya</c:v>
+                  </c:pt>
+                  <c:pt idx="2">
                     <c:v>Sierra Leone</c:v>
                   </c:pt>
-                  <c:pt idx="2">
+                  <c:pt idx="3">
                     <c:v>Uganda</c:v>
                   </c:pt>
-                  <c:pt idx="3">
+                  <c:pt idx="4">
                     <c:v>Nigeria</c:v>
-                  </c:pt>
-                  <c:pt idx="4">
-                    <c:v>Kenya</c:v>
                   </c:pt>
                 </c:lvl>
               </c:multiLvlStrCache>
@@ -1766,16 +1766,16 @@
                   <c:v>152</c:v>
                 </c:pt>
                 <c:pt idx="1">
+                  <c:v>87</c:v>
+                </c:pt>
+                <c:pt idx="2">
                   <c:v>26</c:v>
                 </c:pt>
-                <c:pt idx="2">
+                <c:pt idx="3">
                   <c:v>63</c:v>
                 </c:pt>
-                <c:pt idx="3">
+                <c:pt idx="4">
                   <c:v>42</c:v>
-                </c:pt>
-                <c:pt idx="4">
-                  <c:v>0</c:v>
                 </c:pt>
               </c:numCache>
             </c:numRef>
@@ -2041,16 +2041,16 @@
                     <c:v>Tanzania</c:v>
                   </c:pt>
                   <c:pt idx="1">
+                    <c:v>Kenya</c:v>
+                  </c:pt>
+                  <c:pt idx="2">
                     <c:v>Uganda</c:v>
                   </c:pt>
-                  <c:pt idx="2">
+                  <c:pt idx="3">
                     <c:v>Nigeria</c:v>
                   </c:pt>
-                  <c:pt idx="3">
+                  <c:pt idx="4">
                     <c:v>Sierra Leone</c:v>
-                  </c:pt>
-                  <c:pt idx="4">
-                    <c:v>Kenya</c:v>
                   </c:pt>
                 </c:lvl>
               </c:multiLvlStrCache>
@@ -2069,13 +2069,13 @@
                   <c:v>3</c:v>
                 </c:pt>
                 <c:pt idx="2">
+                  <c:v>3</c:v>
+                </c:pt>
+                <c:pt idx="3">
                   <c:v>4</c:v>
                 </c:pt>
-                <c:pt idx="3">
+                <c:pt idx="4">
                   <c:v>5</c:v>
-                </c:pt>
-                <c:pt idx="4">
-                  <c:v>0</c:v>
                 </c:pt>
               </c:numCache>
             </c:numRef>
@@ -10857,13 +10857,13 @@
             <a:r>
               <a:rPr lang="en-US" sz="1200" b="1" dirty="0">
                 <a:solidFill>
-                  <a:srgbClr val="718096"/>
+                  <a:srgbClr val="1A7A6E"/>
                 </a:solidFill>
                 <a:latin typeface="Calibri" pitchFamily="34" charset="0"/>
                 <a:ea typeface="Calibri" pitchFamily="34" charset="-122"/>
                 <a:cs typeface="Calibri" pitchFamily="34" charset="-120"/>
               </a:rPr>
-              <a:t>-100.0%</a:t>
+              <a:t>+8.8%</a:t>
             </a:r>
             <a:endParaRPr lang="en-US" sz="1200" dirty="0"/>
           </a:p>
@@ -11747,13 +11747,13 @@
             <a:r>
               <a:rPr lang="en-US" sz="1200" b="1" dirty="0">
                 <a:solidFill>
-                  <a:srgbClr val="718096"/>
+                  <a:srgbClr val="1A7A6E"/>
                 </a:solidFill>
                 <a:latin typeface="Calibri" pitchFamily="34" charset="0"/>
                 <a:ea typeface="Calibri" pitchFamily="34" charset="-122"/>
                 <a:cs typeface="Calibri" pitchFamily="34" charset="-120"/>
               </a:rPr>
-              <a:t>-100.0%</a:t>
+              <a:t>+8.8%</a:t>
             </a:r>
             <a:endParaRPr lang="en-US" sz="1200" dirty="0"/>
           </a:p>
@@ -14593,6 +14593,45 @@
                 <a:ea typeface="Calibri" pitchFamily="34" charset="-122"/>
                 <a:cs typeface="Calibri" pitchFamily="34" charset="-120"/>
               </a:rPr>
+              <a:t>+9.4%</a:t>
+            </a:r>
+            <a:endParaRPr lang="en-US" sz="1200" dirty="0"/>
+          </a:p>
+        </p:txBody>
+      </p:sp>
+      <p:sp>
+        <p:nvSpPr>
+          <p:cNvPr id="17" name="Text 14"/>
+          <p:cNvSpPr/>
+          <p:nvPr/>
+        </p:nvSpPr>
+        <p:spPr>
+          <a:xfrm>
+            <a:off x="3172968" y="5925312"/>
+            <a:ext cx="1517904" cy="347472"/>
+          </a:xfrm>
+          <a:prstGeom prst="rect">
+            <a:avLst/>
+          </a:prstGeom>
+          <a:noFill/>
+          <a:ln/>
+        </p:spPr>
+        <p:txBody>
+          <a:bodyPr wrap="square" rtlCol="0" anchor="ctr"/>
+          <a:lstStyle/>
+          <a:p>
+            <a:pPr algn="ctr" indent="0" marL="0">
+              <a:buNone/>
+            </a:pPr>
+            <a:r>
+              <a:rPr lang="en-US" sz="1200" b="1" dirty="0">
+                <a:solidFill>
+                  <a:srgbClr val="1A7A6E"/>
+                </a:solidFill>
+                <a:latin typeface="Calibri" pitchFamily="34" charset="0"/>
+                <a:ea typeface="Calibri" pitchFamily="34" charset="-122"/>
+                <a:cs typeface="Calibri" pitchFamily="34" charset="-120"/>
+              </a:rPr>
               <a:t>+0.6%</a:t>
             </a:r>
             <a:endParaRPr lang="en-US" sz="1200" dirty="0"/>
@@ -14601,13 +14640,13 @@
       </p:sp>
       <p:sp>
         <p:nvSpPr>
-          <p:cNvPr id="17" name="Text 14"/>
-          <p:cNvSpPr/>
-          <p:nvPr/>
-        </p:nvSpPr>
-        <p:spPr>
-          <a:xfrm>
-            <a:off x="3172968" y="5925312"/>
+          <p:cNvPr id="18" name="Text 15"/>
+          <p:cNvSpPr/>
+          <p:nvPr/>
+        </p:nvSpPr>
+        <p:spPr>
+          <a:xfrm>
+            <a:off x="4690872" y="5925312"/>
             <a:ext cx="1517904" cy="347472"/>
           </a:xfrm>
           <a:prstGeom prst="rect">
@@ -14640,13 +14679,13 @@
       </p:sp>
       <p:sp>
         <p:nvSpPr>
-          <p:cNvPr id="18" name="Text 15"/>
-          <p:cNvSpPr/>
-          <p:nvPr/>
-        </p:nvSpPr>
-        <p:spPr>
-          <a:xfrm>
-            <a:off x="4690872" y="5925312"/>
+          <p:cNvPr id="19" name="Text 16"/>
+          <p:cNvSpPr/>
+          <p:nvPr/>
+        </p:nvSpPr>
+        <p:spPr>
+          <a:xfrm>
+            <a:off x="6208776" y="5925312"/>
             <a:ext cx="1517904" cy="347472"/>
           </a:xfrm>
           <a:prstGeom prst="rect">
@@ -14672,45 +14711,6 @@
                 <a:cs typeface="Calibri" pitchFamily="34" charset="-120"/>
               </a:rPr>
               <a:t>-4.8%</a:t>
-            </a:r>
-            <a:endParaRPr lang="en-US" sz="1200" dirty="0"/>
-          </a:p>
-        </p:txBody>
-      </p:sp>
-      <p:sp>
-        <p:nvSpPr>
-          <p:cNvPr id="19" name="Text 16"/>
-          <p:cNvSpPr/>
-          <p:nvPr/>
-        </p:nvSpPr>
-        <p:spPr>
-          <a:xfrm>
-            <a:off x="6208776" y="5925312"/>
-            <a:ext cx="1517904" cy="347472"/>
-          </a:xfrm>
-          <a:prstGeom prst="rect">
-            <a:avLst/>
-          </a:prstGeom>
-          <a:noFill/>
-          <a:ln/>
-        </p:spPr>
-        <p:txBody>
-          <a:bodyPr wrap="square" rtlCol="0" anchor="ctr"/>
-          <a:lstStyle/>
-          <a:p>
-            <a:pPr algn="ctr" indent="0" marL="0">
-              <a:buNone/>
-            </a:pPr>
-            <a:r>
-              <a:rPr lang="en-US" sz="1200" b="1" dirty="0">
-                <a:solidFill>
-                  <a:srgbClr val="718096"/>
-                </a:solidFill>
-                <a:latin typeface="Calibri" pitchFamily="34" charset="0"/>
-                <a:ea typeface="Calibri" pitchFamily="34" charset="-122"/>
-                <a:cs typeface="Calibri" pitchFamily="34" charset="-120"/>
-              </a:rPr>
-              <a:t>-100.0%</a:t>
             </a:r>
             <a:endParaRPr lang="en-US" sz="1200" dirty="0"/>
           </a:p>
@@ -14806,7 +14806,7 @@
                 <a:ea typeface="Century Gothic" pitchFamily="34" charset="-122"/>
                 <a:cs typeface="Century Gothic" pitchFamily="34" charset="-120"/>
               </a:rPr>
-              <a:t>$3,573,689</a:t>
+              <a:t>$5,508,438</a:t>
             </a:r>
             <a:endParaRPr lang="en-US" sz="2600" dirty="0"/>
           </a:p>
@@ -14941,7 +14941,7 @@
                 <a:ea typeface="Century Gothic" pitchFamily="34" charset="-122"/>
                 <a:cs typeface="Century Gothic" pitchFamily="34" charset="-120"/>
               </a:rPr>
-              <a:t>-37.1%</a:t>
+              <a:t>-3.1%</a:t>
             </a:r>
             <a:endParaRPr lang="en-US" sz="2600" dirty="0"/>
           </a:p>
@@ -15076,7 +15076,7 @@
                 <a:ea typeface="Century Gothic" pitchFamily="34" charset="-122"/>
                 <a:cs typeface="Century Gothic" pitchFamily="34" charset="-120"/>
               </a:rPr>
-              <a:t>42</a:t>
+              <a:t>62</a:t>
             </a:r>
             <a:endParaRPr lang="en-US" sz="2600" dirty="0"/>
           </a:p>
@@ -15371,6 +15371,109 @@
                 <a:ea typeface="Calibri" pitchFamily="34" charset="-122"/>
                 <a:cs typeface="Calibri" pitchFamily="34" charset="-120"/>
               </a:rPr>
+              <a:t>Kenya</a:t>
+            </a:r>
+            <a:endParaRPr lang="en-US" sz="1100" dirty="0"/>
+          </a:p>
+        </p:txBody>
+      </p:sp>
+      <p:sp>
+        <p:nvSpPr>
+          <p:cNvPr id="40" name="Text 37"/>
+          <p:cNvSpPr/>
+          <p:nvPr/>
+        </p:nvSpPr>
+        <p:spPr>
+          <a:xfrm>
+            <a:off x="9308592" y="4261104"/>
+            <a:ext cx="1234440" cy="292608"/>
+          </a:xfrm>
+          <a:prstGeom prst="rect">
+            <a:avLst/>
+          </a:prstGeom>
+          <a:noFill/>
+          <a:ln/>
+        </p:spPr>
+        <p:txBody>
+          <a:bodyPr wrap="square" rtlCol="0" anchor="ctr"/>
+          <a:lstStyle/>
+          <a:p>
+            <a:pPr algn="ctr" indent="0" marL="0">
+              <a:buNone/>
+            </a:pPr>
+            <a:r>
+              <a:rPr lang="en-US" sz="1100" b="1" dirty="0">
+                <a:solidFill>
+                  <a:srgbClr val="5D300F"/>
+                </a:solidFill>
+                <a:latin typeface="Century Gothic" pitchFamily="34" charset="0"/>
+                <a:ea typeface="Century Gothic" pitchFamily="34" charset="-122"/>
+                <a:cs typeface="Century Gothic" pitchFamily="34" charset="-120"/>
+              </a:rPr>
+              <a:t>112</a:t>
+            </a:r>
+            <a:endParaRPr lang="en-US" sz="1100" dirty="0"/>
+          </a:p>
+        </p:txBody>
+      </p:sp>
+      <p:sp>
+        <p:nvSpPr>
+          <p:cNvPr id="41" name="Shape 38"/>
+          <p:cNvSpPr/>
+          <p:nvPr/>
+        </p:nvSpPr>
+        <p:spPr>
+          <a:xfrm>
+            <a:off x="10661904" y="4023360"/>
+            <a:ext cx="1234440" cy="530352"/>
+          </a:xfrm>
+          <a:prstGeom prst="rect">
+            <a:avLst/>
+          </a:prstGeom>
+          <a:solidFill>
+            <a:srgbClr val="FFF9D9"/>
+          </a:solidFill>
+          <a:ln w="12700">
+            <a:solidFill>
+              <a:srgbClr val="D6CFC4"/>
+            </a:solidFill>
+            <a:prstDash val="solid"/>
+          </a:ln>
+        </p:spPr>
+      </p:sp>
+      <p:sp>
+        <p:nvSpPr>
+          <p:cNvPr id="42" name="Text 39"/>
+          <p:cNvSpPr/>
+          <p:nvPr/>
+        </p:nvSpPr>
+        <p:spPr>
+          <a:xfrm>
+            <a:off x="10661904" y="4023360"/>
+            <a:ext cx="1234440" cy="237744"/>
+          </a:xfrm>
+          <a:prstGeom prst="rect">
+            <a:avLst/>
+          </a:prstGeom>
+          <a:noFill/>
+          <a:ln/>
+        </p:spPr>
+        <p:txBody>
+          <a:bodyPr wrap="square" rtlCol="0" anchor="b"/>
+          <a:lstStyle/>
+          <a:p>
+            <a:pPr algn="ctr" indent="0" marL="0">
+              <a:buNone/>
+            </a:pPr>
+            <a:r>
+              <a:rPr lang="en-US" sz="1100" dirty="0">
+                <a:solidFill>
+                  <a:srgbClr val="718096"/>
+                </a:solidFill>
+                <a:latin typeface="Calibri" pitchFamily="34" charset="0"/>
+                <a:ea typeface="Calibri" pitchFamily="34" charset="-122"/>
+                <a:cs typeface="Calibri" pitchFamily="34" charset="-120"/>
+              </a:rPr>
               <a:t>Sierra Leone</a:t>
             </a:r>
             <a:endParaRPr lang="en-US" sz="1100" dirty="0"/>
@@ -15379,13 +15482,13 @@
       </p:sp>
       <p:sp>
         <p:nvSpPr>
-          <p:cNvPr id="40" name="Text 37"/>
-          <p:cNvSpPr/>
-          <p:nvPr/>
-        </p:nvSpPr>
-        <p:spPr>
-          <a:xfrm>
-            <a:off x="9308592" y="4261104"/>
+          <p:cNvPr id="43" name="Text 40"/>
+          <p:cNvSpPr/>
+          <p:nvPr/>
+        </p:nvSpPr>
+        <p:spPr>
+          <a:xfrm>
+            <a:off x="10661904" y="4261104"/>
             <a:ext cx="1234440" cy="292608"/>
           </a:xfrm>
           <a:prstGeom prst="rect">
@@ -15418,13 +15521,13 @@
       </p:sp>
       <p:sp>
         <p:nvSpPr>
-          <p:cNvPr id="41" name="Shape 38"/>
-          <p:cNvSpPr/>
-          <p:nvPr/>
-        </p:nvSpPr>
-        <p:spPr>
-          <a:xfrm>
-            <a:off x="10661904" y="4023360"/>
+          <p:cNvPr id="44" name="Shape 41"/>
+          <p:cNvSpPr/>
+          <p:nvPr/>
+        </p:nvSpPr>
+        <p:spPr>
+          <a:xfrm>
+            <a:off x="7955280" y="4617720"/>
             <a:ext cx="1234440" cy="530352"/>
           </a:xfrm>
           <a:prstGeom prst="rect">
@@ -15443,13 +15546,13 @@
       </p:sp>
       <p:sp>
         <p:nvSpPr>
-          <p:cNvPr id="42" name="Text 39"/>
-          <p:cNvSpPr/>
-          <p:nvPr/>
-        </p:nvSpPr>
-        <p:spPr>
-          <a:xfrm>
-            <a:off x="10661904" y="4023360"/>
+          <p:cNvPr id="45" name="Text 42"/>
+          <p:cNvSpPr/>
+          <p:nvPr/>
+        </p:nvSpPr>
+        <p:spPr>
+          <a:xfrm>
+            <a:off x="7955280" y="4617720"/>
             <a:ext cx="1234440" cy="237744"/>
           </a:xfrm>
           <a:prstGeom prst="rect">
@@ -15482,13 +15585,13 @@
       </p:sp>
       <p:sp>
         <p:nvSpPr>
-          <p:cNvPr id="43" name="Text 40"/>
-          <p:cNvSpPr/>
-          <p:nvPr/>
-        </p:nvSpPr>
-        <p:spPr>
-          <a:xfrm>
-            <a:off x="10661904" y="4261104"/>
+          <p:cNvPr id="46" name="Text 43"/>
+          <p:cNvSpPr/>
+          <p:nvPr/>
+        </p:nvSpPr>
+        <p:spPr>
+          <a:xfrm>
+            <a:off x="7955280" y="4855464"/>
             <a:ext cx="1234440" cy="292608"/>
           </a:xfrm>
           <a:prstGeom prst="rect">
@@ -15521,13 +15624,13 @@
       </p:sp>
       <p:sp>
         <p:nvSpPr>
-          <p:cNvPr id="44" name="Shape 41"/>
-          <p:cNvSpPr/>
-          <p:nvPr/>
-        </p:nvSpPr>
-        <p:spPr>
-          <a:xfrm>
-            <a:off x="7955280" y="4617720"/>
+          <p:cNvPr id="47" name="Shape 44"/>
+          <p:cNvSpPr/>
+          <p:nvPr/>
+        </p:nvSpPr>
+        <p:spPr>
+          <a:xfrm>
+            <a:off x="9308592" y="4617720"/>
             <a:ext cx="1234440" cy="530352"/>
           </a:xfrm>
           <a:prstGeom prst="rect">
@@ -15546,13 +15649,13 @@
       </p:sp>
       <p:sp>
         <p:nvSpPr>
-          <p:cNvPr id="45" name="Text 42"/>
-          <p:cNvSpPr/>
-          <p:nvPr/>
-        </p:nvSpPr>
-        <p:spPr>
-          <a:xfrm>
-            <a:off x="7955280" y="4617720"/>
+          <p:cNvPr id="48" name="Text 45"/>
+          <p:cNvSpPr/>
+          <p:nvPr/>
+        </p:nvSpPr>
+        <p:spPr>
+          <a:xfrm>
+            <a:off x="9308592" y="4617720"/>
             <a:ext cx="1234440" cy="237744"/>
           </a:xfrm>
           <a:prstGeom prst="rect">
@@ -15585,13 +15688,13 @@
       </p:sp>
       <p:sp>
         <p:nvSpPr>
-          <p:cNvPr id="46" name="Text 43"/>
-          <p:cNvSpPr/>
-          <p:nvPr/>
-        </p:nvSpPr>
-        <p:spPr>
-          <a:xfrm>
-            <a:off x="7955280" y="4855464"/>
+          <p:cNvPr id="49" name="Text 46"/>
+          <p:cNvSpPr/>
+          <p:nvPr/>
+        </p:nvSpPr>
+        <p:spPr>
+          <a:xfrm>
+            <a:off x="9308592" y="4855464"/>
             <a:ext cx="1234440" cy="292608"/>
           </a:xfrm>
           <a:prstGeom prst="rect">
@@ -15624,109 +15727,6 @@
       </p:sp>
       <p:sp>
         <p:nvSpPr>
-          <p:cNvPr id="47" name="Shape 44"/>
-          <p:cNvSpPr/>
-          <p:nvPr/>
-        </p:nvSpPr>
-        <p:spPr>
-          <a:xfrm>
-            <a:off x="9308592" y="4617720"/>
-            <a:ext cx="1234440" cy="530352"/>
-          </a:xfrm>
-          <a:prstGeom prst="rect">
-            <a:avLst/>
-          </a:prstGeom>
-          <a:solidFill>
-            <a:srgbClr val="FFF9D9"/>
-          </a:solidFill>
-          <a:ln w="12700">
-            <a:solidFill>
-              <a:srgbClr val="D6CFC4"/>
-            </a:solidFill>
-            <a:prstDash val="solid"/>
-          </a:ln>
-        </p:spPr>
-      </p:sp>
-      <p:sp>
-        <p:nvSpPr>
-          <p:cNvPr id="48" name="Text 45"/>
-          <p:cNvSpPr/>
-          <p:nvPr/>
-        </p:nvSpPr>
-        <p:spPr>
-          <a:xfrm>
-            <a:off x="9308592" y="4617720"/>
-            <a:ext cx="1234440" cy="237744"/>
-          </a:xfrm>
-          <a:prstGeom prst="rect">
-            <a:avLst/>
-          </a:prstGeom>
-          <a:noFill/>
-          <a:ln/>
-        </p:spPr>
-        <p:txBody>
-          <a:bodyPr wrap="square" rtlCol="0" anchor="b"/>
-          <a:lstStyle/>
-          <a:p>
-            <a:pPr algn="ctr" indent="0" marL="0">
-              <a:buNone/>
-            </a:pPr>
-            <a:r>
-              <a:rPr lang="en-US" sz="1100" dirty="0">
-                <a:solidFill>
-                  <a:srgbClr val="718096"/>
-                </a:solidFill>
-                <a:latin typeface="Calibri" pitchFamily="34" charset="0"/>
-                <a:ea typeface="Calibri" pitchFamily="34" charset="-122"/>
-                <a:cs typeface="Calibri" pitchFamily="34" charset="-120"/>
-              </a:rPr>
-              <a:t>Kenya</a:t>
-            </a:r>
-            <a:endParaRPr lang="en-US" sz="1100" dirty="0"/>
-          </a:p>
-        </p:txBody>
-      </p:sp>
-      <p:sp>
-        <p:nvSpPr>
-          <p:cNvPr id="49" name="Text 46"/>
-          <p:cNvSpPr/>
-          <p:nvPr/>
-        </p:nvSpPr>
-        <p:spPr>
-          <a:xfrm>
-            <a:off x="9308592" y="4855464"/>
-            <a:ext cx="1234440" cy="292608"/>
-          </a:xfrm>
-          <a:prstGeom prst="rect">
-            <a:avLst/>
-          </a:prstGeom>
-          <a:noFill/>
-          <a:ln/>
-        </p:spPr>
-        <p:txBody>
-          <a:bodyPr wrap="square" rtlCol="0" anchor="ctr"/>
-          <a:lstStyle/>
-          <a:p>
-            <a:pPr algn="ctr" indent="0" marL="0">
-              <a:buNone/>
-            </a:pPr>
-            <a:r>
-              <a:rPr lang="en-US" sz="1100" b="1" dirty="0">
-                <a:solidFill>
-                  <a:srgbClr val="5D300F"/>
-                </a:solidFill>
-                <a:latin typeface="Century Gothic" pitchFamily="34" charset="0"/>
-                <a:ea typeface="Century Gothic" pitchFamily="34" charset="-122"/>
-                <a:cs typeface="Century Gothic" pitchFamily="34" charset="-120"/>
-              </a:rPr>
-              <a:t>112</a:t>
-            </a:r>
-            <a:endParaRPr lang="en-US" sz="1100" dirty="0"/>
-          </a:p>
-        </p:txBody>
-      </p:sp>
-      <p:sp>
-        <p:nvSpPr>
           <p:cNvPr id="50" name="Shape 47"/>
           <p:cNvSpPr/>
           <p:nvPr/>
@@ -15847,7 +15847,7 @@
                 <a:ea typeface="Calibri" pitchFamily="34" charset="-122"/>
                 <a:cs typeface="Calibri" pitchFamily="34" charset="-120"/>
               </a:rPr>
-              <a:t>Total disbursed: $3,573,689 (-37.1% vs prior month).</a:t>
+              <a:t>Total disbursed: $5,508,438 (-3.1% vs prior month).</a:t>
             </a:r>
             <a:endParaRPr lang="en-US" sz="1200" dirty="0"/>
           </a:p>
@@ -16452,6 +16452,45 @@
             <a:r>
               <a:rPr lang="en-US" sz="1200" b="1" dirty="0">
                 <a:solidFill>
+                  <a:srgbClr val="1A7A6E"/>
+                </a:solidFill>
+                <a:latin typeface="Calibri" pitchFamily="34" charset="0"/>
+                <a:ea typeface="Calibri" pitchFamily="34" charset="-122"/>
+                <a:cs typeface="Calibri" pitchFamily="34" charset="-120"/>
+              </a:rPr>
+              <a:t>+2.5%</a:t>
+            </a:r>
+            <a:endParaRPr lang="en-US" sz="1200" dirty="0"/>
+          </a:p>
+        </p:txBody>
+      </p:sp>
+      <p:sp>
+        <p:nvSpPr>
+          <p:cNvPr id="21" name="Text 17"/>
+          <p:cNvSpPr/>
+          <p:nvPr/>
+        </p:nvSpPr>
+        <p:spPr>
+          <a:xfrm>
+            <a:off x="2459736" y="5925312"/>
+            <a:ext cx="1161288" cy="347472"/>
+          </a:xfrm>
+          <a:prstGeom prst="rect">
+            <a:avLst/>
+          </a:prstGeom>
+          <a:noFill/>
+          <a:ln/>
+        </p:spPr>
+        <p:txBody>
+          <a:bodyPr wrap="square" rtlCol="0" anchor="ctr"/>
+          <a:lstStyle/>
+          <a:p>
+            <a:pPr algn="ctr" indent="0" marL="0">
+              <a:buNone/>
+            </a:pPr>
+            <a:r>
+              <a:rPr lang="en-US" sz="1200" b="1" dirty="0">
+                <a:solidFill>
                   <a:srgbClr val="C0392B"/>
                 </a:solidFill>
                 <a:latin typeface="Calibri" pitchFamily="34" charset="0"/>
@@ -16466,13 +16505,13 @@
       </p:sp>
       <p:sp>
         <p:nvSpPr>
-          <p:cNvPr id="21" name="Text 17"/>
-          <p:cNvSpPr/>
-          <p:nvPr/>
-        </p:nvSpPr>
-        <p:spPr>
-          <a:xfrm>
-            <a:off x="2459736" y="5925312"/>
+          <p:cNvPr id="22" name="Text 18"/>
+          <p:cNvSpPr/>
+          <p:nvPr/>
+        </p:nvSpPr>
+        <p:spPr>
+          <a:xfrm>
+            <a:off x="3621024" y="5925312"/>
             <a:ext cx="1161288" cy="347472"/>
           </a:xfrm>
           <a:prstGeom prst="rect">
@@ -16505,13 +16544,13 @@
       </p:sp>
       <p:sp>
         <p:nvSpPr>
-          <p:cNvPr id="22" name="Text 18"/>
-          <p:cNvSpPr/>
-          <p:nvPr/>
-        </p:nvSpPr>
-        <p:spPr>
-          <a:xfrm>
-            <a:off x="3621024" y="5925312"/>
+          <p:cNvPr id="23" name="Text 19"/>
+          <p:cNvSpPr/>
+          <p:nvPr/>
+        </p:nvSpPr>
+        <p:spPr>
+          <a:xfrm>
+            <a:off x="4782312" y="5925312"/>
             <a:ext cx="1161288" cy="347472"/>
           </a:xfrm>
           <a:prstGeom prst="rect">
@@ -16544,45 +16583,6 @@
       </p:sp>
       <p:sp>
         <p:nvSpPr>
-          <p:cNvPr id="23" name="Text 19"/>
-          <p:cNvSpPr/>
-          <p:nvPr/>
-        </p:nvSpPr>
-        <p:spPr>
-          <a:xfrm>
-            <a:off x="4782312" y="5925312"/>
-            <a:ext cx="1161288" cy="347472"/>
-          </a:xfrm>
-          <a:prstGeom prst="rect">
-            <a:avLst/>
-          </a:prstGeom>
-          <a:noFill/>
-          <a:ln/>
-        </p:spPr>
-        <p:txBody>
-          <a:bodyPr wrap="square" rtlCol="0" anchor="ctr"/>
-          <a:lstStyle/>
-          <a:p>
-            <a:pPr algn="ctr" indent="0" marL="0">
-              <a:buNone/>
-            </a:pPr>
-            <a:r>
-              <a:rPr lang="en-US" sz="1200" b="1" dirty="0">
-                <a:solidFill>
-                  <a:srgbClr val="718096"/>
-                </a:solidFill>
-                <a:latin typeface="Calibri" pitchFamily="34" charset="0"/>
-                <a:ea typeface="Calibri" pitchFamily="34" charset="-122"/>
-                <a:cs typeface="Calibri" pitchFamily="34" charset="-120"/>
-              </a:rPr>
-              <a:t>-100.0%</a:t>
-            </a:r>
-            <a:endParaRPr lang="en-US" sz="1200" dirty="0"/>
-          </a:p>
-        </p:txBody>
-      </p:sp>
-      <p:sp>
-        <p:nvSpPr>
           <p:cNvPr id="24" name="Shape 20"/>
           <p:cNvSpPr/>
           <p:nvPr/>
@@ -16742,6 +16742,45 @@
                 <a:ea typeface="Calibri" pitchFamily="34" charset="-122"/>
                 <a:cs typeface="Calibri" pitchFamily="34" charset="-120"/>
               </a:rPr>
+              <a:t>+8.8%</a:t>
+            </a:r>
+            <a:endParaRPr lang="en-US" sz="1200" dirty="0"/>
+          </a:p>
+        </p:txBody>
+      </p:sp>
+      <p:sp>
+        <p:nvSpPr>
+          <p:cNvPr id="29" name="Text 25"/>
+          <p:cNvSpPr/>
+          <p:nvPr/>
+        </p:nvSpPr>
+        <p:spPr>
+          <a:xfrm>
+            <a:off x="8494776" y="5925312"/>
+            <a:ext cx="1161288" cy="347472"/>
+          </a:xfrm>
+          <a:prstGeom prst="rect">
+            <a:avLst/>
+          </a:prstGeom>
+          <a:noFill/>
+          <a:ln/>
+        </p:spPr>
+        <p:txBody>
+          <a:bodyPr wrap="square" rtlCol="0" anchor="ctr"/>
+          <a:lstStyle/>
+          <a:p>
+            <a:pPr algn="ctr" indent="0" marL="0">
+              <a:buNone/>
+            </a:pPr>
+            <a:r>
+              <a:rPr lang="en-US" sz="1200" b="1" dirty="0">
+                <a:solidFill>
+                  <a:srgbClr val="1A7A6E"/>
+                </a:solidFill>
+                <a:latin typeface="Calibri" pitchFamily="34" charset="0"/>
+                <a:ea typeface="Calibri" pitchFamily="34" charset="-122"/>
+                <a:cs typeface="Calibri" pitchFamily="34" charset="-120"/>
+              </a:rPr>
               <a:t>+13.0%</a:t>
             </a:r>
             <a:endParaRPr lang="en-US" sz="1200" dirty="0"/>
@@ -16750,13 +16789,13 @@
       </p:sp>
       <p:sp>
         <p:nvSpPr>
-          <p:cNvPr id="29" name="Text 25"/>
-          <p:cNvSpPr/>
-          <p:nvPr/>
-        </p:nvSpPr>
-        <p:spPr>
-          <a:xfrm>
-            <a:off x="8494776" y="5925312"/>
+          <p:cNvPr id="30" name="Text 26"/>
+          <p:cNvSpPr/>
+          <p:nvPr/>
+        </p:nvSpPr>
+        <p:spPr>
+          <a:xfrm>
+            <a:off x="9656064" y="5925312"/>
             <a:ext cx="1161288" cy="347472"/>
           </a:xfrm>
           <a:prstGeom prst="rect">
@@ -16789,13 +16828,13 @@
       </p:sp>
       <p:sp>
         <p:nvSpPr>
-          <p:cNvPr id="30" name="Text 26"/>
-          <p:cNvSpPr/>
-          <p:nvPr/>
-        </p:nvSpPr>
-        <p:spPr>
-          <a:xfrm>
-            <a:off x="9656064" y="5925312"/>
+          <p:cNvPr id="31" name="Text 27"/>
+          <p:cNvSpPr/>
+          <p:nvPr/>
+        </p:nvSpPr>
+        <p:spPr>
+          <a:xfrm>
+            <a:off x="10817352" y="5925312"/>
             <a:ext cx="1161288" cy="347472"/>
           </a:xfrm>
           <a:prstGeom prst="rect">
@@ -16821,45 +16860,6 @@
                 <a:cs typeface="Calibri" pitchFamily="34" charset="-120"/>
               </a:rPr>
               <a:t>+5.0%</a:t>
-            </a:r>
-            <a:endParaRPr lang="en-US" sz="1200" dirty="0"/>
-          </a:p>
-        </p:txBody>
-      </p:sp>
-      <p:sp>
-        <p:nvSpPr>
-          <p:cNvPr id="31" name="Text 27"/>
-          <p:cNvSpPr/>
-          <p:nvPr/>
-        </p:nvSpPr>
-        <p:spPr>
-          <a:xfrm>
-            <a:off x="10817352" y="5925312"/>
-            <a:ext cx="1161288" cy="347472"/>
-          </a:xfrm>
-          <a:prstGeom prst="rect">
-            <a:avLst/>
-          </a:prstGeom>
-          <a:noFill/>
-          <a:ln/>
-        </p:spPr>
-        <p:txBody>
-          <a:bodyPr wrap="square" rtlCol="0" anchor="ctr"/>
-          <a:lstStyle/>
-          <a:p>
-            <a:pPr algn="ctr" indent="0" marL="0">
-              <a:buNone/>
-            </a:pPr>
-            <a:r>
-              <a:rPr lang="en-US" sz="1200" b="1" dirty="0">
-                <a:solidFill>
-                  <a:srgbClr val="718096"/>
-                </a:solidFill>
-                <a:latin typeface="Calibri" pitchFamily="34" charset="0"/>
-                <a:ea typeface="Calibri" pitchFamily="34" charset="-122"/>
-                <a:cs typeface="Calibri" pitchFamily="34" charset="-120"/>
-              </a:rPr>
-              <a:t>-100.0%</a:t>
             </a:r>
             <a:endParaRPr lang="en-US" sz="1200" dirty="0"/>
           </a:p>
@@ -17387,7 +17387,7 @@
                 <a:ea typeface="Calibri" pitchFamily="34" charset="-122"/>
                 <a:cs typeface="Calibri" pitchFamily="34" charset="-120"/>
               </a:rPr>
-              <a:t>↓</a:t>
+              <a:t>—</a:t>
             </a:r>
             <a:endParaRPr lang="en-US" sz="1200" dirty="0"/>
           </a:p>
@@ -17426,7 +17426,7 @@
                 <a:ea typeface="Calibri" pitchFamily="34" charset="-122"/>
                 <a:cs typeface="Calibri" pitchFamily="34" charset="-120"/>
               </a:rPr>
-              <a:t>—</a:t>
+              <a:t>↓</a:t>
             </a:r>
             <a:endParaRPr lang="en-US" sz="1200" dirty="0"/>
           </a:p>
@@ -17459,7 +17459,7 @@
             <a:r>
               <a:rPr lang="en-US" sz="1200" b="1" dirty="0">
                 <a:solidFill>
-                  <a:srgbClr val="718096"/>
+                  <a:srgbClr val="1A7A6E"/>
                 </a:solidFill>
                 <a:latin typeface="Calibri" pitchFamily="34" charset="0"/>
                 <a:ea typeface="Calibri" pitchFamily="34" charset="-122"/>
@@ -17561,7 +17561,7 @@
                 <a:ea typeface="Century Gothic" pitchFamily="34" charset="-122"/>
                 <a:cs typeface="Century Gothic" pitchFamily="34" charset="-120"/>
               </a:rPr>
-              <a:t>4 days</a:t>
+              <a:t>3 days</a:t>
             </a:r>
             <a:endParaRPr lang="en-US" sz="2600" dirty="0"/>
           </a:p>
@@ -17696,7 +17696,7 @@
                 <a:ea typeface="Century Gothic" pitchFamily="34" charset="-122"/>
                 <a:cs typeface="Century Gothic" pitchFamily="34" charset="-120"/>
               </a:rPr>
-              <a:t>↑</a:t>
+              <a:t>—</a:t>
             </a:r>
             <a:endParaRPr lang="en-US" sz="2600" dirty="0"/>
           </a:p>
@@ -17863,7 +17863,7 @@
                 <a:ea typeface="Calibri" pitchFamily="34" charset="-122"/>
                 <a:cs typeface="Calibri" pitchFamily="34" charset="-120"/>
               </a:rPr>
-              <a:t>Group avg turnaround: 4 days.</a:t>
+              <a:t>Group avg turnaround: 3 days.</a:t>
             </a:r>
             <a:endParaRPr lang="en-US" sz="1200" dirty="0"/>
           </a:p>

</xml_diff>